<commit_message>
Defence docs: authors, anti-AI text pass, screenshots; Gantt label and column width fixes
Co-Authored-By: Claude Sonnet 5.5 <noreply@anthropic.com>
</commit_message>
<xml_diff>
--- a/docs/Презентация_Планировщик_экзаменов.pptx
+++ b/docs/Презентация_Планировщик_экзаменов.pptx
@@ -513,7 +513,7 @@
           <a:p>
             <a:r>
               <a:rPr lang="en-US" dirty="0"/>
-              <a:t>Здравствуйте! Меня зовут [ФИО]. Мой проект номер 60 — планировщик подготовки к экзаменам. Это программа на Python, которая сама раскладывает темы по дням и пересчитывает план, если вы отстаёте.</a:t>
+              <a:t>Здравствуйте! Мы — Павел Дибривный и Георгий Салазде, группы ИСТ04 и ИСТ03. Наш проект номер 60: планировщик подготовки к экзаменам. Программа на Python сама раскладывает темы по дням, а если вы отстали, пересчитывает план.</a:t>
             </a:r>
             <a:endParaRPr lang="en-US" dirty="0"/>
           </a:p>
@@ -601,7 +601,7 @@
           <a:p>
             <a:r>
               <a:rPr lang="en-US" dirty="0"/>
-              <a:t>Проверка ввода. Пустое название, неверная дата, дата в прошлом, повтор — для каждого случая программа показывает понятное сообщение и не падает. Для названия «Введение в анализ» по математике сложность подбирается автоматически и получается два. Справа — скриншоты: окно добавления нескольких тем и сообщение об ошибке.</a:t>
+              <a:t>Здесь примеры ввода и вывода. Пустое название, неверная дата, дата в прошлом, повтор: на каждый случай программа пишет понятное сообщение и продолжает работать. Для темы «Введение в анализ» по математике сложность подобралась сама и равна двум. Справа окно добавления нескольких тем и сообщение об ошибке.</a:t>
             </a:r>
             <a:endParaRPr lang="en-US" dirty="0"/>
           </a:p>
@@ -689,7 +689,7 @@
           <a:p>
             <a:r>
               <a:rPr lang="en-US" dirty="0"/>
-              <a:t>Логика проверена семьюдесятью автоматическими тестами на pytest, все проходят. Тесты проверяют неверный ввод, лимиты часов, день повторения, распределение по дням, перепланирование, автоподбор сложности и работу с повреждёнными файлами. Окно проверялось вручную и скриптами с подменой диалогов.</a:t>
+              <a:t>Логику проверяют 70 автотестов, все проходят. Они смотрят на неверный ввод, лимиты часов, день повторения, распределение по дням, перепланирование, автоподбор сложности и битые файлы. Окно мы проверяли руками.</a:t>
             </a:r>
             <a:endParaRPr lang="en-US" dirty="0"/>
           </a:p>
@@ -777,7 +777,7 @@
           <a:p>
             <a:r>
               <a:rPr lang="en-US" dirty="0"/>
-              <a:t>Итог: получилась рабочая программа с окном, календарём и диаграммой Ганта, данные сохраняются в файлы, логика покрыта тестами. В дальнейшем можно добавить редактирование записей, уведомления и экспорт в календарь. Спасибо за внимание, готов ответить на вопросы.</a:t>
+              <a:t>Итог: программа работает, с окном, календарём и диаграммой Ганта, данные сохраняются, логика покрыта тестами. Дальше можно добавить редактирование записей, напоминания и экспорт в календарь. Спасибо за внимание, будем рады вопросам.</a:t>
             </a:r>
             <a:endParaRPr lang="en-US" dirty="0"/>
           </a:p>
@@ -865,7 +865,7 @@
           <a:p>
             <a:r>
               <a:rPr lang="en-US" dirty="0"/>
-              <a:t>Задача из задания: пользователь вводит экзамены, даты и темы с оценкой сложности, программа распределяет, что учить каждый день, и пересчитывает план, если человек отстаёт. Результат нужно показать наглядно — я сделал календарь нагрузки и диаграмму Ганта. Минимальные требования курса — обработка ошибок, словари и ООП — выполнены, визуализация добавлена как четвёртый критерий.</a:t>
+              <a:t>По заданию человек вводит экзамены, даты и темы со сложностью, а программа решает, что учить каждый день, и пересчитывает план, когда он отстаёт. Результат нужно показать на диаграмме Ганта или в календаре нагрузки. Мы сделали и то и другое. Обязательные требования курса, то есть ошибки, словари и ООП, выполнены, а визуализацию взяли четвёртым критерием.</a:t>
             </a:r>
             <a:endParaRPr lang="en-US" dirty="0"/>
           </a:p>
@@ -953,7 +953,7 @@
           <a:p>
             <a:r>
               <a:rPr lang="en-US" dirty="0"/>
-              <a:t>Проект написан только на стандартной библиотеке Python, ничего дополнительно устанавливать для запуска не нужно. Окно и формы сделаны на tkinter, диаграмма Ганта нарисована на его Canvas. Данные хранятся в CSV-файлах. Для проверки логики использован pytest, для истории изменений — git.</a:t>
+              <a:t>Мы использовали только стандартную библиотеку Python, поэтому для запуска ничего ставить не надо. Окно и формы сделаны на tkinter, диаграмма нарисована на его Canvas. Данные лежат в CSV-файлах. Логику проверяет pytest, историю изменений ведёт git.</a:t>
             </a:r>
             <a:endParaRPr lang="en-US" dirty="0"/>
           </a:p>
@@ -1041,7 +1041,7 @@
           <a:p>
             <a:r>
               <a:rPr lang="en-US" dirty="0"/>
-              <a:t>Проект разделён на три части. Папка planner — вся логика: классы экзамена и темы, планировщик, оценка сложности, чтение и запись файлов. Папка ui — окно tkinter. Данные лежат в трёх CSV-файлах. Логика ничего не знает про окно, поэтому её можно проверять тестами без запуска интерфейса.</a:t>
+              <a:t>Код поделён на две части. В папке planner вся логика: классы экзамена и темы, планировщик, оценка сложности, работа с файлами. В папке ui окно. Данные хранятся в трёх CSV. Логика про окно ничего не знает, и поэтому тесты проверяют её без интерфейса.</a:t>
             </a:r>
             <a:endParaRPr lang="en-US" dirty="0"/>
           </a:p>
@@ -1129,7 +1129,7 @@
           <a:p>
             <a:r>
               <a:rPr lang="en-US" dirty="0"/>
-              <a:t>Что умеет программа. Можно добавлять экзамены и контрольные работы с датами. Темы выбираются из выпадающих списков или вводятся вручную, можно добавить сразу несколько. Сложность подбирается автоматически по названию, её можно поправить. План учитывает лимит часов в день и не ставит большую тему на один день. Если отстал — кнопка «Перепланировать». Всё показывается в календаре и на диаграмме Ганта и сохраняется в файлы.</a:t>
+              <a:t>Что умеет программа. Добавлять экзамены и контрольные с датами. Выбирать темы из списков или вписывать свои, причём можно сразу несколько. Сложность подбирается по названию, её можно поправить. План учитывает лимит часов в день и не сваливает большую тему в один день. Если вы отстали, есть кнопка «Перепланировать». Всё видно в календаре и на диаграмме Ганта, и всё сохраняется в файлы.</a:t>
             </a:r>
             <a:endParaRPr lang="en-US" dirty="0"/>
           </a:p>
@@ -1217,7 +1217,7 @@
           <a:p>
             <a:r>
               <a:rPr lang="en-US" dirty="0"/>
-              <a:t>Правила распределения. Сложность от одного до пяти равна числу часов на тему. В день не больше четырёх часов и не больше двух часов одной темы, поэтому большая тема растягивается на несколько дней — на схеме тема на пять часов превращается в два, два и один час. Сначала идут самые сложные темы ближайшего экзамена. Накануне экзамена — только повторение, в сам день ничего не планируется.</a:t>
+              <a:t>Правила простые. Сложность от одного до пяти равна числу часов на тему. В день не больше четырёх часов, и не больше двух часов одной темы, так что тема на пять часов растянется на три дня: два, два и один. Первыми идут сложные темы ближайшего экзамена. Накануне экзамена только повторение, а в сам день ничего.</a:t>
             </a:r>
             <a:endParaRPr lang="en-US" dirty="0"/>
           </a:p>
@@ -1305,7 +1305,7 @@
           <a:p>
             <a:r>
               <a:rPr lang="en-US" dirty="0"/>
-              <a:t>Как выполнены обязательные требования. Обработка ошибок: все проверки ввода бросают свои исключения, а окно ловит их через try и except и показывает понятное сообщение, программа не падает. Словари: план — это словарь «дата — список занятий», а оценка сложности — словарь основ предметов и слов-поправок. ООП: классы Exam, Topic, Planner, Storage, окно и диаграмма тоже классы, а ошибки образуют иерархию.</a:t>
+              <a:t>Теперь про требования курса. Ошибки: проверки ввода выбрасывают свои исключения, окно ловит их в try/except и показывает понятное сообщение, поэтому программа не вылетает. Словари: план у нас словарь «дата → список занятий», и оценка сложности тоже на словарях. ООП: классы Exam, Topic, Planner и Storage, а окно и диаграмма тоже классы; свои ошибки наследуются от одного общего класса.</a:t>
             </a:r>
             <a:endParaRPr lang="en-US" dirty="0"/>
           </a:p>
@@ -1393,7 +1393,7 @@
           <a:p>
             <a:r>
               <a:rPr lang="en-US" dirty="0"/>
-              <a:t>Первый вид визуализации — календарь на месяц. Цвет клетки показывает, сколько часов запланировано: чем темнее, тем ближе к лимиту. Экзамены отмечены красным, контрольные — фиолетовым. По клику на день внизу видно, какие темы и сколько часов в этот день.</a:t>
+              <a:t>Первый вид визуализации, календарь. Цвет клетки показывает, сколько часов стоит на этот день: чем ближе к лимиту, тем темнее. Экзамены красные, контрольные фиолетовые. Если нажать на день, внизу появится список тем и часов.</a:t>
             </a:r>
             <a:endParaRPr lang="en-US" dirty="0"/>
           </a:p>
@@ -1481,7 +1481,7 @@
           <a:p>
             <a:r>
               <a:rPr lang="en-US" dirty="0"/>
-              <a:t>Второй вид визуализации — диаграмма Ганта. Каждая тема — полоска от первого до последнего дня занятий, полоски сгруппированы по экзаменам. Вертикальные линии — даты экзаменов и контрольных, пунктирная — сегодня. Выполненные темы и темы, которые не помещаются до срока, показаны отдельными строками.</a:t>
+              <a:t>Второй вид, диаграмма Ганта. Каждая тема это полоска от первого до последнего дня занятий, полоски сгруппированы по экзаменам. Вертикальные линии показывают даты экзаменов, пунктирная линия — сегодня. Выполненные темы и те, что не успеть, вынесены в отдельные строки.</a:t>
             </a:r>
             <a:endParaRPr lang="en-US" dirty="0"/>
           </a:p>
@@ -2176,7 +2176,7 @@
                 <a:ea typeface="Calibri" pitchFamily="34" charset="-122"/>
                 <a:cs typeface="Calibri" pitchFamily="34" charset="-120"/>
               </a:rPr>
-              <a:t>Автор: [ФИО], группа [номер]</a:t>
+              <a:t>Дибривный Павел (ИСТ04), Салазде Георгий (ИСТ03)</a:t>
             </a:r>
             <a:endParaRPr lang="en-US" sz="1800" dirty="0"/>
           </a:p>
@@ -3550,160 +3550,96 @@
         </p:nvSpPr>
         <p:spPr>
           <a:xfrm>
-            <a:off x="7589520" y="1371600"/>
-            <a:ext cx="4050792" cy="2560320"/>
+            <a:off x="7671195" y="1344168"/>
+            <a:ext cx="3887442" cy="2615184"/>
           </a:xfrm>
           <a:prstGeom prst="rect">
             <a:avLst/>
           </a:prstGeom>
           <a:solidFill>
-            <a:srgbClr val="E2E8F0"/>
+            <a:srgbClr val="FFFFFF"/>
           </a:solidFill>
-          <a:ln w="12700">
+          <a:ln w="9525">
             <a:solidFill>
-              <a:srgbClr val="94A3B8"/>
+              <a:srgbClr val="CBD5E1"/>
             </a:solidFill>
-            <a:prstDash val="dash"/>
+            <a:prstDash val="solid"/>
           </a:ln>
         </p:spPr>
       </p:sp>
-      <p:sp>
-        <p:nvSpPr>
-          <p:cNvPr id="6" name="Text 2"/>
-          <p:cNvSpPr txBox="1"/>
-          <p:nvPr/>
-        </p:nvSpPr>
-        <p:spPr>
-          <a:xfrm>
-            <a:off x="7589520" y="1371600"/>
-            <a:ext cx="4050792" cy="2560320"/>
-          </a:xfrm>
-          <a:prstGeom prst="rect">
-            <a:avLst/>
-          </a:prstGeom>
-          <a:noFill/>
-          <a:ln/>
-        </p:spPr>
-        <p:txBody>
-          <a:bodyPr wrap="square" rtlCol="0" anchor="ctr"/>
-          <a:lstStyle/>
-          <a:p>
-            <a:pPr algn="ctr" indent="0" marL="0">
-              <a:buNone/>
-            </a:pPr>
-            <a:r>
-              <a:rPr lang="en-US" sz="1600" dirty="0">
-                <a:solidFill>
-                  <a:srgbClr val="64748B"/>
-                </a:solidFill>
-                <a:latin typeface="Calibri" pitchFamily="34" charset="0"/>
-                <a:ea typeface="Calibri" pitchFamily="34" charset="-122"/>
-                <a:cs typeface="Calibri" pitchFamily="34" charset="-120"/>
-              </a:rPr>
-              <a:t>Здесь будет скриншот</a:t>
-            </a:r>
-            <a:endParaRPr lang="en-US" sz="1600" dirty="0"/>
-          </a:p>
-          <a:p>
-            <a:pPr algn="ctr" indent="0" marL="0">
-              <a:buNone/>
-            </a:pPr>
-            <a:r>
-              <a:rPr lang="en-US" sz="1600" dirty="0">
-                <a:solidFill>
-                  <a:srgbClr val="64748B"/>
-                </a:solidFill>
-                <a:latin typeface="Calibri" pitchFamily="34" charset="0"/>
-                <a:ea typeface="Calibri" pitchFamily="34" charset="-122"/>
-                <a:cs typeface="Calibri" pitchFamily="34" charset="-120"/>
-              </a:rPr>
-              <a:t>03_dialog.png</a:t>
-            </a:r>
-            <a:endParaRPr lang="en-US" sz="1600" dirty="0"/>
-          </a:p>
-        </p:txBody>
-      </p:sp>
-      <p:sp>
-        <p:nvSpPr>
-          <p:cNvPr id="7" name="Shape 3"/>
+      <p:pic>
+        <p:nvPicPr>
+          <p:cNvPr id="6" name="Image 0" descr="Скриншот программы: 03_dialog.png">    </p:cNvPr>
+          <p:cNvPicPr>
+            <a:picLocks noChangeAspect="1"/>
+          </p:cNvPicPr>
+          <p:nvPr/>
+        </p:nvPicPr>
+        <p:blipFill>
+          <a:blip r:embed="rId1"/>
+          <a:stretch>
+            <a:fillRect/>
+          </a:stretch>
+        </p:blipFill>
+        <p:spPr>
+          <a:xfrm>
+            <a:off x="7698627" y="1371600"/>
+            <a:ext cx="3832578" cy="2560320"/>
+          </a:xfrm>
+          <a:prstGeom prst="rect">
+            <a:avLst/>
+          </a:prstGeom>
+        </p:spPr>
+      </p:pic>
+      <p:sp>
+        <p:nvSpPr>
+          <p:cNvPr id="7" name="Shape 2"/>
           <p:cNvSpPr/>
           <p:nvPr/>
         </p:nvSpPr>
         <p:spPr>
           <a:xfrm>
-            <a:off x="7589520" y="4114800"/>
-            <a:ext cx="4050792" cy="2011680"/>
+            <a:off x="7906080" y="4087368"/>
+            <a:ext cx="3417672" cy="2066544"/>
           </a:xfrm>
           <a:prstGeom prst="rect">
             <a:avLst/>
           </a:prstGeom>
           <a:solidFill>
-            <a:srgbClr val="E2E8F0"/>
+            <a:srgbClr val="FFFFFF"/>
           </a:solidFill>
-          <a:ln w="12700">
+          <a:ln w="9525">
             <a:solidFill>
-              <a:srgbClr val="94A3B8"/>
+              <a:srgbClr val="CBD5E1"/>
             </a:solidFill>
-            <a:prstDash val="dash"/>
+            <a:prstDash val="solid"/>
           </a:ln>
         </p:spPr>
       </p:sp>
-      <p:sp>
-        <p:nvSpPr>
-          <p:cNvPr id="8" name="Text 4"/>
-          <p:cNvSpPr txBox="1"/>
-          <p:nvPr/>
-        </p:nvSpPr>
-        <p:spPr>
-          <a:xfrm>
-            <a:off x="7589520" y="4114800"/>
-            <a:ext cx="4050792" cy="2011680"/>
-          </a:xfrm>
-          <a:prstGeom prst="rect">
-            <a:avLst/>
-          </a:prstGeom>
-          <a:noFill/>
-          <a:ln/>
-        </p:spPr>
-        <p:txBody>
-          <a:bodyPr wrap="square" rtlCol="0" anchor="ctr"/>
-          <a:lstStyle/>
-          <a:p>
-            <a:pPr algn="ctr" indent="0" marL="0">
-              <a:buNone/>
-            </a:pPr>
-            <a:r>
-              <a:rPr lang="en-US" sz="1600" dirty="0">
-                <a:solidFill>
-                  <a:srgbClr val="64748B"/>
-                </a:solidFill>
-                <a:latin typeface="Calibri" pitchFamily="34" charset="0"/>
-                <a:ea typeface="Calibri" pitchFamily="34" charset="-122"/>
-                <a:cs typeface="Calibri" pitchFamily="34" charset="-120"/>
-              </a:rPr>
-              <a:t>Здесь будет скриншот</a:t>
-            </a:r>
-            <a:endParaRPr lang="en-US" sz="1600" dirty="0"/>
-          </a:p>
-          <a:p>
-            <a:pPr algn="ctr" indent="0" marL="0">
-              <a:buNone/>
-            </a:pPr>
-            <a:r>
-              <a:rPr lang="en-US" sz="1600" dirty="0">
-                <a:solidFill>
-                  <a:srgbClr val="64748B"/>
-                </a:solidFill>
-                <a:latin typeface="Calibri" pitchFamily="34" charset="0"/>
-                <a:ea typeface="Calibri" pitchFamily="34" charset="-122"/>
-                <a:cs typeface="Calibri" pitchFamily="34" charset="-120"/>
-              </a:rPr>
-              <a:t>04_error.png</a:t>
-            </a:r>
-            <a:endParaRPr lang="en-US" sz="1600" dirty="0"/>
-          </a:p>
-        </p:txBody>
-      </p:sp>
+      <p:pic>
+        <p:nvPicPr>
+          <p:cNvPr id="8" name="Image 1" descr="Скриншот программы: 04_error.png">    </p:cNvPr>
+          <p:cNvPicPr>
+            <a:picLocks noChangeAspect="1"/>
+          </p:cNvPicPr>
+          <p:nvPr/>
+        </p:nvPicPr>
+        <p:blipFill>
+          <a:blip r:embed="rId2"/>
+          <a:stretch>
+            <a:fillRect/>
+          </a:stretch>
+        </p:blipFill>
+        <p:spPr>
+          <a:xfrm>
+            <a:off x="7933512" y="4114800"/>
+            <a:ext cx="3362808" cy="2011680"/>
+          </a:xfrm>
+          <a:prstGeom prst="rect">
+            <a:avLst/>
+          </a:prstGeom>
+        </p:spPr>
+      </p:pic>
       <p:sp>
         <p:nvSpPr>
           <p:cNvPr id="25" name="Slide Number Placeholder 0"/>
@@ -4242,7 +4178,7 @@
                 <a:ea typeface="Calibri" pitchFamily="34" charset="-122"/>
                 <a:cs typeface="Calibri" pitchFamily="34" charset="-120"/>
               </a:rPr>
-              <a:t>Готовая программа с окном, двумя видами визуализации и сохранением данных</a:t>
+              <a:t>Работает окно с календарём, диаграммой Ганта и сохранением данных</a:t>
             </a:r>
             <a:endParaRPr lang="en-US" sz="2200" dirty="0"/>
           </a:p>
@@ -4263,7 +4199,7 @@
                 <a:ea typeface="Calibri" pitchFamily="34" charset="-122"/>
                 <a:cs typeface="Calibri" pitchFamily="34" charset="-120"/>
               </a:rPr>
-              <a:t>Обязательные требования курса выполнены, добавлены визуализация, CSV и тесты</a:t>
+              <a:t>Ошибки, словари и ООП в деле, плюс визуализация, CSV и тесты</a:t>
             </a:r>
             <a:endParaRPr lang="en-US" sz="2200" dirty="0"/>
           </a:p>
@@ -4281,7 +4217,7 @@
                 <a:ea typeface="Calibri" pitchFamily="34" charset="-122"/>
                 <a:cs typeface="Calibri" pitchFamily="34" charset="-120"/>
               </a:rPr>
-              <a:t>Дальше можно: редактирование записей, уведомления, экспорт в календарь</a:t>
+              <a:t>Дальше: редактирование записей, напоминания, экспорт в календарь</a:t>
             </a:r>
             <a:endParaRPr lang="en-US" sz="2200" dirty="0"/>
           </a:p>
@@ -4423,7 +4359,7 @@
                 <a:ea typeface="Calibri" pitchFamily="34" charset="-122"/>
                 <a:cs typeface="Calibri" pitchFamily="34" charset="-120"/>
               </a:rPr>
-              <a:t>Студент вводит экзамены, даты и темы со сложностью. Программа сама решает, что учить каждый день, и пересчитывает план, если студент отстаёт.</a:t>
+              <a:t>Студент вводит экзамены, даты и темы со сложностью. Программа решает, что учить каждый день, и пересчитывает план, когда студент отстаёт.</a:t>
             </a:r>
             <a:endParaRPr lang="en-US" sz="2000" dirty="0"/>
           </a:p>
@@ -4951,7 +4887,7 @@
                 <a:ea typeface="Calibri" pitchFamily="34" charset="-122"/>
                 <a:cs typeface="Calibri" pitchFamily="34" charset="-120"/>
               </a:rPr>
-              <a:t>Если отстал — невыполненное переезжает вперёд, программа предупреждает о риске</a:t>
+              <a:t>Отстал: невыполненное переезжает вперёд, а о рисках программа предупреждает</a:t>
             </a:r>
             <a:endParaRPr lang="en-US" sz="1600" dirty="0"/>
           </a:p>
@@ -7056,7 +6992,7 @@
                 <a:ea typeface="Calibri" pitchFamily="34" charset="-122"/>
                 <a:cs typeface="Calibri" pitchFamily="34" charset="-120"/>
               </a:rPr>
-              <a:t>Логика не зависит от окна — её проверяют тесты без интерфейса</a:t>
+              <a:t>Логика не зависит от окна, поэтому тесты проверяют её без интерфейса</a:t>
             </a:r>
             <a:endParaRPr lang="en-US" sz="1800" dirty="0"/>
           </a:p>
@@ -8048,7 +7984,7 @@
                 <a:ea typeface="Calibri" pitchFamily="34" charset="-122"/>
                 <a:cs typeface="Calibri" pitchFamily="34" charset="-120"/>
               </a:rPr>
-              <a:t>отстал — темы переезжают вперёд, предупреждение о риске</a:t>
+              <a:t>отстал: темы переезжают вперёд, есть предупреждение о риске</a:t>
             </a:r>
             <a:endParaRPr lang="en-US" sz="1400" dirty="0"/>
           </a:p>
@@ -8400,7 +8336,7 @@
                 <a:ea typeface="Calibri" pitchFamily="34" charset="-122"/>
                 <a:cs typeface="Calibri" pitchFamily="34" charset="-120"/>
               </a:rPr>
-              <a:t>данные не пропадают, повреждённый файл не ломает программу</a:t>
+              <a:t>данные не пропадают, битый файл программу не ломает</a:t>
             </a:r>
             <a:endParaRPr lang="en-US" sz="1400" dirty="0"/>
           </a:p>
@@ -8636,7 +8572,7 @@
                 <a:ea typeface="Calibri" pitchFamily="34" charset="-122"/>
                 <a:cs typeface="Calibri" pitchFamily="34" charset="-120"/>
               </a:rPr>
-              <a:t>Не помещается — предупреждение, а не перегруз</a:t>
+              <a:t>Не помещается: предупреждение вместо перегруза</a:t>
             </a:r>
             <a:endParaRPr lang="en-US" sz="1800" dirty="0"/>
           </a:p>
@@ -10134,82 +10070,50 @@
         </p:nvSpPr>
         <p:spPr>
           <a:xfrm>
-            <a:off x="548640" y="1280160"/>
-            <a:ext cx="7589520" cy="4937760"/>
+            <a:off x="521208" y="1253904"/>
+            <a:ext cx="7644384" cy="4990271"/>
           </a:xfrm>
           <a:prstGeom prst="rect">
             <a:avLst/>
           </a:prstGeom>
           <a:solidFill>
-            <a:srgbClr val="E2E8F0"/>
+            <a:srgbClr val="FFFFFF"/>
           </a:solidFill>
-          <a:ln w="12700">
+          <a:ln w="9525">
             <a:solidFill>
-              <a:srgbClr val="94A3B8"/>
+              <a:srgbClr val="CBD5E1"/>
             </a:solidFill>
-            <a:prstDash val="dash"/>
+            <a:prstDash val="solid"/>
           </a:ln>
         </p:spPr>
       </p:sp>
-      <p:sp>
-        <p:nvSpPr>
-          <p:cNvPr id="5" name="Text 2"/>
-          <p:cNvSpPr txBox="1"/>
-          <p:nvPr/>
-        </p:nvSpPr>
-        <p:spPr>
-          <a:xfrm>
-            <a:off x="548640" y="1280160"/>
-            <a:ext cx="7589520" cy="4937760"/>
-          </a:xfrm>
-          <a:prstGeom prst="rect">
-            <a:avLst/>
-          </a:prstGeom>
-          <a:noFill/>
-          <a:ln/>
-        </p:spPr>
-        <p:txBody>
-          <a:bodyPr wrap="square" rtlCol="0" anchor="ctr"/>
-          <a:lstStyle/>
-          <a:p>
-            <a:pPr algn="ctr" indent="0" marL="0">
-              <a:buNone/>
-            </a:pPr>
-            <a:r>
-              <a:rPr lang="en-US" sz="1600" dirty="0">
-                <a:solidFill>
-                  <a:srgbClr val="64748B"/>
-                </a:solidFill>
-                <a:latin typeface="Calibri" pitchFamily="34" charset="0"/>
-                <a:ea typeface="Calibri" pitchFamily="34" charset="-122"/>
-                <a:cs typeface="Calibri" pitchFamily="34" charset="-120"/>
-              </a:rPr>
-              <a:t>Здесь будет скриншот</a:t>
-            </a:r>
-            <a:endParaRPr lang="en-US" sz="1600" dirty="0"/>
-          </a:p>
-          <a:p>
-            <a:pPr algn="ctr" indent="0" marL="0">
-              <a:buNone/>
-            </a:pPr>
-            <a:r>
-              <a:rPr lang="en-US" sz="1600" dirty="0">
-                <a:solidFill>
-                  <a:srgbClr val="64748B"/>
-                </a:solidFill>
-                <a:latin typeface="Calibri" pitchFamily="34" charset="0"/>
-                <a:ea typeface="Calibri" pitchFamily="34" charset="-122"/>
-                <a:cs typeface="Calibri" pitchFamily="34" charset="-120"/>
-              </a:rPr>
-              <a:t>01_calendar.png</a:t>
-            </a:r>
-            <a:endParaRPr lang="en-US" sz="1600" dirty="0"/>
-          </a:p>
-        </p:txBody>
-      </p:sp>
-      <p:sp>
-        <p:nvSpPr>
-          <p:cNvPr id="6" name="Shape 3"/>
+      <p:pic>
+        <p:nvPicPr>
+          <p:cNvPr id="5" name="Image 0" descr="Скриншот программы: 01_calendar.png">    </p:cNvPr>
+          <p:cNvPicPr>
+            <a:picLocks noChangeAspect="1"/>
+          </p:cNvPicPr>
+          <p:nvPr/>
+        </p:nvPicPr>
+        <p:blipFill>
+          <a:blip r:embed="rId1"/>
+          <a:stretch>
+            <a:fillRect/>
+          </a:stretch>
+        </p:blipFill>
+        <p:spPr>
+          <a:xfrm>
+            <a:off x="548640" y="1281336"/>
+            <a:ext cx="7589520" cy="4935407"/>
+          </a:xfrm>
+          <a:prstGeom prst="rect">
+            <a:avLst/>
+          </a:prstGeom>
+        </p:spPr>
+      </p:pic>
+      <p:sp>
+        <p:nvSpPr>
+          <p:cNvPr id="6" name="Shape 2"/>
           <p:cNvSpPr/>
           <p:nvPr/>
         </p:nvSpPr>
@@ -10243,7 +10147,7 @@
       </p:sp>
       <p:sp>
         <p:nvSpPr>
-          <p:cNvPr id="7" name="Text 4"/>
+          <p:cNvPr id="7" name="Text 3"/>
           <p:cNvSpPr txBox="1"/>
           <p:nvPr/>
         </p:nvSpPr>
@@ -10467,82 +10371,50 @@
         </p:nvSpPr>
         <p:spPr>
           <a:xfrm>
-            <a:off x="548640" y="1280160"/>
-            <a:ext cx="7589520" cy="4937760"/>
+            <a:off x="521208" y="1253904"/>
+            <a:ext cx="7644384" cy="4990271"/>
           </a:xfrm>
           <a:prstGeom prst="rect">
             <a:avLst/>
           </a:prstGeom>
           <a:solidFill>
-            <a:srgbClr val="E2E8F0"/>
+            <a:srgbClr val="FFFFFF"/>
           </a:solidFill>
-          <a:ln w="12700">
+          <a:ln w="9525">
             <a:solidFill>
-              <a:srgbClr val="94A3B8"/>
+              <a:srgbClr val="CBD5E1"/>
             </a:solidFill>
-            <a:prstDash val="dash"/>
+            <a:prstDash val="solid"/>
           </a:ln>
         </p:spPr>
       </p:sp>
-      <p:sp>
-        <p:nvSpPr>
-          <p:cNvPr id="5" name="Text 2"/>
-          <p:cNvSpPr txBox="1"/>
-          <p:nvPr/>
-        </p:nvSpPr>
-        <p:spPr>
-          <a:xfrm>
-            <a:off x="548640" y="1280160"/>
-            <a:ext cx="7589520" cy="4937760"/>
-          </a:xfrm>
-          <a:prstGeom prst="rect">
-            <a:avLst/>
-          </a:prstGeom>
-          <a:noFill/>
-          <a:ln/>
-        </p:spPr>
-        <p:txBody>
-          <a:bodyPr wrap="square" rtlCol="0" anchor="ctr"/>
-          <a:lstStyle/>
-          <a:p>
-            <a:pPr algn="ctr" indent="0" marL="0">
-              <a:buNone/>
-            </a:pPr>
-            <a:r>
-              <a:rPr lang="en-US" sz="1600" dirty="0">
-                <a:solidFill>
-                  <a:srgbClr val="64748B"/>
-                </a:solidFill>
-                <a:latin typeface="Calibri" pitchFamily="34" charset="0"/>
-                <a:ea typeface="Calibri" pitchFamily="34" charset="-122"/>
-                <a:cs typeface="Calibri" pitchFamily="34" charset="-120"/>
-              </a:rPr>
-              <a:t>Здесь будет скриншот</a:t>
-            </a:r>
-            <a:endParaRPr lang="en-US" sz="1600" dirty="0"/>
-          </a:p>
-          <a:p>
-            <a:pPr algn="ctr" indent="0" marL="0">
-              <a:buNone/>
-            </a:pPr>
-            <a:r>
-              <a:rPr lang="en-US" sz="1600" dirty="0">
-                <a:solidFill>
-                  <a:srgbClr val="64748B"/>
-                </a:solidFill>
-                <a:latin typeface="Calibri" pitchFamily="34" charset="0"/>
-                <a:ea typeface="Calibri" pitchFamily="34" charset="-122"/>
-                <a:cs typeface="Calibri" pitchFamily="34" charset="-120"/>
-              </a:rPr>
-              <a:t>02_gantt.png</a:t>
-            </a:r>
-            <a:endParaRPr lang="en-US" sz="1600" dirty="0"/>
-          </a:p>
-        </p:txBody>
-      </p:sp>
-      <p:sp>
-        <p:nvSpPr>
-          <p:cNvPr id="6" name="Shape 3"/>
+      <p:pic>
+        <p:nvPicPr>
+          <p:cNvPr id="5" name="Image 0" descr="Скриншот программы: 02_gantt.png">    </p:cNvPr>
+          <p:cNvPicPr>
+            <a:picLocks noChangeAspect="1"/>
+          </p:cNvPicPr>
+          <p:nvPr/>
+        </p:nvPicPr>
+        <p:blipFill>
+          <a:blip r:embed="rId1"/>
+          <a:stretch>
+            <a:fillRect/>
+          </a:stretch>
+        </p:blipFill>
+        <p:spPr>
+          <a:xfrm>
+            <a:off x="548640" y="1281336"/>
+            <a:ext cx="7589520" cy="4935407"/>
+          </a:xfrm>
+          <a:prstGeom prst="rect">
+            <a:avLst/>
+          </a:prstGeom>
+        </p:spPr>
+      </p:pic>
+      <p:sp>
+        <p:nvSpPr>
+          <p:cNvPr id="6" name="Shape 2"/>
           <p:cNvSpPr/>
           <p:nvPr/>
         </p:nvSpPr>
@@ -10576,7 +10448,7 @@
       </p:sp>
       <p:sp>
         <p:nvSpPr>
-          <p:cNvPr id="7" name="Text 4"/>
+          <p:cNvPr id="7" name="Text 3"/>
           <p:cNvSpPr txBox="1"/>
           <p:nvPr/>
         </p:nvSpPr>

</xml_diff>

<commit_message>
Add repository link to README, presentation and report
Co-Authored-By: Claude Sonnet 5.5 <noreply@anthropic.com>
</commit_message>
<xml_diff>
--- a/docs/Презентация_Планировщик_экзаменов.pptx
+++ b/docs/Презентация_Планировщик_экзаменов.pptx
@@ -866,7 +866,7 @@
           <a:p>
             <a:r>
               <a:rPr lang="en-US" dirty="0"/>
-              <a:t>Итог: программа работает, с окном, календарём и диаграммой Ганта, данные сохраняются, логика покрыта тестами. Дальше можно добавить редактирование записей, напоминания и экспорт в календарь. Спасибо за внимание, будем рады вопросам.</a:t>
+              <a:t>Итог: программа работает, с окном, календарём и диаграммой Ганта, данные сохраняются, логика покрыта тестами. Дальше можно добавить редактирование записей, напоминания и экспорт в календарь. Код проекта выложен на GitHub, ссылка на последнем слайде. Спасибо за внимание, будем рады вопросам.</a:t>
             </a:r>
             <a:endParaRPr lang="en-US" dirty="0"/>
           </a:p>
@@ -1042,7 +1042,7 @@
           <a:p>
             <a:r>
               <a:rPr lang="en-US" dirty="0"/>
-              <a:t>Окно и формы сделаны на tkinter, диаграмма нарисована на его Canvas. Данные лежат в CSV-файлах. Логику проверяет pytest, историю изменений ведёт git.</a:t>
+              <a:t>Окно и формы сделаны на tkinter, диаграмма нарисована на его Canvas. Данные лежат в CSV-файлах. Логику проверяет pytest, историю изменений ведёт git. Код лежит на GitHub.</a:t>
             </a:r>
             <a:endParaRPr lang="en-US" dirty="0"/>
           </a:p>
@@ -5196,6 +5196,45 @@
         </p:nvSpPr>
         <p:spPr>
           <a:xfrm>
+            <a:off x="731520" y="4480560"/>
+            <a:ext cx="10698480" cy="457200"/>
+          </a:xfrm>
+          <a:prstGeom prst="rect">
+            <a:avLst/>
+          </a:prstGeom>
+          <a:noFill/>
+          <a:ln/>
+        </p:spPr>
+        <p:txBody>
+          <a:bodyPr wrap="square" lIns="0" tIns="0" rIns="0" bIns="0" rtlCol="0" anchor="ctr"/>
+          <a:lstStyle/>
+          <a:p>
+            <a:pPr indent="0" marL="0">
+              <a:buNone/>
+            </a:pPr>
+            <a:r>
+              <a:rPr lang="en-US" sz="2000" dirty="0">
+                <a:solidFill>
+                  <a:srgbClr val="A5B4FC"/>
+                </a:solidFill>
+                <a:latin typeface="Calibri" pitchFamily="34" charset="0"/>
+                <a:ea typeface="Calibri" pitchFamily="34" charset="-122"/>
+                <a:cs typeface="Calibri" pitchFamily="34" charset="-120"/>
+              </a:rPr>
+              <a:t>Код: github.com/leywinkw/exam-planner</a:t>
+            </a:r>
+            <a:endParaRPr lang="en-US" sz="2000" dirty="0"/>
+          </a:p>
+        </p:txBody>
+      </p:sp>
+      <p:sp>
+        <p:nvSpPr>
+          <p:cNvPr id="5" name="Text 3"/>
+          <p:cNvSpPr txBox="1"/>
+          <p:nvPr/>
+        </p:nvSpPr>
+        <p:spPr>
+          <a:xfrm>
             <a:off x="731520" y="5120640"/>
             <a:ext cx="10698480" cy="822960"/>
           </a:xfrm>
@@ -7052,6 +7091,118 @@
                 <a:cs typeface="Calibri" pitchFamily="34" charset="-120"/>
               </a:rPr>
               <a:t>история версий проекта</a:t>
+            </a:r>
+            <a:endParaRPr lang="en-US" sz="1600" dirty="0"/>
+          </a:p>
+        </p:txBody>
+      </p:sp>
+      <p:sp>
+        <p:nvSpPr>
+          <p:cNvPr id="25" name="Shape 22"/>
+          <p:cNvSpPr/>
+          <p:nvPr/>
+        </p:nvSpPr>
+        <p:spPr>
+          <a:xfrm>
+            <a:off x="8970264" y="3794760"/>
+            <a:ext cx="2624328" cy="1965960"/>
+          </a:xfrm>
+          <a:prstGeom prst="roundRect">
+            <a:avLst>
+              <a:gd name="adj" fmla="val 5581"/>
+            </a:avLst>
+          </a:prstGeom>
+          <a:solidFill>
+            <a:srgbClr val="FFFFFF"/>
+          </a:solidFill>
+          <a:ln w="9525">
+            <a:solidFill>
+              <a:srgbClr val="DBE3EE"/>
+            </a:solidFill>
+            <a:prstDash val="solid"/>
+          </a:ln>
+          <a:effectLst>
+            <a:outerShdw sx="100000" sy="100000" kx="0" ky="0" algn="bl" rotWithShape="0" blurRad="76200" dist="25400" dir="5400000">
+              <a:srgbClr val="000000">
+                <a:alpha val="8000"/>
+              </a:srgbClr>
+            </a:outerShdw>
+          </a:effectLst>
+        </p:spPr>
+      </p:sp>
+      <p:sp>
+        <p:nvSpPr>
+          <p:cNvPr id="26" name="Text 23"/>
+          <p:cNvSpPr txBox="1"/>
+          <p:nvPr/>
+        </p:nvSpPr>
+        <p:spPr>
+          <a:xfrm>
+            <a:off x="9153144" y="4069080"/>
+            <a:ext cx="2258568" cy="822960"/>
+          </a:xfrm>
+          <a:prstGeom prst="rect">
+            <a:avLst/>
+          </a:prstGeom>
+          <a:noFill/>
+          <a:ln/>
+        </p:spPr>
+        <p:txBody>
+          <a:bodyPr wrap="square" lIns="0" tIns="0" rIns="0" bIns="0" rtlCol="0" anchor="t"/>
+          <a:lstStyle/>
+          <a:p>
+            <a:pPr indent="0" marL="0">
+              <a:buNone/>
+            </a:pPr>
+            <a:r>
+              <a:rPr lang="en-US" sz="2200" b="1" dirty="0">
+                <a:solidFill>
+                  <a:srgbClr val="1E1B4B"/>
+                </a:solidFill>
+                <a:latin typeface="Cambria" pitchFamily="34" charset="0"/>
+                <a:ea typeface="Cambria" pitchFamily="34" charset="-122"/>
+                <a:cs typeface="Cambria" pitchFamily="34" charset="-120"/>
+              </a:rPr>
+              <a:t>GitHub</a:t>
+            </a:r>
+            <a:endParaRPr lang="en-US" sz="2200" dirty="0"/>
+          </a:p>
+        </p:txBody>
+      </p:sp>
+      <p:sp>
+        <p:nvSpPr>
+          <p:cNvPr id="27" name="Text 24"/>
+          <p:cNvSpPr txBox="1"/>
+          <p:nvPr/>
+        </p:nvSpPr>
+        <p:spPr>
+          <a:xfrm>
+            <a:off x="9153144" y="4983480"/>
+            <a:ext cx="2258568" cy="640080"/>
+          </a:xfrm>
+          <a:prstGeom prst="rect">
+            <a:avLst/>
+          </a:prstGeom>
+          <a:noFill/>
+          <a:ln/>
+        </p:spPr>
+        <p:txBody>
+          <a:bodyPr wrap="square" lIns="0" tIns="0" rIns="0" bIns="0" rtlCol="0" anchor="t"/>
+          <a:lstStyle/>
+          <a:p>
+            <a:pPr indent="0" marL="0">
+              <a:buNone/>
+            </a:pPr>
+            <a:r>
+              <a:rPr lang="en-US" sz="1600" dirty="0">
+                <a:solidFill>
+                  <a:srgbClr val="64748B"/>
+                </a:solidFill>
+                <a:latin typeface="Calibri" pitchFamily="34" charset="0"/>
+                <a:ea typeface="Calibri" pitchFamily="34" charset="-122"/>
+                <a:cs typeface="Calibri" pitchFamily="34" charset="-120"/>
+              </a:rPr>
+              <a:t>код проекта: github.com/leywinkw/exam-planner</a:t>
             </a:r>
             <a:endParaRPr lang="en-US" sz="1600" dirty="0"/>
           </a:p>

</xml_diff>

<commit_message>
Russian comments in code, code screenshots and six code slides
Co-Authored-By: Claude Sonnet 5.5 <noreply@anthropic.com>
</commit_message>
<xml_diff>
--- a/docs/Презентация_Планировщик_экзаменов.pptx
+++ b/docs/Презентация_Планировщик_экзаменов.pptx
@@ -18,9 +18,15 @@
     <p:sldId id="266" r:id="rId12"/>
     <p:sldId id="267" r:id="rId13"/>
     <p:sldId id="268" r:id="rId14"/>
+    <p:sldId id="269" r:id="rId15"/>
+    <p:sldId id="270" r:id="rId16"/>
+    <p:sldId id="271" r:id="rId17"/>
+    <p:sldId id="272" r:id="rId18"/>
+    <p:sldId id="273" r:id="rId19"/>
+    <p:sldId id="274" r:id="rId20"/>
   </p:sldIdLst>
   <p:notesMasterIdLst>
-    <p:notesMasterId r:id="rId15"/>
+    <p:notesMasterId r:id="rId21"/>
   </p:notesMasterIdLst>
   <p:sldSz cx="12192000" cy="6858000"/>
   <p:notesSz cx="6858000" cy="12192000"/>
@@ -602,7 +608,7 @@
           <a:p>
             <a:r>
               <a:rPr lang="en-US" dirty="0"/>
-              <a:t>Теперь короткий сценарий. Сначала окно пустое, в полях подсказки. Темы можно добавлять пачкой через отдельное окно. А если часов в день мало, например два, календарь заполняется почти целиком, на диаграмме Ганта появляются красные строки «не помещается до экзамена», и внизу программа предупреждает о темах под угрозой.</a:t>
+              <a:t>Теперь словари. Для автоподбора сложности у нас два словаря: в первом основа названия предмета и базовая сложность, во втором основы слов темы и поправки. Функция ищет предмет в первом словаре и прибавляет поправки из второго.</a:t>
             </a:r>
             <a:endParaRPr lang="en-US" dirty="0"/>
           </a:p>
@@ -690,7 +696,7 @@
           <a:p>
             <a:r>
               <a:rPr lang="en-US" dirty="0"/>
-              <a:t>Здесь примеры ввода и вывода. Пустое название, неверная дата, дата в прошлом, повтор: на каждый случай программа пишет понятное сообщение и продолжает работать. Для темы «Введение в анализ» по математике сложность подобралась сама и равна двум. Справа окно добавления нескольких тем и сообщение об ошибке.</a:t>
+              <a:t>Сам план тоже словарь: ключ — дата, значение — список занятий. Рядом второй словарь load считает, сколько часов уже занято в каждый день, и благодаря ему мы не превышаем лимит.</a:t>
             </a:r>
             <a:endParaRPr lang="en-US" dirty="0"/>
           </a:p>
@@ -778,7 +784,7 @@
           <a:p>
             <a:r>
               <a:rPr lang="en-US" dirty="0"/>
-              <a:t>Логику проверяют 70 автотестов, все проходят. Они смотрят на неверный ввод, лимиты часов, день повторения, распределение по дням, перепланирование, автоподбор сложности и битые файлы. Окно мы проверяли руками.</a:t>
+              <a:t>Теперь ООП. Класс Exam описывает экзамен или контрольную, класс Topic — тему. Данные проверяются прямо при создании объекта, поэтому некорректный экзамен или тему создать нельзя.</a:t>
             </a:r>
             <a:endParaRPr lang="en-US" dirty="0"/>
           </a:p>
@@ -866,7 +872,7 @@
           <a:p>
             <a:r>
               <a:rPr lang="en-US" dirty="0"/>
-              <a:t>Итог: программа работает, с окном, календарём и диаграммой Ганта, данные сохраняются, логика покрыта тестами. Дальше можно добавить редактирование записей, напоминания и экспорт в календарь. Код проекта выложен на GitHub, ссылка на последнем слайде. Спасибо за внимание, будем рады вопросам.</a:t>
+              <a:t>Класс Planner собирает всё вместе: хранит словари экзаменов, тем и плана, а методы add_exam, add_topic, build_plan и replan работают с ними. Окно только вызывает эти методы.</a:t>
             </a:r>
             <a:endParaRPr lang="en-US" dirty="0"/>
           </a:p>
@@ -890,6 +896,534 @@
             <a:fld id="{F7021451-1387-4CA6-816F-3879F97B5CBC}" type="slidenum">
               <a:rPr lang="en-US"/>
               <a:t>13</a:t>
+            </a:fld>
+            <a:endParaRPr lang="en-US"/>
+          </a:p>
+        </p:txBody>
+      </p:sp>
+    </p:spTree>
+    <p:extLst>
+      <p:ext uri="{BB962C8B-B14F-4D97-AF65-F5344CB8AC3E}">
+        <p14:creationId xmlns:p14="http://schemas.microsoft.com/office/powerpoint/2010/main" val="1024086991"/>
+      </p:ext>
+    </p:extLst>
+  </p:cSld>
+  <p:clrMapOvr>
+    <a:masterClrMapping/>
+  </p:clrMapOvr>
+</p:notes>
+</file>
+
+<file path=ppt/notesSlides/notesSlide14.xml><?xml version="1.0" encoding="utf-8"?>
+<p:notes xmlns:a="http://schemas.openxmlformats.org/drawingml/2006/main" xmlns:r="http://schemas.openxmlformats.org/officeDocument/2006/relationships" xmlns:p="http://schemas.openxmlformats.org/presentationml/2006/main">
+  <p:cSld>
+    <p:spTree>
+      <p:nvGrpSpPr>
+        <p:cNvPr id="1" name=""/>
+        <p:cNvGrpSpPr/>
+        <p:nvPr/>
+      </p:nvGrpSpPr>
+      <p:grpSpPr>
+        <a:xfrm>
+          <a:off x="0" y="0"/>
+          <a:ext cx="0" cy="0"/>
+          <a:chOff x="0" y="0"/>
+          <a:chExt cx="0" cy="0"/>
+        </a:xfrm>
+      </p:grpSpPr>
+      <p:sp>
+        <p:nvSpPr>
+          <p:cNvPr id="2" name="Slide Image Placeholder 1"/>
+          <p:cNvSpPr>
+            <a:spLocks noGrp="1" noRot="1" noChangeAspect="1"/>
+          </p:cNvSpPr>
+          <p:nvPr>
+            <p:ph type="sldImg"/>
+          </p:nvPr>
+        </p:nvSpPr>
+        <p:spPr/>
+      </p:sp>
+      <p:sp>
+        <p:nvSpPr>
+          <p:cNvPr id="3" name="Notes Placeholder 2"/>
+          <p:cNvSpPr>
+            <a:spLocks noGrp="1"/>
+          </p:cNvSpPr>
+          <p:nvPr>
+            <p:ph type="body" idx="1"/>
+          </p:nvPr>
+        </p:nvSpPr>
+        <p:spPr/>
+        <p:txBody>
+          <a:bodyPr/>
+          <a:lstStyle/>
+          <a:p>
+            <a:r>
+              <a:rPr lang="en-US" dirty="0"/>
+              <a:t>Первый вид визуализации, календарь. Цвет клетки показывает, сколько часов стоит на этот день: чем ближе к лимиту, тем темнее. Экзамены красные, контрольные фиолетовые. Если нажать на день, внизу появится список тем и часов.</a:t>
+            </a:r>
+            <a:endParaRPr lang="en-US" dirty="0"/>
+          </a:p>
+        </p:txBody>
+      </p:sp>
+      <p:sp>
+        <p:nvSpPr>
+          <p:cNvPr id="4" name="Slide Number Placeholder 3"/>
+          <p:cNvSpPr>
+            <a:spLocks noGrp="1"/>
+          </p:cNvSpPr>
+          <p:nvPr>
+            <p:ph type="sldNum" sz="quarter" idx="10"/>
+          </p:nvPr>
+        </p:nvSpPr>
+        <p:spPr/>
+        <p:txBody>
+          <a:bodyPr/>
+          <a:lstStyle/>
+          <a:p>
+            <a:fld id="{F7021451-1387-4CA6-816F-3879F97B5CBC}" type="slidenum">
+              <a:rPr lang="en-US"/>
+              <a:t>14</a:t>
+            </a:fld>
+            <a:endParaRPr lang="en-US"/>
+          </a:p>
+        </p:txBody>
+      </p:sp>
+    </p:spTree>
+    <p:extLst>
+      <p:ext uri="{BB962C8B-B14F-4D97-AF65-F5344CB8AC3E}">
+        <p14:creationId xmlns:p14="http://schemas.microsoft.com/office/powerpoint/2010/main" val="1024086991"/>
+      </p:ext>
+    </p:extLst>
+  </p:cSld>
+  <p:clrMapOvr>
+    <a:masterClrMapping/>
+  </p:clrMapOvr>
+</p:notes>
+</file>
+
+<file path=ppt/notesSlides/notesSlide15.xml><?xml version="1.0" encoding="utf-8"?>
+<p:notes xmlns:a="http://schemas.openxmlformats.org/drawingml/2006/main" xmlns:r="http://schemas.openxmlformats.org/officeDocument/2006/relationships" xmlns:p="http://schemas.openxmlformats.org/presentationml/2006/main">
+  <p:cSld>
+    <p:spTree>
+      <p:nvGrpSpPr>
+        <p:cNvPr id="1" name=""/>
+        <p:cNvGrpSpPr/>
+        <p:nvPr/>
+      </p:nvGrpSpPr>
+      <p:grpSpPr>
+        <a:xfrm>
+          <a:off x="0" y="0"/>
+          <a:ext cx="0" cy="0"/>
+          <a:chOff x="0" y="0"/>
+          <a:chExt cx="0" cy="0"/>
+        </a:xfrm>
+      </p:grpSpPr>
+      <p:sp>
+        <p:nvSpPr>
+          <p:cNvPr id="2" name="Slide Image Placeholder 1"/>
+          <p:cNvSpPr>
+            <a:spLocks noGrp="1" noRot="1" noChangeAspect="1"/>
+          </p:cNvSpPr>
+          <p:nvPr>
+            <p:ph type="sldImg"/>
+          </p:nvPr>
+        </p:nvSpPr>
+        <p:spPr/>
+      </p:sp>
+      <p:sp>
+        <p:nvSpPr>
+          <p:cNvPr id="3" name="Notes Placeholder 2"/>
+          <p:cNvSpPr>
+            <a:spLocks noGrp="1"/>
+          </p:cNvSpPr>
+          <p:nvPr>
+            <p:ph type="body" idx="1"/>
+          </p:nvPr>
+        </p:nvSpPr>
+        <p:spPr/>
+        <p:txBody>
+          <a:bodyPr/>
+          <a:lstStyle/>
+          <a:p>
+            <a:r>
+              <a:rPr lang="en-US" dirty="0"/>
+              <a:t>Второй вид, диаграмма Ганта. Каждая тема это полоска от первого до последнего дня занятий, полоски сгруппированы по экзаменам. Вертикальные линии показывают даты экзаменов, пунктирная линия — сегодня. Выполненные темы и те, что не успеть, вынесены в отдельные строки.</a:t>
+            </a:r>
+            <a:endParaRPr lang="en-US" dirty="0"/>
+          </a:p>
+        </p:txBody>
+      </p:sp>
+      <p:sp>
+        <p:nvSpPr>
+          <p:cNvPr id="4" name="Slide Number Placeholder 3"/>
+          <p:cNvSpPr>
+            <a:spLocks noGrp="1"/>
+          </p:cNvSpPr>
+          <p:nvPr>
+            <p:ph type="sldNum" sz="quarter" idx="10"/>
+          </p:nvPr>
+        </p:nvSpPr>
+        <p:spPr/>
+        <p:txBody>
+          <a:bodyPr/>
+          <a:lstStyle/>
+          <a:p>
+            <a:fld id="{F7021451-1387-4CA6-816F-3879F97B5CBC}" type="slidenum">
+              <a:rPr lang="en-US"/>
+              <a:t>15</a:t>
+            </a:fld>
+            <a:endParaRPr lang="en-US"/>
+          </a:p>
+        </p:txBody>
+      </p:sp>
+    </p:spTree>
+    <p:extLst>
+      <p:ext uri="{BB962C8B-B14F-4D97-AF65-F5344CB8AC3E}">
+        <p14:creationId xmlns:p14="http://schemas.microsoft.com/office/powerpoint/2010/main" val="1024086991"/>
+      </p:ext>
+    </p:extLst>
+  </p:cSld>
+  <p:clrMapOvr>
+    <a:masterClrMapping/>
+  </p:clrMapOvr>
+</p:notes>
+</file>
+
+<file path=ppt/notesSlides/notesSlide16.xml><?xml version="1.0" encoding="utf-8"?>
+<p:notes xmlns:a="http://schemas.openxmlformats.org/drawingml/2006/main" xmlns:r="http://schemas.openxmlformats.org/officeDocument/2006/relationships" xmlns:p="http://schemas.openxmlformats.org/presentationml/2006/main">
+  <p:cSld>
+    <p:spTree>
+      <p:nvGrpSpPr>
+        <p:cNvPr id="1" name=""/>
+        <p:cNvGrpSpPr/>
+        <p:nvPr/>
+      </p:nvGrpSpPr>
+      <p:grpSpPr>
+        <a:xfrm>
+          <a:off x="0" y="0"/>
+          <a:ext cx="0" cy="0"/>
+          <a:chOff x="0" y="0"/>
+          <a:chExt cx="0" cy="0"/>
+        </a:xfrm>
+      </p:grpSpPr>
+      <p:sp>
+        <p:nvSpPr>
+          <p:cNvPr id="2" name="Slide Image Placeholder 1"/>
+          <p:cNvSpPr>
+            <a:spLocks noGrp="1" noRot="1" noChangeAspect="1"/>
+          </p:cNvSpPr>
+          <p:nvPr>
+            <p:ph type="sldImg"/>
+          </p:nvPr>
+        </p:nvSpPr>
+        <p:spPr/>
+      </p:sp>
+      <p:sp>
+        <p:nvSpPr>
+          <p:cNvPr id="3" name="Notes Placeholder 2"/>
+          <p:cNvSpPr>
+            <a:spLocks noGrp="1"/>
+          </p:cNvSpPr>
+          <p:nvPr>
+            <p:ph type="body" idx="1"/>
+          </p:nvPr>
+        </p:nvSpPr>
+        <p:spPr/>
+        <p:txBody>
+          <a:bodyPr/>
+          <a:lstStyle/>
+          <a:p>
+            <a:r>
+              <a:rPr lang="en-US" dirty="0"/>
+              <a:t>Теперь короткий сценарий. Сначала окно пустое, в полях подсказки. Темы можно добавлять пачкой через отдельное окно. А если часов в день мало, например два, календарь заполняется почти целиком, на диаграмме Ганта появляются красные строки «не помещается до экзамена», и внизу программа предупреждает о темах под угрозой.</a:t>
+            </a:r>
+            <a:endParaRPr lang="en-US" dirty="0"/>
+          </a:p>
+        </p:txBody>
+      </p:sp>
+      <p:sp>
+        <p:nvSpPr>
+          <p:cNvPr id="4" name="Slide Number Placeholder 3"/>
+          <p:cNvSpPr>
+            <a:spLocks noGrp="1"/>
+          </p:cNvSpPr>
+          <p:nvPr>
+            <p:ph type="sldNum" sz="quarter" idx="10"/>
+          </p:nvPr>
+        </p:nvSpPr>
+        <p:spPr/>
+        <p:txBody>
+          <a:bodyPr/>
+          <a:lstStyle/>
+          <a:p>
+            <a:fld id="{F7021451-1387-4CA6-816F-3879F97B5CBC}" type="slidenum">
+              <a:rPr lang="en-US"/>
+              <a:t>16</a:t>
+            </a:fld>
+            <a:endParaRPr lang="en-US"/>
+          </a:p>
+        </p:txBody>
+      </p:sp>
+    </p:spTree>
+    <p:extLst>
+      <p:ext uri="{BB962C8B-B14F-4D97-AF65-F5344CB8AC3E}">
+        <p14:creationId xmlns:p14="http://schemas.microsoft.com/office/powerpoint/2010/main" val="1024086991"/>
+      </p:ext>
+    </p:extLst>
+  </p:cSld>
+  <p:clrMapOvr>
+    <a:masterClrMapping/>
+  </p:clrMapOvr>
+</p:notes>
+</file>
+
+<file path=ppt/notesSlides/notesSlide17.xml><?xml version="1.0" encoding="utf-8"?>
+<p:notes xmlns:a="http://schemas.openxmlformats.org/drawingml/2006/main" xmlns:r="http://schemas.openxmlformats.org/officeDocument/2006/relationships" xmlns:p="http://schemas.openxmlformats.org/presentationml/2006/main">
+  <p:cSld>
+    <p:spTree>
+      <p:nvGrpSpPr>
+        <p:cNvPr id="1" name=""/>
+        <p:cNvGrpSpPr/>
+        <p:nvPr/>
+      </p:nvGrpSpPr>
+      <p:grpSpPr>
+        <a:xfrm>
+          <a:off x="0" y="0"/>
+          <a:ext cx="0" cy="0"/>
+          <a:chOff x="0" y="0"/>
+          <a:chExt cx="0" cy="0"/>
+        </a:xfrm>
+      </p:grpSpPr>
+      <p:sp>
+        <p:nvSpPr>
+          <p:cNvPr id="2" name="Slide Image Placeholder 1"/>
+          <p:cNvSpPr>
+            <a:spLocks noGrp="1" noRot="1" noChangeAspect="1"/>
+          </p:cNvSpPr>
+          <p:nvPr>
+            <p:ph type="sldImg"/>
+          </p:nvPr>
+        </p:nvSpPr>
+        <p:spPr/>
+      </p:sp>
+      <p:sp>
+        <p:nvSpPr>
+          <p:cNvPr id="3" name="Notes Placeholder 2"/>
+          <p:cNvSpPr>
+            <a:spLocks noGrp="1"/>
+          </p:cNvSpPr>
+          <p:nvPr>
+            <p:ph type="body" idx="1"/>
+          </p:nvPr>
+        </p:nvSpPr>
+        <p:spPr/>
+        <p:txBody>
+          <a:bodyPr/>
+          <a:lstStyle/>
+          <a:p>
+            <a:r>
+              <a:rPr lang="en-US" dirty="0"/>
+              <a:t>Здесь примеры ввода и вывода. Пустое название, неверная дата, дата в прошлом, повтор: на каждый случай программа пишет понятное сообщение и продолжает работать. Для темы «Введение в анализ» по математике сложность подобралась сама и равна двум. Справа окно добавления нескольких тем и сообщение об ошибке.</a:t>
+            </a:r>
+            <a:endParaRPr lang="en-US" dirty="0"/>
+          </a:p>
+        </p:txBody>
+      </p:sp>
+      <p:sp>
+        <p:nvSpPr>
+          <p:cNvPr id="4" name="Slide Number Placeholder 3"/>
+          <p:cNvSpPr>
+            <a:spLocks noGrp="1"/>
+          </p:cNvSpPr>
+          <p:nvPr>
+            <p:ph type="sldNum" sz="quarter" idx="10"/>
+          </p:nvPr>
+        </p:nvSpPr>
+        <p:spPr/>
+        <p:txBody>
+          <a:bodyPr/>
+          <a:lstStyle/>
+          <a:p>
+            <a:fld id="{F7021451-1387-4CA6-816F-3879F97B5CBC}" type="slidenum">
+              <a:rPr lang="en-US"/>
+              <a:t>17</a:t>
+            </a:fld>
+            <a:endParaRPr lang="en-US"/>
+          </a:p>
+        </p:txBody>
+      </p:sp>
+    </p:spTree>
+    <p:extLst>
+      <p:ext uri="{BB962C8B-B14F-4D97-AF65-F5344CB8AC3E}">
+        <p14:creationId xmlns:p14="http://schemas.microsoft.com/office/powerpoint/2010/main" val="1024086991"/>
+      </p:ext>
+    </p:extLst>
+  </p:cSld>
+  <p:clrMapOvr>
+    <a:masterClrMapping/>
+  </p:clrMapOvr>
+</p:notes>
+</file>
+
+<file path=ppt/notesSlides/notesSlide18.xml><?xml version="1.0" encoding="utf-8"?>
+<p:notes xmlns:a="http://schemas.openxmlformats.org/drawingml/2006/main" xmlns:r="http://schemas.openxmlformats.org/officeDocument/2006/relationships" xmlns:p="http://schemas.openxmlformats.org/presentationml/2006/main">
+  <p:cSld>
+    <p:spTree>
+      <p:nvGrpSpPr>
+        <p:cNvPr id="1" name=""/>
+        <p:cNvGrpSpPr/>
+        <p:nvPr/>
+      </p:nvGrpSpPr>
+      <p:grpSpPr>
+        <a:xfrm>
+          <a:off x="0" y="0"/>
+          <a:ext cx="0" cy="0"/>
+          <a:chOff x="0" y="0"/>
+          <a:chExt cx="0" cy="0"/>
+        </a:xfrm>
+      </p:grpSpPr>
+      <p:sp>
+        <p:nvSpPr>
+          <p:cNvPr id="2" name="Slide Image Placeholder 1"/>
+          <p:cNvSpPr>
+            <a:spLocks noGrp="1" noRot="1" noChangeAspect="1"/>
+          </p:cNvSpPr>
+          <p:nvPr>
+            <p:ph type="sldImg"/>
+          </p:nvPr>
+        </p:nvSpPr>
+        <p:spPr/>
+      </p:sp>
+      <p:sp>
+        <p:nvSpPr>
+          <p:cNvPr id="3" name="Notes Placeholder 2"/>
+          <p:cNvSpPr>
+            <a:spLocks noGrp="1"/>
+          </p:cNvSpPr>
+          <p:nvPr>
+            <p:ph type="body" idx="1"/>
+          </p:nvPr>
+        </p:nvSpPr>
+        <p:spPr/>
+        <p:txBody>
+          <a:bodyPr/>
+          <a:lstStyle/>
+          <a:p>
+            <a:r>
+              <a:rPr lang="en-US" dirty="0"/>
+              <a:t>Логику проверяют 70 автотестов, все проходят. Они смотрят на неверный ввод, лимиты часов, день повторения, распределение по дням, перепланирование, автоподбор сложности и битые файлы. Окно мы проверяли руками.</a:t>
+            </a:r>
+            <a:endParaRPr lang="en-US" dirty="0"/>
+          </a:p>
+        </p:txBody>
+      </p:sp>
+      <p:sp>
+        <p:nvSpPr>
+          <p:cNvPr id="4" name="Slide Number Placeholder 3"/>
+          <p:cNvSpPr>
+            <a:spLocks noGrp="1"/>
+          </p:cNvSpPr>
+          <p:nvPr>
+            <p:ph type="sldNum" sz="quarter" idx="10"/>
+          </p:nvPr>
+        </p:nvSpPr>
+        <p:spPr/>
+        <p:txBody>
+          <a:bodyPr/>
+          <a:lstStyle/>
+          <a:p>
+            <a:fld id="{F7021451-1387-4CA6-816F-3879F97B5CBC}" type="slidenum">
+              <a:rPr lang="en-US"/>
+              <a:t>18</a:t>
+            </a:fld>
+            <a:endParaRPr lang="en-US"/>
+          </a:p>
+        </p:txBody>
+      </p:sp>
+    </p:spTree>
+    <p:extLst>
+      <p:ext uri="{BB962C8B-B14F-4D97-AF65-F5344CB8AC3E}">
+        <p14:creationId xmlns:p14="http://schemas.microsoft.com/office/powerpoint/2010/main" val="1024086991"/>
+      </p:ext>
+    </p:extLst>
+  </p:cSld>
+  <p:clrMapOvr>
+    <a:masterClrMapping/>
+  </p:clrMapOvr>
+</p:notes>
+</file>
+
+<file path=ppt/notesSlides/notesSlide19.xml><?xml version="1.0" encoding="utf-8"?>
+<p:notes xmlns:a="http://schemas.openxmlformats.org/drawingml/2006/main" xmlns:r="http://schemas.openxmlformats.org/officeDocument/2006/relationships" xmlns:p="http://schemas.openxmlformats.org/presentationml/2006/main">
+  <p:cSld>
+    <p:spTree>
+      <p:nvGrpSpPr>
+        <p:cNvPr id="1" name=""/>
+        <p:cNvGrpSpPr/>
+        <p:nvPr/>
+      </p:nvGrpSpPr>
+      <p:grpSpPr>
+        <a:xfrm>
+          <a:off x="0" y="0"/>
+          <a:ext cx="0" cy="0"/>
+          <a:chOff x="0" y="0"/>
+          <a:chExt cx="0" cy="0"/>
+        </a:xfrm>
+      </p:grpSpPr>
+      <p:sp>
+        <p:nvSpPr>
+          <p:cNvPr id="2" name="Slide Image Placeholder 1"/>
+          <p:cNvSpPr>
+            <a:spLocks noGrp="1" noRot="1" noChangeAspect="1"/>
+          </p:cNvSpPr>
+          <p:nvPr>
+            <p:ph type="sldImg"/>
+          </p:nvPr>
+        </p:nvSpPr>
+        <p:spPr/>
+      </p:sp>
+      <p:sp>
+        <p:nvSpPr>
+          <p:cNvPr id="3" name="Notes Placeholder 2"/>
+          <p:cNvSpPr>
+            <a:spLocks noGrp="1"/>
+          </p:cNvSpPr>
+          <p:nvPr>
+            <p:ph type="body" idx="1"/>
+          </p:nvPr>
+        </p:nvSpPr>
+        <p:spPr/>
+        <p:txBody>
+          <a:bodyPr/>
+          <a:lstStyle/>
+          <a:p>
+            <a:r>
+              <a:rPr lang="en-US" dirty="0"/>
+              <a:t>Итог: программа работает, с окном, календарём и диаграммой Ганта, данные сохраняются, логика покрыта тестами. Дальше можно добавить редактирование записей, напоминания и экспорт в календарь. Код проекта выложен на GitHub, ссылка на последнем слайде. Спасибо за внимание, будем рады вопросам.</a:t>
+            </a:r>
+            <a:endParaRPr lang="en-US" dirty="0"/>
+          </a:p>
+        </p:txBody>
+      </p:sp>
+      <p:sp>
+        <p:nvSpPr>
+          <p:cNvPr id="4" name="Slide Number Placeholder 3"/>
+          <p:cNvSpPr>
+            <a:spLocks noGrp="1"/>
+          </p:cNvSpPr>
+          <p:nvPr>
+            <p:ph type="sldNum" sz="quarter" idx="10"/>
+          </p:nvPr>
+        </p:nvSpPr>
+        <p:spPr/>
+        <p:txBody>
+          <a:bodyPr/>
+          <a:lstStyle/>
+          <a:p>
+            <a:fld id="{F7021451-1387-4CA6-816F-3879F97B5CBC}" type="slidenum">
+              <a:rPr lang="en-US"/>
+              <a:t>19</a:t>
             </a:fld>
             <a:endParaRPr lang="en-US"/>
           </a:p>
@@ -1482,7 +2016,7 @@
           <a:p>
             <a:r>
               <a:rPr lang="en-US" dirty="0"/>
-              <a:t>Первый вид визуализации, календарь. Цвет клетки показывает, сколько часов стоит на этот день: чем ближе к лимиту, тем темнее. Экзамены красные, контрольные фиолетовые. Если нажать на день, внизу появится список тем и часов.</a:t>
+              <a:t>Начнём с кода. Вот наши собственные исключения: общий класс PlannerError и два потомка, ошибка ввода и ошибка файлов. А ниже функция проверки сложности: если ввод не число или выходит за границы от одного до пяти, она выбрасывает понятную ошибку, а не падает.</a:t>
             </a:r>
             <a:endParaRPr lang="en-US" dirty="0"/>
           </a:p>
@@ -1570,7 +2104,7 @@
           <a:p>
             <a:r>
               <a:rPr lang="en-US" dirty="0"/>
-              <a:t>Второй вид, диаграмма Ганта. Каждая тема это полоска от первого до последнего дня занятий, полоски сгруппированы по экзаменам. Вертикальные линии показывают даты экзаменов, пунктирная линия — сегодня. Выполненные темы и те, что не успеть, вынесены в отдельные строки.</a:t>
+              <a:t>Ловим ошибки в двух местах. В окне любое действие пользователя выполняется внутри try, и если случилась наша ошибка, показываем сообщение. А при чтении файлов любая проблема приводит к копии файла с расширением bak и пустому плану, программа не вылетает.</a:t>
             </a:r>
             <a:endParaRPr lang="en-US" dirty="0"/>
           </a:p>
@@ -2491,7 +3025,7 @@
                 <a:ea typeface="Cambria" pitchFamily="34" charset="-122"/>
                 <a:cs typeface="Cambria" pitchFamily="34" charset="-120"/>
               </a:rPr>
-              <a:t>Работа программы по шагам</a:t>
+              <a:t>Словари: оценка сложности</a:t>
             </a:r>
             <a:endParaRPr lang="en-US" sz="3400" dirty="0"/>
           </a:p>
@@ -2505,8 +3039,8 @@
         </p:nvSpPr>
         <p:spPr>
           <a:xfrm>
-            <a:off x="523566" y="1298448"/>
-            <a:ext cx="3296268" cy="2386584"/>
+            <a:off x="521208" y="1542022"/>
+            <a:ext cx="11146536" cy="4414036"/>
           </a:xfrm>
           <a:prstGeom prst="rect">
             <a:avLst/>
@@ -2524,7 +3058,7 @@
       </p:sp>
       <p:pic>
         <p:nvPicPr>
-          <p:cNvPr id="5" name="Image 0" descr="Скриншот программы: s1_empty.png">    </p:cNvPr>
+          <p:cNvPr id="5" name="Image 0" descr="Скриншот программы: code_dicts_right.png">    </p:cNvPr>
           <p:cNvPicPr>
             <a:picLocks noChangeAspect="1"/>
           </p:cNvPicPr>
@@ -2538,729 +3072,14 @@
         </p:blipFill>
         <p:spPr>
           <a:xfrm>
-            <a:off x="550998" y="1325880"/>
-            <a:ext cx="3241404" cy="2331720"/>
+            <a:off x="548640" y="1569454"/>
+            <a:ext cx="11091672" cy="4359172"/>
           </a:xfrm>
           <a:prstGeom prst="rect">
             <a:avLst/>
           </a:prstGeom>
         </p:spPr>
       </p:pic>
-      <p:sp>
-        <p:nvSpPr>
-          <p:cNvPr id="6" name="Shape 2"/>
-          <p:cNvSpPr/>
-          <p:nvPr/>
-        </p:nvSpPr>
-        <p:spPr>
-          <a:xfrm>
-            <a:off x="3977640" y="1371600"/>
-            <a:ext cx="457200" cy="457200"/>
-          </a:xfrm>
-          <a:prstGeom prst="ellipse">
-            <a:avLst/>
-          </a:prstGeom>
-          <a:solidFill>
-            <a:srgbClr val="4F46E5"/>
-          </a:solidFill>
-          <a:ln w="12700">
-            <a:solidFill>
-              <a:srgbClr val="4F46E5"/>
-            </a:solidFill>
-            <a:prstDash val="solid"/>
-          </a:ln>
-        </p:spPr>
-      </p:sp>
-      <p:sp>
-        <p:nvSpPr>
-          <p:cNvPr id="7" name="Text 3"/>
-          <p:cNvSpPr txBox="1"/>
-          <p:nvPr/>
-        </p:nvSpPr>
-        <p:spPr>
-          <a:xfrm>
-            <a:off x="3977640" y="1371600"/>
-            <a:ext cx="457200" cy="457200"/>
-          </a:xfrm>
-          <a:prstGeom prst="rect">
-            <a:avLst/>
-          </a:prstGeom>
-          <a:noFill/>
-          <a:ln/>
-        </p:spPr>
-        <p:txBody>
-          <a:bodyPr wrap="square" lIns="0" tIns="0" rIns="0" bIns="0" rtlCol="0" anchor="ctr"/>
-          <a:lstStyle/>
-          <a:p>
-            <a:pPr algn="ctr" indent="0" marL="0">
-              <a:buNone/>
-            </a:pPr>
-            <a:r>
-              <a:rPr lang="en-US" sz="1600" b="1" dirty="0">
-                <a:solidFill>
-                  <a:srgbClr val="FFFFFF"/>
-                </a:solidFill>
-                <a:latin typeface="Calibri" pitchFamily="34" charset="0"/>
-                <a:ea typeface="Calibri" pitchFamily="34" charset="-122"/>
-                <a:cs typeface="Calibri" pitchFamily="34" charset="-120"/>
-              </a:rPr>
-              <a:t>1</a:t>
-            </a:r>
-            <a:endParaRPr lang="en-US" sz="1600" dirty="0"/>
-          </a:p>
-        </p:txBody>
-      </p:sp>
-      <p:sp>
-        <p:nvSpPr>
-          <p:cNvPr id="8" name="Text 4"/>
-          <p:cNvSpPr txBox="1"/>
-          <p:nvPr/>
-        </p:nvSpPr>
-        <p:spPr>
-          <a:xfrm>
-            <a:off x="4526280" y="1371600"/>
-            <a:ext cx="1554480" cy="457200"/>
-          </a:xfrm>
-          <a:prstGeom prst="rect">
-            <a:avLst/>
-          </a:prstGeom>
-          <a:noFill/>
-          <a:ln/>
-        </p:spPr>
-        <p:txBody>
-          <a:bodyPr wrap="square" lIns="0" tIns="0" rIns="0" bIns="0" rtlCol="0" anchor="ctr"/>
-          <a:lstStyle/>
-          <a:p>
-            <a:pPr indent="0" marL="0">
-              <a:buNone/>
-            </a:pPr>
-            <a:r>
-              <a:rPr lang="en-US" sz="1600" b="1" dirty="0">
-                <a:solidFill>
-                  <a:srgbClr val="1E1B4B"/>
-                </a:solidFill>
-                <a:latin typeface="Cambria" pitchFamily="34" charset="0"/>
-                <a:ea typeface="Cambria" pitchFamily="34" charset="-122"/>
-                <a:cs typeface="Cambria" pitchFamily="34" charset="-120"/>
-              </a:rPr>
-              <a:t>Старт</a:t>
-            </a:r>
-            <a:endParaRPr lang="en-US" sz="1600" dirty="0"/>
-          </a:p>
-        </p:txBody>
-      </p:sp>
-      <p:sp>
-        <p:nvSpPr>
-          <p:cNvPr id="9" name="Text 5"/>
-          <p:cNvSpPr txBox="1"/>
-          <p:nvPr/>
-        </p:nvSpPr>
-        <p:spPr>
-          <a:xfrm>
-            <a:off x="3977640" y="1965960"/>
-            <a:ext cx="2103120" cy="1645920"/>
-          </a:xfrm>
-          <a:prstGeom prst="rect">
-            <a:avLst/>
-          </a:prstGeom>
-          <a:noFill/>
-          <a:ln/>
-        </p:spPr>
-        <p:txBody>
-          <a:bodyPr wrap="square" lIns="0" tIns="0" rIns="0" bIns="0" rtlCol="0" anchor="t"/>
-          <a:lstStyle/>
-          <a:p>
-            <a:pPr indent="0" marL="0">
-              <a:buNone/>
-            </a:pPr>
-            <a:r>
-              <a:rPr lang="en-US" sz="1400" dirty="0">
-                <a:solidFill>
-                  <a:srgbClr val="0F172A"/>
-                </a:solidFill>
-                <a:latin typeface="Calibri" pitchFamily="34" charset="0"/>
-                <a:ea typeface="Calibri" pitchFamily="34" charset="-122"/>
-                <a:cs typeface="Calibri" pitchFamily="34" charset="-120"/>
-              </a:rPr>
-              <a:t>Окно пустое, в полях подсказки. Предмет и тему можно выбрать из списка.</a:t>
-            </a:r>
-            <a:endParaRPr lang="en-US" sz="1400" dirty="0"/>
-          </a:p>
-        </p:txBody>
-      </p:sp>
-      <p:sp>
-        <p:nvSpPr>
-          <p:cNvPr id="10" name="Shape 6"/>
-          <p:cNvSpPr/>
-          <p:nvPr/>
-        </p:nvSpPr>
-        <p:spPr>
-          <a:xfrm>
-            <a:off x="6261197" y="1298448"/>
-            <a:ext cx="3159565" cy="2386584"/>
-          </a:xfrm>
-          <a:prstGeom prst="rect">
-            <a:avLst/>
-          </a:prstGeom>
-          <a:solidFill>
-            <a:srgbClr val="FFFFFF"/>
-          </a:solidFill>
-          <a:ln w="9525">
-            <a:solidFill>
-              <a:srgbClr val="CBD5E1"/>
-            </a:solidFill>
-            <a:prstDash val="solid"/>
-          </a:ln>
-        </p:spPr>
-      </p:sp>
-      <p:pic>
-        <p:nvPicPr>
-          <p:cNvPr id="11" name="Image 1" descr="Скриншот программы: 03_dialog.png">    </p:cNvPr>
-          <p:cNvPicPr>
-            <a:picLocks noChangeAspect="1"/>
-          </p:cNvPicPr>
-          <p:nvPr/>
-        </p:nvPicPr>
-        <p:blipFill>
-          <a:blip r:embed="rId2"/>
-          <a:stretch>
-            <a:fillRect/>
-          </a:stretch>
-        </p:blipFill>
-        <p:spPr>
-          <a:xfrm>
-            <a:off x="6288629" y="1325880"/>
-            <a:ext cx="3104701" cy="2331720"/>
-          </a:xfrm>
-          <a:prstGeom prst="rect">
-            <a:avLst/>
-          </a:prstGeom>
-        </p:spPr>
-      </p:pic>
-      <p:sp>
-        <p:nvSpPr>
-          <p:cNvPr id="12" name="Shape 7"/>
-          <p:cNvSpPr/>
-          <p:nvPr/>
-        </p:nvSpPr>
-        <p:spPr>
-          <a:xfrm>
-            <a:off x="9646920" y="1371600"/>
-            <a:ext cx="457200" cy="457200"/>
-          </a:xfrm>
-          <a:prstGeom prst="ellipse">
-            <a:avLst/>
-          </a:prstGeom>
-          <a:solidFill>
-            <a:srgbClr val="4F46E5"/>
-          </a:solidFill>
-          <a:ln w="12700">
-            <a:solidFill>
-              <a:srgbClr val="4F46E5"/>
-            </a:solidFill>
-            <a:prstDash val="solid"/>
-          </a:ln>
-        </p:spPr>
-      </p:sp>
-      <p:sp>
-        <p:nvSpPr>
-          <p:cNvPr id="13" name="Text 8"/>
-          <p:cNvSpPr txBox="1"/>
-          <p:nvPr/>
-        </p:nvSpPr>
-        <p:spPr>
-          <a:xfrm>
-            <a:off x="9646920" y="1371600"/>
-            <a:ext cx="457200" cy="457200"/>
-          </a:xfrm>
-          <a:prstGeom prst="rect">
-            <a:avLst/>
-          </a:prstGeom>
-          <a:noFill/>
-          <a:ln/>
-        </p:spPr>
-        <p:txBody>
-          <a:bodyPr wrap="square" lIns="0" tIns="0" rIns="0" bIns="0" rtlCol="0" anchor="ctr"/>
-          <a:lstStyle/>
-          <a:p>
-            <a:pPr algn="ctr" indent="0" marL="0">
-              <a:buNone/>
-            </a:pPr>
-            <a:r>
-              <a:rPr lang="en-US" sz="1600" b="1" dirty="0">
-                <a:solidFill>
-                  <a:srgbClr val="FFFFFF"/>
-                </a:solidFill>
-                <a:latin typeface="Calibri" pitchFamily="34" charset="0"/>
-                <a:ea typeface="Calibri" pitchFamily="34" charset="-122"/>
-                <a:cs typeface="Calibri" pitchFamily="34" charset="-120"/>
-              </a:rPr>
-              <a:t>2</a:t>
-            </a:r>
-            <a:endParaRPr lang="en-US" sz="1600" dirty="0"/>
-          </a:p>
-        </p:txBody>
-      </p:sp>
-      <p:sp>
-        <p:nvSpPr>
-          <p:cNvPr id="14" name="Text 9"/>
-          <p:cNvSpPr txBox="1"/>
-          <p:nvPr/>
-        </p:nvSpPr>
-        <p:spPr>
-          <a:xfrm>
-            <a:off x="10195560" y="1371600"/>
-            <a:ext cx="1554480" cy="457200"/>
-          </a:xfrm>
-          <a:prstGeom prst="rect">
-            <a:avLst/>
-          </a:prstGeom>
-          <a:noFill/>
-          <a:ln/>
-        </p:spPr>
-        <p:txBody>
-          <a:bodyPr wrap="square" lIns="0" tIns="0" rIns="0" bIns="0" rtlCol="0" anchor="ctr"/>
-          <a:lstStyle/>
-          <a:p>
-            <a:pPr indent="0" marL="0">
-              <a:buNone/>
-            </a:pPr>
-            <a:r>
-              <a:rPr lang="en-US" sz="1600" b="1" dirty="0">
-                <a:solidFill>
-                  <a:srgbClr val="1E1B4B"/>
-                </a:solidFill>
-                <a:latin typeface="Cambria" pitchFamily="34" charset="0"/>
-                <a:ea typeface="Cambria" pitchFamily="34" charset="-122"/>
-                <a:cs typeface="Cambria" pitchFamily="34" charset="-120"/>
-              </a:rPr>
-              <a:t>Темы пачкой</a:t>
-            </a:r>
-            <a:endParaRPr lang="en-US" sz="1600" dirty="0"/>
-          </a:p>
-        </p:txBody>
-      </p:sp>
-      <p:sp>
-        <p:nvSpPr>
-          <p:cNvPr id="15" name="Text 10"/>
-          <p:cNvSpPr txBox="1"/>
-          <p:nvPr/>
-        </p:nvSpPr>
-        <p:spPr>
-          <a:xfrm>
-            <a:off x="9646920" y="1965960"/>
-            <a:ext cx="2103120" cy="1645920"/>
-          </a:xfrm>
-          <a:prstGeom prst="rect">
-            <a:avLst/>
-          </a:prstGeom>
-          <a:noFill/>
-          <a:ln/>
-        </p:spPr>
-        <p:txBody>
-          <a:bodyPr wrap="square" lIns="0" tIns="0" rIns="0" bIns="0" rtlCol="0" anchor="t"/>
-          <a:lstStyle/>
-          <a:p>
-            <a:pPr indent="0" marL="0">
-              <a:buNone/>
-            </a:pPr>
-            <a:r>
-              <a:rPr lang="en-US" sz="1400" dirty="0">
-                <a:solidFill>
-                  <a:srgbClr val="0F172A"/>
-                </a:solidFill>
-                <a:latin typeface="Calibri" pitchFamily="34" charset="0"/>
-                <a:ea typeface="Calibri" pitchFamily="34" charset="-122"/>
-                <a:cs typeface="Calibri" pitchFamily="34" charset="-120"/>
-              </a:rPr>
-              <a:t>В окне «Несколько…» отмечаем готовые темы и дописываем свои.</a:t>
-            </a:r>
-            <a:endParaRPr lang="en-US" sz="1400" dirty="0"/>
-          </a:p>
-        </p:txBody>
-      </p:sp>
-      <p:sp>
-        <p:nvSpPr>
-          <p:cNvPr id="16" name="Shape 11"/>
-          <p:cNvSpPr/>
-          <p:nvPr/>
-        </p:nvSpPr>
-        <p:spPr>
-          <a:xfrm>
-            <a:off x="523566" y="3813048"/>
-            <a:ext cx="3296268" cy="2386584"/>
-          </a:xfrm>
-          <a:prstGeom prst="rect">
-            <a:avLst/>
-          </a:prstGeom>
-          <a:solidFill>
-            <a:srgbClr val="FFFFFF"/>
-          </a:solidFill>
-          <a:ln w="9525">
-            <a:solidFill>
-              <a:srgbClr val="CBD5E1"/>
-            </a:solidFill>
-            <a:prstDash val="solid"/>
-          </a:ln>
-        </p:spPr>
-      </p:sp>
-      <p:pic>
-        <p:nvPicPr>
-          <p:cNvPr id="17" name="Image 2" descr="Скриншот программы: s4_risk_calendar.png">    </p:cNvPr>
-          <p:cNvPicPr>
-            <a:picLocks noChangeAspect="1"/>
-          </p:cNvPicPr>
-          <p:nvPr/>
-        </p:nvPicPr>
-        <p:blipFill>
-          <a:blip r:embed="rId3"/>
-          <a:stretch>
-            <a:fillRect/>
-          </a:stretch>
-        </p:blipFill>
-        <p:spPr>
-          <a:xfrm>
-            <a:off x="550998" y="3840480"/>
-            <a:ext cx="3241404" cy="2331720"/>
-          </a:xfrm>
-          <a:prstGeom prst="rect">
-            <a:avLst/>
-          </a:prstGeom>
-        </p:spPr>
-      </p:pic>
-      <p:sp>
-        <p:nvSpPr>
-          <p:cNvPr id="18" name="Shape 12"/>
-          <p:cNvSpPr/>
-          <p:nvPr/>
-        </p:nvSpPr>
-        <p:spPr>
-          <a:xfrm>
-            <a:off x="3977640" y="3886200"/>
-            <a:ext cx="457200" cy="457200"/>
-          </a:xfrm>
-          <a:prstGeom prst="ellipse">
-            <a:avLst/>
-          </a:prstGeom>
-          <a:solidFill>
-            <a:srgbClr val="4F46E5"/>
-          </a:solidFill>
-          <a:ln w="12700">
-            <a:solidFill>
-              <a:srgbClr val="4F46E5"/>
-            </a:solidFill>
-            <a:prstDash val="solid"/>
-          </a:ln>
-        </p:spPr>
-      </p:sp>
-      <p:sp>
-        <p:nvSpPr>
-          <p:cNvPr id="19" name="Text 13"/>
-          <p:cNvSpPr txBox="1"/>
-          <p:nvPr/>
-        </p:nvSpPr>
-        <p:spPr>
-          <a:xfrm>
-            <a:off x="3977640" y="3886200"/>
-            <a:ext cx="457200" cy="457200"/>
-          </a:xfrm>
-          <a:prstGeom prst="rect">
-            <a:avLst/>
-          </a:prstGeom>
-          <a:noFill/>
-          <a:ln/>
-        </p:spPr>
-        <p:txBody>
-          <a:bodyPr wrap="square" lIns="0" tIns="0" rIns="0" bIns="0" rtlCol="0" anchor="ctr"/>
-          <a:lstStyle/>
-          <a:p>
-            <a:pPr algn="ctr" indent="0" marL="0">
-              <a:buNone/>
-            </a:pPr>
-            <a:r>
-              <a:rPr lang="en-US" sz="1600" b="1" dirty="0">
-                <a:solidFill>
-                  <a:srgbClr val="FFFFFF"/>
-                </a:solidFill>
-                <a:latin typeface="Calibri" pitchFamily="34" charset="0"/>
-                <a:ea typeface="Calibri" pitchFamily="34" charset="-122"/>
-                <a:cs typeface="Calibri" pitchFamily="34" charset="-120"/>
-              </a:rPr>
-              <a:t>3</a:t>
-            </a:r>
-            <a:endParaRPr lang="en-US" sz="1600" dirty="0"/>
-          </a:p>
-        </p:txBody>
-      </p:sp>
-      <p:sp>
-        <p:nvSpPr>
-          <p:cNvPr id="20" name="Text 14"/>
-          <p:cNvSpPr txBox="1"/>
-          <p:nvPr/>
-        </p:nvSpPr>
-        <p:spPr>
-          <a:xfrm>
-            <a:off x="4526280" y="3886200"/>
-            <a:ext cx="1554480" cy="457200"/>
-          </a:xfrm>
-          <a:prstGeom prst="rect">
-            <a:avLst/>
-          </a:prstGeom>
-          <a:noFill/>
-          <a:ln/>
-        </p:spPr>
-        <p:txBody>
-          <a:bodyPr wrap="square" lIns="0" tIns="0" rIns="0" bIns="0" rtlCol="0" anchor="ctr"/>
-          <a:lstStyle/>
-          <a:p>
-            <a:pPr indent="0" marL="0">
-              <a:buNone/>
-            </a:pPr>
-            <a:r>
-              <a:rPr lang="en-US" sz="1600" b="1" dirty="0">
-                <a:solidFill>
-                  <a:srgbClr val="1E1B4B"/>
-                </a:solidFill>
-                <a:latin typeface="Cambria" pitchFamily="34" charset="0"/>
-                <a:ea typeface="Cambria" pitchFamily="34" charset="-122"/>
-                <a:cs typeface="Cambria" pitchFamily="34" charset="-120"/>
-              </a:rPr>
-              <a:t>Мало часов в день</a:t>
-            </a:r>
-            <a:endParaRPr lang="en-US" sz="1600" dirty="0"/>
-          </a:p>
-        </p:txBody>
-      </p:sp>
-      <p:sp>
-        <p:nvSpPr>
-          <p:cNvPr id="21" name="Text 15"/>
-          <p:cNvSpPr txBox="1"/>
-          <p:nvPr/>
-        </p:nvSpPr>
-        <p:spPr>
-          <a:xfrm>
-            <a:off x="3977640" y="4480560"/>
-            <a:ext cx="2103120" cy="1645920"/>
-          </a:xfrm>
-          <a:prstGeom prst="rect">
-            <a:avLst/>
-          </a:prstGeom>
-          <a:noFill/>
-          <a:ln/>
-        </p:spPr>
-        <p:txBody>
-          <a:bodyPr wrap="square" lIns="0" tIns="0" rIns="0" bIns="0" rtlCol="0" anchor="t"/>
-          <a:lstStyle/>
-          <a:p>
-            <a:pPr indent="0" marL="0">
-              <a:buNone/>
-            </a:pPr>
-            <a:r>
-              <a:rPr lang="en-US" sz="1400" dirty="0">
-                <a:solidFill>
-                  <a:srgbClr val="0F172A"/>
-                </a:solidFill>
-                <a:latin typeface="Calibri" pitchFamily="34" charset="0"/>
-                <a:ea typeface="Calibri" pitchFamily="34" charset="-122"/>
-                <a:cs typeface="Calibri" pitchFamily="34" charset="-120"/>
-              </a:rPr>
-              <a:t>Поставили 2 часа в день, и календарь заполнился почти целиком.</a:t>
-            </a:r>
-            <a:endParaRPr lang="en-US" sz="1400" dirty="0"/>
-          </a:p>
-        </p:txBody>
-      </p:sp>
-      <p:sp>
-        <p:nvSpPr>
-          <p:cNvPr id="22" name="Shape 16"/>
-          <p:cNvSpPr/>
-          <p:nvPr/>
-        </p:nvSpPr>
-        <p:spPr>
-          <a:xfrm>
-            <a:off x="6192846" y="3813048"/>
-            <a:ext cx="3296268" cy="2386584"/>
-          </a:xfrm>
-          <a:prstGeom prst="rect">
-            <a:avLst/>
-          </a:prstGeom>
-          <a:solidFill>
-            <a:srgbClr val="FFFFFF"/>
-          </a:solidFill>
-          <a:ln w="9525">
-            <a:solidFill>
-              <a:srgbClr val="CBD5E1"/>
-            </a:solidFill>
-            <a:prstDash val="solid"/>
-          </a:ln>
-        </p:spPr>
-      </p:sp>
-      <p:pic>
-        <p:nvPicPr>
-          <p:cNvPr id="23" name="Image 3" descr="Скриншот программы: s4_risk_gantt.png">    </p:cNvPr>
-          <p:cNvPicPr>
-            <a:picLocks noChangeAspect="1"/>
-          </p:cNvPicPr>
-          <p:nvPr/>
-        </p:nvPicPr>
-        <p:blipFill>
-          <a:blip r:embed="rId4"/>
-          <a:stretch>
-            <a:fillRect/>
-          </a:stretch>
-        </p:blipFill>
-        <p:spPr>
-          <a:xfrm>
-            <a:off x="6220278" y="3840480"/>
-            <a:ext cx="3241404" cy="2331720"/>
-          </a:xfrm>
-          <a:prstGeom prst="rect">
-            <a:avLst/>
-          </a:prstGeom>
-        </p:spPr>
-      </p:pic>
-      <p:sp>
-        <p:nvSpPr>
-          <p:cNvPr id="24" name="Shape 17"/>
-          <p:cNvSpPr/>
-          <p:nvPr/>
-        </p:nvSpPr>
-        <p:spPr>
-          <a:xfrm>
-            <a:off x="9646920" y="3886200"/>
-            <a:ext cx="457200" cy="457200"/>
-          </a:xfrm>
-          <a:prstGeom prst="ellipse">
-            <a:avLst/>
-          </a:prstGeom>
-          <a:solidFill>
-            <a:srgbClr val="4F46E5"/>
-          </a:solidFill>
-          <a:ln w="12700">
-            <a:solidFill>
-              <a:srgbClr val="4F46E5"/>
-            </a:solidFill>
-            <a:prstDash val="solid"/>
-          </a:ln>
-        </p:spPr>
-      </p:sp>
-      <p:sp>
-        <p:nvSpPr>
-          <p:cNvPr id="25" name="Text 18"/>
-          <p:cNvSpPr txBox="1"/>
-          <p:nvPr/>
-        </p:nvSpPr>
-        <p:spPr>
-          <a:xfrm>
-            <a:off x="9646920" y="3886200"/>
-            <a:ext cx="457200" cy="457200"/>
-          </a:xfrm>
-          <a:prstGeom prst="rect">
-            <a:avLst/>
-          </a:prstGeom>
-          <a:noFill/>
-          <a:ln/>
-        </p:spPr>
-        <p:txBody>
-          <a:bodyPr wrap="square" lIns="0" tIns="0" rIns="0" bIns="0" rtlCol="0" anchor="ctr"/>
-          <a:lstStyle/>
-          <a:p>
-            <a:pPr algn="ctr" indent="0" marL="0">
-              <a:buNone/>
-            </a:pPr>
-            <a:r>
-              <a:rPr lang="en-US" sz="1600" b="1" dirty="0">
-                <a:solidFill>
-                  <a:srgbClr val="FFFFFF"/>
-                </a:solidFill>
-                <a:latin typeface="Calibri" pitchFamily="34" charset="0"/>
-                <a:ea typeface="Calibri" pitchFamily="34" charset="-122"/>
-                <a:cs typeface="Calibri" pitchFamily="34" charset="-120"/>
-              </a:rPr>
-              <a:t>4</a:t>
-            </a:r>
-            <a:endParaRPr lang="en-US" sz="1600" dirty="0"/>
-          </a:p>
-        </p:txBody>
-      </p:sp>
-      <p:sp>
-        <p:nvSpPr>
-          <p:cNvPr id="26" name="Text 19"/>
-          <p:cNvSpPr txBox="1"/>
-          <p:nvPr/>
-        </p:nvSpPr>
-        <p:spPr>
-          <a:xfrm>
-            <a:off x="10195560" y="3886200"/>
-            <a:ext cx="1554480" cy="457200"/>
-          </a:xfrm>
-          <a:prstGeom prst="rect">
-            <a:avLst/>
-          </a:prstGeom>
-          <a:noFill/>
-          <a:ln/>
-        </p:spPr>
-        <p:txBody>
-          <a:bodyPr wrap="square" lIns="0" tIns="0" rIns="0" bIns="0" rtlCol="0" anchor="ctr"/>
-          <a:lstStyle/>
-          <a:p>
-            <a:pPr indent="0" marL="0">
-              <a:buNone/>
-            </a:pPr>
-            <a:r>
-              <a:rPr lang="en-US" sz="1600" b="1" dirty="0">
-                <a:solidFill>
-                  <a:srgbClr val="1E1B4B"/>
-                </a:solidFill>
-                <a:latin typeface="Cambria" pitchFamily="34" charset="0"/>
-                <a:ea typeface="Cambria" pitchFamily="34" charset="-122"/>
-                <a:cs typeface="Cambria" pitchFamily="34" charset="-120"/>
-              </a:rPr>
-              <a:t>Не успеваем</a:t>
-            </a:r>
-            <a:endParaRPr lang="en-US" sz="1600" dirty="0"/>
-          </a:p>
-        </p:txBody>
-      </p:sp>
-      <p:sp>
-        <p:nvSpPr>
-          <p:cNvPr id="27" name="Text 20"/>
-          <p:cNvSpPr txBox="1"/>
-          <p:nvPr/>
-        </p:nvSpPr>
-        <p:spPr>
-          <a:xfrm>
-            <a:off x="9646920" y="4480560"/>
-            <a:ext cx="2103120" cy="1645920"/>
-          </a:xfrm>
-          <a:prstGeom prst="rect">
-            <a:avLst/>
-          </a:prstGeom>
-          <a:noFill/>
-          <a:ln/>
-        </p:spPr>
-        <p:txBody>
-          <a:bodyPr wrap="square" lIns="0" tIns="0" rIns="0" bIns="0" rtlCol="0" anchor="t"/>
-          <a:lstStyle/>
-          <a:p>
-            <a:pPr indent="0" marL="0">
-              <a:buNone/>
-            </a:pPr>
-            <a:r>
-              <a:rPr lang="en-US" sz="1400" dirty="0">
-                <a:solidFill>
-                  <a:srgbClr val="0F172A"/>
-                </a:solidFill>
-                <a:latin typeface="Calibri" pitchFamily="34" charset="0"/>
-                <a:ea typeface="Calibri" pitchFamily="34" charset="-122"/>
-                <a:cs typeface="Calibri" pitchFamily="34" charset="-120"/>
-              </a:rPr>
-              <a:t>На диаграмме красные строки, внизу предупреждение о темах под угрозой.</a:t>
-            </a:r>
-            <a:endParaRPr lang="en-US" sz="1400" dirty="0"/>
-          </a:p>
-        </p:txBody>
-      </p:sp>
       <p:sp>
         <p:nvSpPr>
           <p:cNvPr id="25" name="Slide Number Placeholder 0"/>
@@ -3367,6 +3186,1967 @@
                 <a:ea typeface="Cambria" pitchFamily="34" charset="-122"/>
                 <a:cs typeface="Cambria" pitchFamily="34" charset="-120"/>
               </a:rPr>
+              <a:t>Словари: план по дням</a:t>
+            </a:r>
+            <a:endParaRPr lang="en-US" sz="3400" dirty="0"/>
+          </a:p>
+        </p:txBody>
+      </p:sp>
+      <p:sp>
+        <p:nvSpPr>
+          <p:cNvPr id="4" name="Shape 1"/>
+          <p:cNvSpPr/>
+          <p:nvPr/>
+        </p:nvSpPr>
+        <p:spPr>
+          <a:xfrm>
+            <a:off x="521208" y="1456289"/>
+            <a:ext cx="11146536" cy="4585502"/>
+          </a:xfrm>
+          <a:prstGeom prst="rect">
+            <a:avLst/>
+          </a:prstGeom>
+          <a:solidFill>
+            <a:srgbClr val="FFFFFF"/>
+          </a:solidFill>
+          <a:ln w="9525">
+            <a:solidFill>
+              <a:srgbClr val="CBD5E1"/>
+            </a:solidFill>
+            <a:prstDash val="solid"/>
+          </a:ln>
+        </p:spPr>
+      </p:sp>
+      <p:pic>
+        <p:nvPicPr>
+          <p:cNvPr id="5" name="Image 0" descr="Скриншот программы: code_dicts_left.png">    </p:cNvPr>
+          <p:cNvPicPr>
+            <a:picLocks noChangeAspect="1"/>
+          </p:cNvPicPr>
+          <p:nvPr/>
+        </p:nvPicPr>
+        <p:blipFill>
+          <a:blip r:embed="rId1"/>
+          <a:stretch>
+            <a:fillRect/>
+          </a:stretch>
+        </p:blipFill>
+        <p:spPr>
+          <a:xfrm>
+            <a:off x="548640" y="1483721"/>
+            <a:ext cx="11091672" cy="4530638"/>
+          </a:xfrm>
+          <a:prstGeom prst="rect">
+            <a:avLst/>
+          </a:prstGeom>
+        </p:spPr>
+      </p:pic>
+      <p:sp>
+        <p:nvSpPr>
+          <p:cNvPr id="25" name="Slide Number Placeholder 0"/>
+          <p:cNvSpPr>
+            <a:spLocks noGrp="1"/>
+          </p:cNvSpPr>
+          <p:nvPr>
+            <p:ph type="sldNum" sz="quarter" idx="4294967295"/>
+          </p:nvPr>
+        </p:nvSpPr>
+        <p:spPr>
+          <a:xfrm>
+            <a:off x="10972800" y="6400800"/>
+            <a:ext cx="731520" cy="274320"/>
+          </a:xfrm>
+          <a:prstGeom prst="rect">
+            <a:avLst/>
+          </a:prstGeom>
+          <a:extLst>
+            <a:ext uri="{C572A759-6A51-4108-AA02-DFA0A04FC94B}">
+              <ma14:wrappingTextBoxFlag xmlns:ma14="http://schemas.microsoft.com/office/mac/drawingml/2011/main" val="0"/>
+            </a:ext>
+          </a:extLst>
+        </p:spPr>
+        <p:txBody>
+          <a:bodyPr/>
+          <a:lstStyle>
+            <a:lvl1pPr>
+              <a:defRPr sz="1000">
+                <a:solidFill>
+                  <a:srgbClr val="64748B"/>
+                </a:solidFill>
+                <a:latin typeface="Calibri"/>
+                <a:ea typeface="Calibri"/>
+                <a:cs typeface="Calibri"/>
+              </a:defRPr>
+            </a:lvl1pPr>
+          </a:lstStyle>
+          <a:p>
+            <a:pPr algn="r"/>
+            <a:fld id="{F7021451-1387-4CA6-816F-3879F97B5CBC}" type="slidenum">
+              <a:rPr b="0" lang="en-US"/>
+              <a:t>11</a:t>
+            </a:fld>
+            <a:endParaRPr lang="en-US"/>
+          </a:p>
+        </p:txBody>
+      </p:sp>
+    </p:spTree>
+  </p:cSld>
+  <p:clrMapOvr>
+    <a:masterClrMapping/>
+  </p:clrMapOvr>
+</p:sld>
+</file>
+
+<file path=ppt/slides/slide12.xml><?xml version="1.0" encoding="utf-8"?>
+<p:sld xmlns:a="http://schemas.openxmlformats.org/drawingml/2006/main" xmlns:r="http://schemas.openxmlformats.org/officeDocument/2006/relationships" xmlns:p="http://schemas.openxmlformats.org/presentationml/2006/main">
+  <p:cSld name="Slide 12">
+    <p:spTree>
+      <p:nvGrpSpPr>
+        <p:cNvPr id="1" name=""/>
+        <p:cNvGrpSpPr/>
+        <p:nvPr/>
+      </p:nvGrpSpPr>
+      <p:grpSpPr>
+        <a:xfrm>
+          <a:off x="0" y="0"/>
+          <a:ext cx="0" cy="0"/>
+          <a:chOff x="0" y="0"/>
+          <a:chExt cx="0" cy="0"/>
+        </a:xfrm>
+      </p:grpSpPr>
+      <p:sp>
+        <p:nvSpPr>
+          <p:cNvPr id="2" name="Title"/>
+          <p:cNvSpPr txBox="1"/>
+          <p:nvPr/>
+        </p:nvSpPr>
+        <p:spPr>
+          <a:xfrm>
+            <a:off x="548640" y="320040"/>
+            <a:ext cx="11064240" cy="822960"/>
+          </a:xfrm>
+          <a:prstGeom prst="rect">
+            <a:avLst/>
+          </a:prstGeom>
+          <a:noFill/>
+          <a:ln/>
+        </p:spPr>
+        <p:txBody>
+          <a:bodyPr wrap="square" lIns="0" tIns="0" rIns="0" bIns="0" rtlCol="0" anchor="ctr"/>
+          <a:lstStyle/>
+          <a:p>
+            <a:pPr indent="0" marL="0">
+              <a:buNone/>
+            </a:pPr>
+            <a:r>
+              <a:rPr lang="en-US" sz="3400" b="1" dirty="0">
+                <a:solidFill>
+                  <a:srgbClr val="1E1B4B"/>
+                </a:solidFill>
+                <a:latin typeface="Cambria" pitchFamily="34" charset="0"/>
+                <a:ea typeface="Cambria" pitchFamily="34" charset="-122"/>
+                <a:cs typeface="Cambria" pitchFamily="34" charset="-120"/>
+              </a:rPr>
+              <a:t>ООП: экзамен и тема</a:t>
+            </a:r>
+            <a:endParaRPr lang="en-US" sz="3400" dirty="0"/>
+          </a:p>
+        </p:txBody>
+      </p:sp>
+      <p:sp>
+        <p:nvSpPr>
+          <p:cNvPr id="4" name="Shape 1"/>
+          <p:cNvSpPr/>
+          <p:nvPr/>
+        </p:nvSpPr>
+        <p:spPr>
+          <a:xfrm>
+            <a:off x="1222741" y="1207008"/>
+            <a:ext cx="9743470" cy="5084064"/>
+          </a:xfrm>
+          <a:prstGeom prst="rect">
+            <a:avLst/>
+          </a:prstGeom>
+          <a:solidFill>
+            <a:srgbClr val="FFFFFF"/>
+          </a:solidFill>
+          <a:ln w="9525">
+            <a:solidFill>
+              <a:srgbClr val="CBD5E1"/>
+            </a:solidFill>
+            <a:prstDash val="solid"/>
+          </a:ln>
+        </p:spPr>
+      </p:sp>
+      <p:pic>
+        <p:nvPicPr>
+          <p:cNvPr id="5" name="Image 0" descr="Скриншот программы: code_oop_left.png">    </p:cNvPr>
+          <p:cNvPicPr>
+            <a:picLocks noChangeAspect="1"/>
+          </p:cNvPicPr>
+          <p:nvPr/>
+        </p:nvPicPr>
+        <p:blipFill>
+          <a:blip r:embed="rId1"/>
+          <a:stretch>
+            <a:fillRect/>
+          </a:stretch>
+        </p:blipFill>
+        <p:spPr>
+          <a:xfrm>
+            <a:off x="1250173" y="1234440"/>
+            <a:ext cx="9688606" cy="5029200"/>
+          </a:xfrm>
+          <a:prstGeom prst="rect">
+            <a:avLst/>
+          </a:prstGeom>
+        </p:spPr>
+      </p:pic>
+      <p:sp>
+        <p:nvSpPr>
+          <p:cNvPr id="25" name="Slide Number Placeholder 0"/>
+          <p:cNvSpPr>
+            <a:spLocks noGrp="1"/>
+          </p:cNvSpPr>
+          <p:nvPr>
+            <p:ph type="sldNum" sz="quarter" idx="4294967295"/>
+          </p:nvPr>
+        </p:nvSpPr>
+        <p:spPr>
+          <a:xfrm>
+            <a:off x="10972800" y="6400800"/>
+            <a:ext cx="731520" cy="274320"/>
+          </a:xfrm>
+          <a:prstGeom prst="rect">
+            <a:avLst/>
+          </a:prstGeom>
+          <a:extLst>
+            <a:ext uri="{C572A759-6A51-4108-AA02-DFA0A04FC94B}">
+              <ma14:wrappingTextBoxFlag xmlns:ma14="http://schemas.microsoft.com/office/mac/drawingml/2011/main" val="0"/>
+            </a:ext>
+          </a:extLst>
+        </p:spPr>
+        <p:txBody>
+          <a:bodyPr/>
+          <a:lstStyle>
+            <a:lvl1pPr>
+              <a:defRPr sz="1000">
+                <a:solidFill>
+                  <a:srgbClr val="64748B"/>
+                </a:solidFill>
+                <a:latin typeface="Calibri"/>
+                <a:ea typeface="Calibri"/>
+                <a:cs typeface="Calibri"/>
+              </a:defRPr>
+            </a:lvl1pPr>
+          </a:lstStyle>
+          <a:p>
+            <a:pPr algn="r"/>
+            <a:fld id="{F7021451-1387-4CA6-816F-3879F97B5CBC}" type="slidenum">
+              <a:rPr b="0" lang="en-US"/>
+              <a:t>12</a:t>
+            </a:fld>
+            <a:endParaRPr lang="en-US"/>
+          </a:p>
+        </p:txBody>
+      </p:sp>
+    </p:spTree>
+  </p:cSld>
+  <p:clrMapOvr>
+    <a:masterClrMapping/>
+  </p:clrMapOvr>
+</p:sld>
+</file>
+
+<file path=ppt/slides/slide13.xml><?xml version="1.0" encoding="utf-8"?>
+<p:sld xmlns:a="http://schemas.openxmlformats.org/drawingml/2006/main" xmlns:r="http://schemas.openxmlformats.org/officeDocument/2006/relationships" xmlns:p="http://schemas.openxmlformats.org/presentationml/2006/main">
+  <p:cSld name="Slide 13">
+    <p:spTree>
+      <p:nvGrpSpPr>
+        <p:cNvPr id="1" name=""/>
+        <p:cNvGrpSpPr/>
+        <p:nvPr/>
+      </p:nvGrpSpPr>
+      <p:grpSpPr>
+        <a:xfrm>
+          <a:off x="0" y="0"/>
+          <a:ext cx="0" cy="0"/>
+          <a:chOff x="0" y="0"/>
+          <a:chExt cx="0" cy="0"/>
+        </a:xfrm>
+      </p:grpSpPr>
+      <p:sp>
+        <p:nvSpPr>
+          <p:cNvPr id="2" name="Title"/>
+          <p:cNvSpPr txBox="1"/>
+          <p:nvPr/>
+        </p:nvSpPr>
+        <p:spPr>
+          <a:xfrm>
+            <a:off x="548640" y="320040"/>
+            <a:ext cx="11064240" cy="822960"/>
+          </a:xfrm>
+          <a:prstGeom prst="rect">
+            <a:avLst/>
+          </a:prstGeom>
+          <a:noFill/>
+          <a:ln/>
+        </p:spPr>
+        <p:txBody>
+          <a:bodyPr wrap="square" lIns="0" tIns="0" rIns="0" bIns="0" rtlCol="0" anchor="ctr"/>
+          <a:lstStyle/>
+          <a:p>
+            <a:pPr indent="0" marL="0">
+              <a:buNone/>
+            </a:pPr>
+            <a:r>
+              <a:rPr lang="en-US" sz="3400" b="1" dirty="0">
+                <a:solidFill>
+                  <a:srgbClr val="1E1B4B"/>
+                </a:solidFill>
+                <a:latin typeface="Cambria" pitchFamily="34" charset="0"/>
+                <a:ea typeface="Cambria" pitchFamily="34" charset="-122"/>
+                <a:cs typeface="Cambria" pitchFamily="34" charset="-120"/>
+              </a:rPr>
+              <a:t>ООП: планировщик</a:t>
+            </a:r>
+            <a:endParaRPr lang="en-US" sz="3400" dirty="0"/>
+          </a:p>
+        </p:txBody>
+      </p:sp>
+      <p:sp>
+        <p:nvSpPr>
+          <p:cNvPr id="4" name="Shape 1"/>
+          <p:cNvSpPr/>
+          <p:nvPr/>
+        </p:nvSpPr>
+        <p:spPr>
+          <a:xfrm>
+            <a:off x="824618" y="1207008"/>
+            <a:ext cx="10539717" cy="5084064"/>
+          </a:xfrm>
+          <a:prstGeom prst="rect">
+            <a:avLst/>
+          </a:prstGeom>
+          <a:solidFill>
+            <a:srgbClr val="FFFFFF"/>
+          </a:solidFill>
+          <a:ln w="9525">
+            <a:solidFill>
+              <a:srgbClr val="CBD5E1"/>
+            </a:solidFill>
+            <a:prstDash val="solid"/>
+          </a:ln>
+        </p:spPr>
+      </p:sp>
+      <p:pic>
+        <p:nvPicPr>
+          <p:cNvPr id="5" name="Image 0" descr="Скриншот программы: code_oop_right.png">    </p:cNvPr>
+          <p:cNvPicPr>
+            <a:picLocks noChangeAspect="1"/>
+          </p:cNvPicPr>
+          <p:nvPr/>
+        </p:nvPicPr>
+        <p:blipFill>
+          <a:blip r:embed="rId1"/>
+          <a:stretch>
+            <a:fillRect/>
+          </a:stretch>
+        </p:blipFill>
+        <p:spPr>
+          <a:xfrm>
+            <a:off x="852050" y="1234440"/>
+            <a:ext cx="10484853" cy="5029200"/>
+          </a:xfrm>
+          <a:prstGeom prst="rect">
+            <a:avLst/>
+          </a:prstGeom>
+        </p:spPr>
+      </p:pic>
+      <p:sp>
+        <p:nvSpPr>
+          <p:cNvPr id="25" name="Slide Number Placeholder 0"/>
+          <p:cNvSpPr>
+            <a:spLocks noGrp="1"/>
+          </p:cNvSpPr>
+          <p:nvPr>
+            <p:ph type="sldNum" sz="quarter" idx="4294967295"/>
+          </p:nvPr>
+        </p:nvSpPr>
+        <p:spPr>
+          <a:xfrm>
+            <a:off x="10972800" y="6400800"/>
+            <a:ext cx="731520" cy="274320"/>
+          </a:xfrm>
+          <a:prstGeom prst="rect">
+            <a:avLst/>
+          </a:prstGeom>
+          <a:extLst>
+            <a:ext uri="{C572A759-6A51-4108-AA02-DFA0A04FC94B}">
+              <ma14:wrappingTextBoxFlag xmlns:ma14="http://schemas.microsoft.com/office/mac/drawingml/2011/main" val="0"/>
+            </a:ext>
+          </a:extLst>
+        </p:spPr>
+        <p:txBody>
+          <a:bodyPr/>
+          <a:lstStyle>
+            <a:lvl1pPr>
+              <a:defRPr sz="1000">
+                <a:solidFill>
+                  <a:srgbClr val="64748B"/>
+                </a:solidFill>
+                <a:latin typeface="Calibri"/>
+                <a:ea typeface="Calibri"/>
+                <a:cs typeface="Calibri"/>
+              </a:defRPr>
+            </a:lvl1pPr>
+          </a:lstStyle>
+          <a:p>
+            <a:pPr algn="r"/>
+            <a:fld id="{F7021451-1387-4CA6-816F-3879F97B5CBC}" type="slidenum">
+              <a:rPr b="0" lang="en-US"/>
+              <a:t>13</a:t>
+            </a:fld>
+            <a:endParaRPr lang="en-US"/>
+          </a:p>
+        </p:txBody>
+      </p:sp>
+    </p:spTree>
+  </p:cSld>
+  <p:clrMapOvr>
+    <a:masterClrMapping/>
+  </p:clrMapOvr>
+</p:sld>
+</file>
+
+<file path=ppt/slides/slide14.xml><?xml version="1.0" encoding="utf-8"?>
+<p:sld xmlns:a="http://schemas.openxmlformats.org/drawingml/2006/main" xmlns:r="http://schemas.openxmlformats.org/officeDocument/2006/relationships" xmlns:p="http://schemas.openxmlformats.org/presentationml/2006/main">
+  <p:cSld name="Slide 14">
+    <p:spTree>
+      <p:nvGrpSpPr>
+        <p:cNvPr id="1" name=""/>
+        <p:cNvGrpSpPr/>
+        <p:nvPr/>
+      </p:nvGrpSpPr>
+      <p:grpSpPr>
+        <a:xfrm>
+          <a:off x="0" y="0"/>
+          <a:ext cx="0" cy="0"/>
+          <a:chOff x="0" y="0"/>
+          <a:chExt cx="0" cy="0"/>
+        </a:xfrm>
+      </p:grpSpPr>
+      <p:sp>
+        <p:nvSpPr>
+          <p:cNvPr id="2" name="Title"/>
+          <p:cNvSpPr txBox="1"/>
+          <p:nvPr/>
+        </p:nvSpPr>
+        <p:spPr>
+          <a:xfrm>
+            <a:off x="548640" y="320040"/>
+            <a:ext cx="11064240" cy="822960"/>
+          </a:xfrm>
+          <a:prstGeom prst="rect">
+            <a:avLst/>
+          </a:prstGeom>
+          <a:noFill/>
+          <a:ln/>
+        </p:spPr>
+        <p:txBody>
+          <a:bodyPr wrap="square" lIns="0" tIns="0" rIns="0" bIns="0" rtlCol="0" anchor="ctr"/>
+          <a:lstStyle/>
+          <a:p>
+            <a:pPr indent="0" marL="0">
+              <a:buNone/>
+            </a:pPr>
+            <a:r>
+              <a:rPr lang="en-US" sz="3400" b="1" dirty="0">
+                <a:solidFill>
+                  <a:srgbClr val="1E1B4B"/>
+                </a:solidFill>
+                <a:latin typeface="Cambria" pitchFamily="34" charset="0"/>
+                <a:ea typeface="Cambria" pitchFamily="34" charset="-122"/>
+                <a:cs typeface="Cambria" pitchFamily="34" charset="-120"/>
+              </a:rPr>
+              <a:t>Календарь нагрузки</a:t>
+            </a:r>
+            <a:endParaRPr lang="en-US" sz="3400" dirty="0"/>
+          </a:p>
+        </p:txBody>
+      </p:sp>
+      <p:sp>
+        <p:nvSpPr>
+          <p:cNvPr id="4" name="Shape 1"/>
+          <p:cNvSpPr/>
+          <p:nvPr/>
+        </p:nvSpPr>
+        <p:spPr>
+          <a:xfrm>
+            <a:off x="883893" y="1252728"/>
+            <a:ext cx="6919015" cy="4992624"/>
+          </a:xfrm>
+          <a:prstGeom prst="rect">
+            <a:avLst/>
+          </a:prstGeom>
+          <a:solidFill>
+            <a:srgbClr val="FFFFFF"/>
+          </a:solidFill>
+          <a:ln w="9525">
+            <a:solidFill>
+              <a:srgbClr val="CBD5E1"/>
+            </a:solidFill>
+            <a:prstDash val="solid"/>
+          </a:ln>
+        </p:spPr>
+      </p:sp>
+      <p:pic>
+        <p:nvPicPr>
+          <p:cNvPr id="5" name="Image 0" descr="Скриншот программы: 01_calendar.png">    </p:cNvPr>
+          <p:cNvPicPr>
+            <a:picLocks noChangeAspect="1"/>
+          </p:cNvPicPr>
+          <p:nvPr/>
+        </p:nvPicPr>
+        <p:blipFill>
+          <a:blip r:embed="rId1"/>
+          <a:stretch>
+            <a:fillRect/>
+          </a:stretch>
+        </p:blipFill>
+        <p:spPr>
+          <a:xfrm>
+            <a:off x="911325" y="1280160"/>
+            <a:ext cx="6864151" cy="4937760"/>
+          </a:xfrm>
+          <a:prstGeom prst="rect">
+            <a:avLst/>
+          </a:prstGeom>
+        </p:spPr>
+      </p:pic>
+      <p:sp>
+        <p:nvSpPr>
+          <p:cNvPr id="6" name="Shape 2"/>
+          <p:cNvSpPr/>
+          <p:nvPr/>
+        </p:nvSpPr>
+        <p:spPr>
+          <a:xfrm>
+            <a:off x="8412480" y="1280160"/>
+            <a:ext cx="3227832" cy="4937760"/>
+          </a:xfrm>
+          <a:prstGeom prst="roundRect">
+            <a:avLst>
+              <a:gd name="adj" fmla="val 3399"/>
+            </a:avLst>
+          </a:prstGeom>
+          <a:solidFill>
+            <a:srgbClr val="FFFFFF"/>
+          </a:solidFill>
+          <a:ln w="9525">
+            <a:solidFill>
+              <a:srgbClr val="DBE3EE"/>
+            </a:solidFill>
+            <a:prstDash val="solid"/>
+          </a:ln>
+          <a:effectLst>
+            <a:outerShdw sx="100000" sy="100000" kx="0" ky="0" algn="bl" rotWithShape="0" blurRad="76200" dist="25400" dir="5400000">
+              <a:srgbClr val="000000">
+                <a:alpha val="8000"/>
+              </a:srgbClr>
+            </a:outerShdw>
+          </a:effectLst>
+        </p:spPr>
+      </p:sp>
+      <p:sp>
+        <p:nvSpPr>
+          <p:cNvPr id="7" name="Text 3"/>
+          <p:cNvSpPr txBox="1"/>
+          <p:nvPr/>
+        </p:nvSpPr>
+        <p:spPr>
+          <a:xfrm>
+            <a:off x="8641080" y="1508760"/>
+            <a:ext cx="2834640" cy="4480560"/>
+          </a:xfrm>
+          <a:prstGeom prst="rect">
+            <a:avLst/>
+          </a:prstGeom>
+          <a:noFill/>
+          <a:ln/>
+        </p:spPr>
+        <p:txBody>
+          <a:bodyPr wrap="square" lIns="0" tIns="0" rIns="0" bIns="0" rtlCol="0" anchor="t"/>
+          <a:lstStyle/>
+          <a:p>
+            <a:pPr marL="228600" indent="-228600">
+              <a:spcAft>
+                <a:spcPts val="800"/>
+              </a:spcAft>
+              <a:buSzPct val="100000"/>
+              <a:buChar char="•"/>
+            </a:pPr>
+            <a:r>
+              <a:rPr lang="en-US" sz="1600" dirty="0">
+                <a:solidFill>
+                  <a:srgbClr val="0F172A"/>
+                </a:solidFill>
+                <a:latin typeface="Calibri" pitchFamily="34" charset="0"/>
+                <a:ea typeface="Calibri" pitchFamily="34" charset="-122"/>
+                <a:cs typeface="Calibri" pitchFamily="34" charset="-120"/>
+              </a:rPr>
+              <a:t>Цвет — загрузка дня</a:t>
+            </a:r>
+            <a:endParaRPr lang="en-US" sz="1600" dirty="0"/>
+          </a:p>
+          <a:p>
+            <a:pPr marL="228600" indent="-228600">
+              <a:spcAft>
+                <a:spcPts val="800"/>
+              </a:spcAft>
+              <a:buSzPct val="100000"/>
+              <a:buChar char="•"/>
+            </a:pPr>
+            <a:r>
+              <a:rPr lang="en-US" sz="1600" dirty="0">
+                <a:solidFill>
+                  <a:srgbClr val="0F172A"/>
+                </a:solidFill>
+                <a:latin typeface="Calibri" pitchFamily="34" charset="0"/>
+                <a:ea typeface="Calibri" pitchFamily="34" charset="-122"/>
+                <a:cs typeface="Calibri" pitchFamily="34" charset="-120"/>
+              </a:rPr>
+              <a:t>Красный — экзамен, фиолетовый — контрольная</a:t>
+            </a:r>
+            <a:endParaRPr lang="en-US" sz="1600" dirty="0"/>
+          </a:p>
+          <a:p>
+            <a:pPr marL="228600" indent="-228600">
+              <a:spcAft>
+                <a:spcPts val="800"/>
+              </a:spcAft>
+              <a:buSzPct val="100000"/>
+              <a:buChar char="•"/>
+            </a:pPr>
+            <a:r>
+              <a:rPr lang="en-US" sz="1600" dirty="0">
+                <a:solidFill>
+                  <a:srgbClr val="0F172A"/>
+                </a:solidFill>
+                <a:latin typeface="Calibri" pitchFamily="34" charset="0"/>
+                <a:ea typeface="Calibri" pitchFamily="34" charset="-122"/>
+                <a:cs typeface="Calibri" pitchFamily="34" charset="-120"/>
+              </a:rPr>
+              <a:t>Клик по дню — список тем и часов</a:t>
+            </a:r>
+            <a:endParaRPr lang="en-US" sz="1600" dirty="0"/>
+          </a:p>
+          <a:p>
+            <a:pPr marL="228600" indent="-228600">
+              <a:spcAft>
+                <a:spcPts val="800"/>
+              </a:spcAft>
+              <a:buSzPct val="100000"/>
+              <a:buChar char="•"/>
+            </a:pPr>
+            <a:r>
+              <a:rPr lang="en-US" sz="1600" dirty="0">
+                <a:solidFill>
+                  <a:srgbClr val="0F172A"/>
+                </a:solidFill>
+                <a:latin typeface="Calibri" pitchFamily="34" charset="0"/>
+                <a:ea typeface="Calibri" pitchFamily="34" charset="-122"/>
+                <a:cs typeface="Calibri" pitchFamily="34" charset="-120"/>
+              </a:rPr>
+              <a:t>Листание месяцев</a:t>
+            </a:r>
+            <a:endParaRPr lang="en-US" sz="1600" dirty="0"/>
+          </a:p>
+        </p:txBody>
+      </p:sp>
+      <p:sp>
+        <p:nvSpPr>
+          <p:cNvPr id="25" name="Slide Number Placeholder 0"/>
+          <p:cNvSpPr>
+            <a:spLocks noGrp="1"/>
+          </p:cNvSpPr>
+          <p:nvPr>
+            <p:ph type="sldNum" sz="quarter" idx="4294967295"/>
+          </p:nvPr>
+        </p:nvSpPr>
+        <p:spPr>
+          <a:xfrm>
+            <a:off x="10972800" y="6400800"/>
+            <a:ext cx="731520" cy="274320"/>
+          </a:xfrm>
+          <a:prstGeom prst="rect">
+            <a:avLst/>
+          </a:prstGeom>
+          <a:extLst>
+            <a:ext uri="{C572A759-6A51-4108-AA02-DFA0A04FC94B}">
+              <ma14:wrappingTextBoxFlag xmlns:ma14="http://schemas.microsoft.com/office/mac/drawingml/2011/main" val="0"/>
+            </a:ext>
+          </a:extLst>
+        </p:spPr>
+        <p:txBody>
+          <a:bodyPr/>
+          <a:lstStyle>
+            <a:lvl1pPr>
+              <a:defRPr sz="1000">
+                <a:solidFill>
+                  <a:srgbClr val="64748B"/>
+                </a:solidFill>
+                <a:latin typeface="Calibri"/>
+                <a:ea typeface="Calibri"/>
+                <a:cs typeface="Calibri"/>
+              </a:defRPr>
+            </a:lvl1pPr>
+          </a:lstStyle>
+          <a:p>
+            <a:pPr algn="r"/>
+            <a:fld id="{F7021451-1387-4CA6-816F-3879F97B5CBC}" type="slidenum">
+              <a:rPr b="0" lang="en-US"/>
+              <a:t>14</a:t>
+            </a:fld>
+            <a:endParaRPr lang="en-US"/>
+          </a:p>
+        </p:txBody>
+      </p:sp>
+    </p:spTree>
+  </p:cSld>
+  <p:clrMapOvr>
+    <a:masterClrMapping/>
+  </p:clrMapOvr>
+</p:sld>
+</file>
+
+<file path=ppt/slides/slide15.xml><?xml version="1.0" encoding="utf-8"?>
+<p:sld xmlns:a="http://schemas.openxmlformats.org/drawingml/2006/main" xmlns:r="http://schemas.openxmlformats.org/officeDocument/2006/relationships" xmlns:p="http://schemas.openxmlformats.org/presentationml/2006/main">
+  <p:cSld name="Slide 15">
+    <p:spTree>
+      <p:nvGrpSpPr>
+        <p:cNvPr id="1" name=""/>
+        <p:cNvGrpSpPr/>
+        <p:nvPr/>
+      </p:nvGrpSpPr>
+      <p:grpSpPr>
+        <a:xfrm>
+          <a:off x="0" y="0"/>
+          <a:ext cx="0" cy="0"/>
+          <a:chOff x="0" y="0"/>
+          <a:chExt cx="0" cy="0"/>
+        </a:xfrm>
+      </p:grpSpPr>
+      <p:sp>
+        <p:nvSpPr>
+          <p:cNvPr id="2" name="Title"/>
+          <p:cNvSpPr txBox="1"/>
+          <p:nvPr/>
+        </p:nvSpPr>
+        <p:spPr>
+          <a:xfrm>
+            <a:off x="548640" y="320040"/>
+            <a:ext cx="11064240" cy="822960"/>
+          </a:xfrm>
+          <a:prstGeom prst="rect">
+            <a:avLst/>
+          </a:prstGeom>
+          <a:noFill/>
+          <a:ln/>
+        </p:spPr>
+        <p:txBody>
+          <a:bodyPr wrap="square" lIns="0" tIns="0" rIns="0" bIns="0" rtlCol="0" anchor="ctr"/>
+          <a:lstStyle/>
+          <a:p>
+            <a:pPr indent="0" marL="0">
+              <a:buNone/>
+            </a:pPr>
+            <a:r>
+              <a:rPr lang="en-US" sz="3400" b="1" dirty="0">
+                <a:solidFill>
+                  <a:srgbClr val="1E1B4B"/>
+                </a:solidFill>
+                <a:latin typeface="Cambria" pitchFamily="34" charset="0"/>
+                <a:ea typeface="Cambria" pitchFamily="34" charset="-122"/>
+                <a:cs typeface="Cambria" pitchFamily="34" charset="-120"/>
+              </a:rPr>
+              <a:t>Диаграмма Ганта</a:t>
+            </a:r>
+            <a:endParaRPr lang="en-US" sz="3400" dirty="0"/>
+          </a:p>
+        </p:txBody>
+      </p:sp>
+      <p:sp>
+        <p:nvSpPr>
+          <p:cNvPr id="4" name="Shape 1"/>
+          <p:cNvSpPr/>
+          <p:nvPr/>
+        </p:nvSpPr>
+        <p:spPr>
+          <a:xfrm>
+            <a:off x="883893" y="1252728"/>
+            <a:ext cx="6919015" cy="4992624"/>
+          </a:xfrm>
+          <a:prstGeom prst="rect">
+            <a:avLst/>
+          </a:prstGeom>
+          <a:solidFill>
+            <a:srgbClr val="FFFFFF"/>
+          </a:solidFill>
+          <a:ln w="9525">
+            <a:solidFill>
+              <a:srgbClr val="CBD5E1"/>
+            </a:solidFill>
+            <a:prstDash val="solid"/>
+          </a:ln>
+        </p:spPr>
+      </p:sp>
+      <p:pic>
+        <p:nvPicPr>
+          <p:cNvPr id="5" name="Image 0" descr="Скриншот программы: 02_gantt.png">    </p:cNvPr>
+          <p:cNvPicPr>
+            <a:picLocks noChangeAspect="1"/>
+          </p:cNvPicPr>
+          <p:nvPr/>
+        </p:nvPicPr>
+        <p:blipFill>
+          <a:blip r:embed="rId1"/>
+          <a:stretch>
+            <a:fillRect/>
+          </a:stretch>
+        </p:blipFill>
+        <p:spPr>
+          <a:xfrm>
+            <a:off x="911325" y="1280160"/>
+            <a:ext cx="6864151" cy="4937760"/>
+          </a:xfrm>
+          <a:prstGeom prst="rect">
+            <a:avLst/>
+          </a:prstGeom>
+        </p:spPr>
+      </p:pic>
+      <p:sp>
+        <p:nvSpPr>
+          <p:cNvPr id="6" name="Shape 2"/>
+          <p:cNvSpPr/>
+          <p:nvPr/>
+        </p:nvSpPr>
+        <p:spPr>
+          <a:xfrm>
+            <a:off x="8412480" y="1280160"/>
+            <a:ext cx="3227832" cy="4937760"/>
+          </a:xfrm>
+          <a:prstGeom prst="roundRect">
+            <a:avLst>
+              <a:gd name="adj" fmla="val 3399"/>
+            </a:avLst>
+          </a:prstGeom>
+          <a:solidFill>
+            <a:srgbClr val="FFFFFF"/>
+          </a:solidFill>
+          <a:ln w="9525">
+            <a:solidFill>
+              <a:srgbClr val="DBE3EE"/>
+            </a:solidFill>
+            <a:prstDash val="solid"/>
+          </a:ln>
+          <a:effectLst>
+            <a:outerShdw sx="100000" sy="100000" kx="0" ky="0" algn="bl" rotWithShape="0" blurRad="76200" dist="25400" dir="5400000">
+              <a:srgbClr val="000000">
+                <a:alpha val="8000"/>
+              </a:srgbClr>
+            </a:outerShdw>
+          </a:effectLst>
+        </p:spPr>
+      </p:sp>
+      <p:sp>
+        <p:nvSpPr>
+          <p:cNvPr id="7" name="Text 3"/>
+          <p:cNvSpPr txBox="1"/>
+          <p:nvPr/>
+        </p:nvSpPr>
+        <p:spPr>
+          <a:xfrm>
+            <a:off x="8641080" y="1508760"/>
+            <a:ext cx="2834640" cy="4480560"/>
+          </a:xfrm>
+          <a:prstGeom prst="rect">
+            <a:avLst/>
+          </a:prstGeom>
+          <a:noFill/>
+          <a:ln/>
+        </p:spPr>
+        <p:txBody>
+          <a:bodyPr wrap="square" lIns="0" tIns="0" rIns="0" bIns="0" rtlCol="0" anchor="t"/>
+          <a:lstStyle/>
+          <a:p>
+            <a:pPr marL="228600" indent="-228600">
+              <a:spcAft>
+                <a:spcPts val="800"/>
+              </a:spcAft>
+              <a:buSzPct val="100000"/>
+              <a:buChar char="•"/>
+            </a:pPr>
+            <a:r>
+              <a:rPr lang="en-US" sz="1600" dirty="0">
+                <a:solidFill>
+                  <a:srgbClr val="0F172A"/>
+                </a:solidFill>
+                <a:latin typeface="Calibri" pitchFamily="34" charset="0"/>
+                <a:ea typeface="Calibri" pitchFamily="34" charset="-122"/>
+                <a:cs typeface="Calibri" pitchFamily="34" charset="-120"/>
+              </a:rPr>
+              <a:t>Полоска — период занятий по теме</a:t>
+            </a:r>
+            <a:endParaRPr lang="en-US" sz="1600" dirty="0"/>
+          </a:p>
+          <a:p>
+            <a:pPr marL="228600" indent="-228600">
+              <a:spcAft>
+                <a:spcPts val="800"/>
+              </a:spcAft>
+              <a:buSzPct val="100000"/>
+              <a:buChar char="•"/>
+            </a:pPr>
+            <a:r>
+              <a:rPr lang="en-US" sz="1600" dirty="0">
+                <a:solidFill>
+                  <a:srgbClr val="0F172A"/>
+                </a:solidFill>
+                <a:latin typeface="Calibri" pitchFamily="34" charset="0"/>
+                <a:ea typeface="Calibri" pitchFamily="34" charset="-122"/>
+                <a:cs typeface="Calibri" pitchFamily="34" charset="-120"/>
+              </a:rPr>
+              <a:t>Линии — экзамены, контрольные и «сегодня»</a:t>
+            </a:r>
+            <a:endParaRPr lang="en-US" sz="1600" dirty="0"/>
+          </a:p>
+          <a:p>
+            <a:pPr marL="228600" indent="-228600">
+              <a:spcAft>
+                <a:spcPts val="800"/>
+              </a:spcAft>
+              <a:buSzPct val="100000"/>
+              <a:buChar char="•"/>
+            </a:pPr>
+            <a:r>
+              <a:rPr lang="en-US" sz="1600" dirty="0">
+                <a:solidFill>
+                  <a:srgbClr val="0F172A"/>
+                </a:solidFill>
+                <a:latin typeface="Calibri" pitchFamily="34" charset="0"/>
+                <a:ea typeface="Calibri" pitchFamily="34" charset="-122"/>
+                <a:cs typeface="Calibri" pitchFamily="34" charset="-120"/>
+              </a:rPr>
+              <a:t>Красная строка — тема не помещается</a:t>
+            </a:r>
+            <a:endParaRPr lang="en-US" sz="1600" dirty="0"/>
+          </a:p>
+          <a:p>
+            <a:pPr marL="228600" indent="-228600">
+              <a:spcAft>
+                <a:spcPts val="800"/>
+              </a:spcAft>
+              <a:buSzPct val="100000"/>
+              <a:buChar char="•"/>
+            </a:pPr>
+            <a:r>
+              <a:rPr lang="en-US" sz="1600" dirty="0">
+                <a:solidFill>
+                  <a:srgbClr val="0F172A"/>
+                </a:solidFill>
+                <a:latin typeface="Calibri" pitchFamily="34" charset="0"/>
+                <a:ea typeface="Calibri" pitchFamily="34" charset="-122"/>
+                <a:cs typeface="Calibri" pitchFamily="34" charset="-120"/>
+              </a:rPr>
+              <a:t>Серая — тема уже выполнена</a:t>
+            </a:r>
+            <a:endParaRPr lang="en-US" sz="1600" dirty="0"/>
+          </a:p>
+        </p:txBody>
+      </p:sp>
+      <p:sp>
+        <p:nvSpPr>
+          <p:cNvPr id="25" name="Slide Number Placeholder 0"/>
+          <p:cNvSpPr>
+            <a:spLocks noGrp="1"/>
+          </p:cNvSpPr>
+          <p:nvPr>
+            <p:ph type="sldNum" sz="quarter" idx="4294967295"/>
+          </p:nvPr>
+        </p:nvSpPr>
+        <p:spPr>
+          <a:xfrm>
+            <a:off x="10972800" y="6400800"/>
+            <a:ext cx="731520" cy="274320"/>
+          </a:xfrm>
+          <a:prstGeom prst="rect">
+            <a:avLst/>
+          </a:prstGeom>
+          <a:extLst>
+            <a:ext uri="{C572A759-6A51-4108-AA02-DFA0A04FC94B}">
+              <ma14:wrappingTextBoxFlag xmlns:ma14="http://schemas.microsoft.com/office/mac/drawingml/2011/main" val="0"/>
+            </a:ext>
+          </a:extLst>
+        </p:spPr>
+        <p:txBody>
+          <a:bodyPr/>
+          <a:lstStyle>
+            <a:lvl1pPr>
+              <a:defRPr sz="1000">
+                <a:solidFill>
+                  <a:srgbClr val="64748B"/>
+                </a:solidFill>
+                <a:latin typeface="Calibri"/>
+                <a:ea typeface="Calibri"/>
+                <a:cs typeface="Calibri"/>
+              </a:defRPr>
+            </a:lvl1pPr>
+          </a:lstStyle>
+          <a:p>
+            <a:pPr algn="r"/>
+            <a:fld id="{F7021451-1387-4CA6-816F-3879F97B5CBC}" type="slidenum">
+              <a:rPr b="0" lang="en-US"/>
+              <a:t>15</a:t>
+            </a:fld>
+            <a:endParaRPr lang="en-US"/>
+          </a:p>
+        </p:txBody>
+      </p:sp>
+    </p:spTree>
+  </p:cSld>
+  <p:clrMapOvr>
+    <a:masterClrMapping/>
+  </p:clrMapOvr>
+</p:sld>
+</file>
+
+<file path=ppt/slides/slide16.xml><?xml version="1.0" encoding="utf-8"?>
+<p:sld xmlns:a="http://schemas.openxmlformats.org/drawingml/2006/main" xmlns:r="http://schemas.openxmlformats.org/officeDocument/2006/relationships" xmlns:p="http://schemas.openxmlformats.org/presentationml/2006/main">
+  <p:cSld name="Slide 16">
+    <p:spTree>
+      <p:nvGrpSpPr>
+        <p:cNvPr id="1" name=""/>
+        <p:cNvGrpSpPr/>
+        <p:nvPr/>
+      </p:nvGrpSpPr>
+      <p:grpSpPr>
+        <a:xfrm>
+          <a:off x="0" y="0"/>
+          <a:ext cx="0" cy="0"/>
+          <a:chOff x="0" y="0"/>
+          <a:chExt cx="0" cy="0"/>
+        </a:xfrm>
+      </p:grpSpPr>
+      <p:sp>
+        <p:nvSpPr>
+          <p:cNvPr id="2" name="Title"/>
+          <p:cNvSpPr txBox="1"/>
+          <p:nvPr/>
+        </p:nvSpPr>
+        <p:spPr>
+          <a:xfrm>
+            <a:off x="548640" y="320040"/>
+            <a:ext cx="11064240" cy="822960"/>
+          </a:xfrm>
+          <a:prstGeom prst="rect">
+            <a:avLst/>
+          </a:prstGeom>
+          <a:noFill/>
+          <a:ln/>
+        </p:spPr>
+        <p:txBody>
+          <a:bodyPr wrap="square" lIns="0" tIns="0" rIns="0" bIns="0" rtlCol="0" anchor="ctr"/>
+          <a:lstStyle/>
+          <a:p>
+            <a:pPr indent="0" marL="0">
+              <a:buNone/>
+            </a:pPr>
+            <a:r>
+              <a:rPr lang="en-US" sz="3400" b="1" dirty="0">
+                <a:solidFill>
+                  <a:srgbClr val="1E1B4B"/>
+                </a:solidFill>
+                <a:latin typeface="Cambria" pitchFamily="34" charset="0"/>
+                <a:ea typeface="Cambria" pitchFamily="34" charset="-122"/>
+                <a:cs typeface="Cambria" pitchFamily="34" charset="-120"/>
+              </a:rPr>
+              <a:t>Работа программы по шагам</a:t>
+            </a:r>
+            <a:endParaRPr lang="en-US" sz="3400" dirty="0"/>
+          </a:p>
+        </p:txBody>
+      </p:sp>
+      <p:sp>
+        <p:nvSpPr>
+          <p:cNvPr id="4" name="Shape 1"/>
+          <p:cNvSpPr/>
+          <p:nvPr/>
+        </p:nvSpPr>
+        <p:spPr>
+          <a:xfrm>
+            <a:off x="523566" y="1298448"/>
+            <a:ext cx="3296268" cy="2386584"/>
+          </a:xfrm>
+          <a:prstGeom prst="rect">
+            <a:avLst/>
+          </a:prstGeom>
+          <a:solidFill>
+            <a:srgbClr val="FFFFFF"/>
+          </a:solidFill>
+          <a:ln w="9525">
+            <a:solidFill>
+              <a:srgbClr val="CBD5E1"/>
+            </a:solidFill>
+            <a:prstDash val="solid"/>
+          </a:ln>
+        </p:spPr>
+      </p:sp>
+      <p:pic>
+        <p:nvPicPr>
+          <p:cNvPr id="5" name="Image 0" descr="Скриншот программы: s1_empty.png">    </p:cNvPr>
+          <p:cNvPicPr>
+            <a:picLocks noChangeAspect="1"/>
+          </p:cNvPicPr>
+          <p:nvPr/>
+        </p:nvPicPr>
+        <p:blipFill>
+          <a:blip r:embed="rId1"/>
+          <a:stretch>
+            <a:fillRect/>
+          </a:stretch>
+        </p:blipFill>
+        <p:spPr>
+          <a:xfrm>
+            <a:off x="550998" y="1325880"/>
+            <a:ext cx="3241404" cy="2331720"/>
+          </a:xfrm>
+          <a:prstGeom prst="rect">
+            <a:avLst/>
+          </a:prstGeom>
+        </p:spPr>
+      </p:pic>
+      <p:sp>
+        <p:nvSpPr>
+          <p:cNvPr id="6" name="Shape 2"/>
+          <p:cNvSpPr/>
+          <p:nvPr/>
+        </p:nvSpPr>
+        <p:spPr>
+          <a:xfrm>
+            <a:off x="3977640" y="1371600"/>
+            <a:ext cx="457200" cy="457200"/>
+          </a:xfrm>
+          <a:prstGeom prst="ellipse">
+            <a:avLst/>
+          </a:prstGeom>
+          <a:solidFill>
+            <a:srgbClr val="4F46E5"/>
+          </a:solidFill>
+          <a:ln w="12700">
+            <a:solidFill>
+              <a:srgbClr val="4F46E5"/>
+            </a:solidFill>
+            <a:prstDash val="solid"/>
+          </a:ln>
+        </p:spPr>
+      </p:sp>
+      <p:sp>
+        <p:nvSpPr>
+          <p:cNvPr id="7" name="Text 3"/>
+          <p:cNvSpPr txBox="1"/>
+          <p:nvPr/>
+        </p:nvSpPr>
+        <p:spPr>
+          <a:xfrm>
+            <a:off x="3977640" y="1371600"/>
+            <a:ext cx="457200" cy="457200"/>
+          </a:xfrm>
+          <a:prstGeom prst="rect">
+            <a:avLst/>
+          </a:prstGeom>
+          <a:noFill/>
+          <a:ln/>
+        </p:spPr>
+        <p:txBody>
+          <a:bodyPr wrap="square" lIns="0" tIns="0" rIns="0" bIns="0" rtlCol="0" anchor="ctr"/>
+          <a:lstStyle/>
+          <a:p>
+            <a:pPr algn="ctr" indent="0" marL="0">
+              <a:buNone/>
+            </a:pPr>
+            <a:r>
+              <a:rPr lang="en-US" sz="1600" b="1" dirty="0">
+                <a:solidFill>
+                  <a:srgbClr val="FFFFFF"/>
+                </a:solidFill>
+                <a:latin typeface="Calibri" pitchFamily="34" charset="0"/>
+                <a:ea typeface="Calibri" pitchFamily="34" charset="-122"/>
+                <a:cs typeface="Calibri" pitchFamily="34" charset="-120"/>
+              </a:rPr>
+              <a:t>1</a:t>
+            </a:r>
+            <a:endParaRPr lang="en-US" sz="1600" dirty="0"/>
+          </a:p>
+        </p:txBody>
+      </p:sp>
+      <p:sp>
+        <p:nvSpPr>
+          <p:cNvPr id="8" name="Text 4"/>
+          <p:cNvSpPr txBox="1"/>
+          <p:nvPr/>
+        </p:nvSpPr>
+        <p:spPr>
+          <a:xfrm>
+            <a:off x="4526280" y="1371600"/>
+            <a:ext cx="1554480" cy="457200"/>
+          </a:xfrm>
+          <a:prstGeom prst="rect">
+            <a:avLst/>
+          </a:prstGeom>
+          <a:noFill/>
+          <a:ln/>
+        </p:spPr>
+        <p:txBody>
+          <a:bodyPr wrap="square" lIns="0" tIns="0" rIns="0" bIns="0" rtlCol="0" anchor="ctr"/>
+          <a:lstStyle/>
+          <a:p>
+            <a:pPr indent="0" marL="0">
+              <a:buNone/>
+            </a:pPr>
+            <a:r>
+              <a:rPr lang="en-US" sz="1600" b="1" dirty="0">
+                <a:solidFill>
+                  <a:srgbClr val="1E1B4B"/>
+                </a:solidFill>
+                <a:latin typeface="Cambria" pitchFamily="34" charset="0"/>
+                <a:ea typeface="Cambria" pitchFamily="34" charset="-122"/>
+                <a:cs typeface="Cambria" pitchFamily="34" charset="-120"/>
+              </a:rPr>
+              <a:t>Старт</a:t>
+            </a:r>
+            <a:endParaRPr lang="en-US" sz="1600" dirty="0"/>
+          </a:p>
+        </p:txBody>
+      </p:sp>
+      <p:sp>
+        <p:nvSpPr>
+          <p:cNvPr id="9" name="Text 5"/>
+          <p:cNvSpPr txBox="1"/>
+          <p:nvPr/>
+        </p:nvSpPr>
+        <p:spPr>
+          <a:xfrm>
+            <a:off x="3977640" y="1965960"/>
+            <a:ext cx="2103120" cy="1645920"/>
+          </a:xfrm>
+          <a:prstGeom prst="rect">
+            <a:avLst/>
+          </a:prstGeom>
+          <a:noFill/>
+          <a:ln/>
+        </p:spPr>
+        <p:txBody>
+          <a:bodyPr wrap="square" lIns="0" tIns="0" rIns="0" bIns="0" rtlCol="0" anchor="t"/>
+          <a:lstStyle/>
+          <a:p>
+            <a:pPr indent="0" marL="0">
+              <a:buNone/>
+            </a:pPr>
+            <a:r>
+              <a:rPr lang="en-US" sz="1400" dirty="0">
+                <a:solidFill>
+                  <a:srgbClr val="0F172A"/>
+                </a:solidFill>
+                <a:latin typeface="Calibri" pitchFamily="34" charset="0"/>
+                <a:ea typeface="Calibri" pitchFamily="34" charset="-122"/>
+                <a:cs typeface="Calibri" pitchFamily="34" charset="-120"/>
+              </a:rPr>
+              <a:t>Окно пустое, в полях подсказки. Предмет и тему можно выбрать из списка.</a:t>
+            </a:r>
+            <a:endParaRPr lang="en-US" sz="1400" dirty="0"/>
+          </a:p>
+        </p:txBody>
+      </p:sp>
+      <p:sp>
+        <p:nvSpPr>
+          <p:cNvPr id="10" name="Shape 6"/>
+          <p:cNvSpPr/>
+          <p:nvPr/>
+        </p:nvSpPr>
+        <p:spPr>
+          <a:xfrm>
+            <a:off x="6261197" y="1298448"/>
+            <a:ext cx="3159565" cy="2386584"/>
+          </a:xfrm>
+          <a:prstGeom prst="rect">
+            <a:avLst/>
+          </a:prstGeom>
+          <a:solidFill>
+            <a:srgbClr val="FFFFFF"/>
+          </a:solidFill>
+          <a:ln w="9525">
+            <a:solidFill>
+              <a:srgbClr val="CBD5E1"/>
+            </a:solidFill>
+            <a:prstDash val="solid"/>
+          </a:ln>
+        </p:spPr>
+      </p:sp>
+      <p:pic>
+        <p:nvPicPr>
+          <p:cNvPr id="11" name="Image 1" descr="Скриншот программы: 03_dialog.png">    </p:cNvPr>
+          <p:cNvPicPr>
+            <a:picLocks noChangeAspect="1"/>
+          </p:cNvPicPr>
+          <p:nvPr/>
+        </p:nvPicPr>
+        <p:blipFill>
+          <a:blip r:embed="rId2"/>
+          <a:stretch>
+            <a:fillRect/>
+          </a:stretch>
+        </p:blipFill>
+        <p:spPr>
+          <a:xfrm>
+            <a:off x="6288629" y="1325880"/>
+            <a:ext cx="3104701" cy="2331720"/>
+          </a:xfrm>
+          <a:prstGeom prst="rect">
+            <a:avLst/>
+          </a:prstGeom>
+        </p:spPr>
+      </p:pic>
+      <p:sp>
+        <p:nvSpPr>
+          <p:cNvPr id="12" name="Shape 7"/>
+          <p:cNvSpPr/>
+          <p:nvPr/>
+        </p:nvSpPr>
+        <p:spPr>
+          <a:xfrm>
+            <a:off x="9646920" y="1371600"/>
+            <a:ext cx="457200" cy="457200"/>
+          </a:xfrm>
+          <a:prstGeom prst="ellipse">
+            <a:avLst/>
+          </a:prstGeom>
+          <a:solidFill>
+            <a:srgbClr val="4F46E5"/>
+          </a:solidFill>
+          <a:ln w="12700">
+            <a:solidFill>
+              <a:srgbClr val="4F46E5"/>
+            </a:solidFill>
+            <a:prstDash val="solid"/>
+          </a:ln>
+        </p:spPr>
+      </p:sp>
+      <p:sp>
+        <p:nvSpPr>
+          <p:cNvPr id="13" name="Text 8"/>
+          <p:cNvSpPr txBox="1"/>
+          <p:nvPr/>
+        </p:nvSpPr>
+        <p:spPr>
+          <a:xfrm>
+            <a:off x="9646920" y="1371600"/>
+            <a:ext cx="457200" cy="457200"/>
+          </a:xfrm>
+          <a:prstGeom prst="rect">
+            <a:avLst/>
+          </a:prstGeom>
+          <a:noFill/>
+          <a:ln/>
+        </p:spPr>
+        <p:txBody>
+          <a:bodyPr wrap="square" lIns="0" tIns="0" rIns="0" bIns="0" rtlCol="0" anchor="ctr"/>
+          <a:lstStyle/>
+          <a:p>
+            <a:pPr algn="ctr" indent="0" marL="0">
+              <a:buNone/>
+            </a:pPr>
+            <a:r>
+              <a:rPr lang="en-US" sz="1600" b="1" dirty="0">
+                <a:solidFill>
+                  <a:srgbClr val="FFFFFF"/>
+                </a:solidFill>
+                <a:latin typeface="Calibri" pitchFamily="34" charset="0"/>
+                <a:ea typeface="Calibri" pitchFamily="34" charset="-122"/>
+                <a:cs typeface="Calibri" pitchFamily="34" charset="-120"/>
+              </a:rPr>
+              <a:t>2</a:t>
+            </a:r>
+            <a:endParaRPr lang="en-US" sz="1600" dirty="0"/>
+          </a:p>
+        </p:txBody>
+      </p:sp>
+      <p:sp>
+        <p:nvSpPr>
+          <p:cNvPr id="14" name="Text 9"/>
+          <p:cNvSpPr txBox="1"/>
+          <p:nvPr/>
+        </p:nvSpPr>
+        <p:spPr>
+          <a:xfrm>
+            <a:off x="10195560" y="1371600"/>
+            <a:ext cx="1554480" cy="457200"/>
+          </a:xfrm>
+          <a:prstGeom prst="rect">
+            <a:avLst/>
+          </a:prstGeom>
+          <a:noFill/>
+          <a:ln/>
+        </p:spPr>
+        <p:txBody>
+          <a:bodyPr wrap="square" lIns="0" tIns="0" rIns="0" bIns="0" rtlCol="0" anchor="ctr"/>
+          <a:lstStyle/>
+          <a:p>
+            <a:pPr indent="0" marL="0">
+              <a:buNone/>
+            </a:pPr>
+            <a:r>
+              <a:rPr lang="en-US" sz="1600" b="1" dirty="0">
+                <a:solidFill>
+                  <a:srgbClr val="1E1B4B"/>
+                </a:solidFill>
+                <a:latin typeface="Cambria" pitchFamily="34" charset="0"/>
+                <a:ea typeface="Cambria" pitchFamily="34" charset="-122"/>
+                <a:cs typeface="Cambria" pitchFamily="34" charset="-120"/>
+              </a:rPr>
+              <a:t>Темы пачкой</a:t>
+            </a:r>
+            <a:endParaRPr lang="en-US" sz="1600" dirty="0"/>
+          </a:p>
+        </p:txBody>
+      </p:sp>
+      <p:sp>
+        <p:nvSpPr>
+          <p:cNvPr id="15" name="Text 10"/>
+          <p:cNvSpPr txBox="1"/>
+          <p:nvPr/>
+        </p:nvSpPr>
+        <p:spPr>
+          <a:xfrm>
+            <a:off x="9646920" y="1965960"/>
+            <a:ext cx="2103120" cy="1645920"/>
+          </a:xfrm>
+          <a:prstGeom prst="rect">
+            <a:avLst/>
+          </a:prstGeom>
+          <a:noFill/>
+          <a:ln/>
+        </p:spPr>
+        <p:txBody>
+          <a:bodyPr wrap="square" lIns="0" tIns="0" rIns="0" bIns="0" rtlCol="0" anchor="t"/>
+          <a:lstStyle/>
+          <a:p>
+            <a:pPr indent="0" marL="0">
+              <a:buNone/>
+            </a:pPr>
+            <a:r>
+              <a:rPr lang="en-US" sz="1400" dirty="0">
+                <a:solidFill>
+                  <a:srgbClr val="0F172A"/>
+                </a:solidFill>
+                <a:latin typeface="Calibri" pitchFamily="34" charset="0"/>
+                <a:ea typeface="Calibri" pitchFamily="34" charset="-122"/>
+                <a:cs typeface="Calibri" pitchFamily="34" charset="-120"/>
+              </a:rPr>
+              <a:t>В окне «Несколько…» отмечаем готовые темы и дописываем свои.</a:t>
+            </a:r>
+            <a:endParaRPr lang="en-US" sz="1400" dirty="0"/>
+          </a:p>
+        </p:txBody>
+      </p:sp>
+      <p:sp>
+        <p:nvSpPr>
+          <p:cNvPr id="16" name="Shape 11"/>
+          <p:cNvSpPr/>
+          <p:nvPr/>
+        </p:nvSpPr>
+        <p:spPr>
+          <a:xfrm>
+            <a:off x="523566" y="3813048"/>
+            <a:ext cx="3296268" cy="2386584"/>
+          </a:xfrm>
+          <a:prstGeom prst="rect">
+            <a:avLst/>
+          </a:prstGeom>
+          <a:solidFill>
+            <a:srgbClr val="FFFFFF"/>
+          </a:solidFill>
+          <a:ln w="9525">
+            <a:solidFill>
+              <a:srgbClr val="CBD5E1"/>
+            </a:solidFill>
+            <a:prstDash val="solid"/>
+          </a:ln>
+        </p:spPr>
+      </p:sp>
+      <p:pic>
+        <p:nvPicPr>
+          <p:cNvPr id="17" name="Image 2" descr="Скриншот программы: s4_risk_calendar.png">    </p:cNvPr>
+          <p:cNvPicPr>
+            <a:picLocks noChangeAspect="1"/>
+          </p:cNvPicPr>
+          <p:nvPr/>
+        </p:nvPicPr>
+        <p:blipFill>
+          <a:blip r:embed="rId3"/>
+          <a:stretch>
+            <a:fillRect/>
+          </a:stretch>
+        </p:blipFill>
+        <p:spPr>
+          <a:xfrm>
+            <a:off x="550998" y="3840480"/>
+            <a:ext cx="3241404" cy="2331720"/>
+          </a:xfrm>
+          <a:prstGeom prst="rect">
+            <a:avLst/>
+          </a:prstGeom>
+        </p:spPr>
+      </p:pic>
+      <p:sp>
+        <p:nvSpPr>
+          <p:cNvPr id="18" name="Shape 12"/>
+          <p:cNvSpPr/>
+          <p:nvPr/>
+        </p:nvSpPr>
+        <p:spPr>
+          <a:xfrm>
+            <a:off x="3977640" y="3886200"/>
+            <a:ext cx="457200" cy="457200"/>
+          </a:xfrm>
+          <a:prstGeom prst="ellipse">
+            <a:avLst/>
+          </a:prstGeom>
+          <a:solidFill>
+            <a:srgbClr val="4F46E5"/>
+          </a:solidFill>
+          <a:ln w="12700">
+            <a:solidFill>
+              <a:srgbClr val="4F46E5"/>
+            </a:solidFill>
+            <a:prstDash val="solid"/>
+          </a:ln>
+        </p:spPr>
+      </p:sp>
+      <p:sp>
+        <p:nvSpPr>
+          <p:cNvPr id="19" name="Text 13"/>
+          <p:cNvSpPr txBox="1"/>
+          <p:nvPr/>
+        </p:nvSpPr>
+        <p:spPr>
+          <a:xfrm>
+            <a:off x="3977640" y="3886200"/>
+            <a:ext cx="457200" cy="457200"/>
+          </a:xfrm>
+          <a:prstGeom prst="rect">
+            <a:avLst/>
+          </a:prstGeom>
+          <a:noFill/>
+          <a:ln/>
+        </p:spPr>
+        <p:txBody>
+          <a:bodyPr wrap="square" lIns="0" tIns="0" rIns="0" bIns="0" rtlCol="0" anchor="ctr"/>
+          <a:lstStyle/>
+          <a:p>
+            <a:pPr algn="ctr" indent="0" marL="0">
+              <a:buNone/>
+            </a:pPr>
+            <a:r>
+              <a:rPr lang="en-US" sz="1600" b="1" dirty="0">
+                <a:solidFill>
+                  <a:srgbClr val="FFFFFF"/>
+                </a:solidFill>
+                <a:latin typeface="Calibri" pitchFamily="34" charset="0"/>
+                <a:ea typeface="Calibri" pitchFamily="34" charset="-122"/>
+                <a:cs typeface="Calibri" pitchFamily="34" charset="-120"/>
+              </a:rPr>
+              <a:t>3</a:t>
+            </a:r>
+            <a:endParaRPr lang="en-US" sz="1600" dirty="0"/>
+          </a:p>
+        </p:txBody>
+      </p:sp>
+      <p:sp>
+        <p:nvSpPr>
+          <p:cNvPr id="20" name="Text 14"/>
+          <p:cNvSpPr txBox="1"/>
+          <p:nvPr/>
+        </p:nvSpPr>
+        <p:spPr>
+          <a:xfrm>
+            <a:off x="4526280" y="3886200"/>
+            <a:ext cx="1554480" cy="457200"/>
+          </a:xfrm>
+          <a:prstGeom prst="rect">
+            <a:avLst/>
+          </a:prstGeom>
+          <a:noFill/>
+          <a:ln/>
+        </p:spPr>
+        <p:txBody>
+          <a:bodyPr wrap="square" lIns="0" tIns="0" rIns="0" bIns="0" rtlCol="0" anchor="ctr"/>
+          <a:lstStyle/>
+          <a:p>
+            <a:pPr indent="0" marL="0">
+              <a:buNone/>
+            </a:pPr>
+            <a:r>
+              <a:rPr lang="en-US" sz="1600" b="1" dirty="0">
+                <a:solidFill>
+                  <a:srgbClr val="1E1B4B"/>
+                </a:solidFill>
+                <a:latin typeface="Cambria" pitchFamily="34" charset="0"/>
+                <a:ea typeface="Cambria" pitchFamily="34" charset="-122"/>
+                <a:cs typeface="Cambria" pitchFamily="34" charset="-120"/>
+              </a:rPr>
+              <a:t>Мало часов в день</a:t>
+            </a:r>
+            <a:endParaRPr lang="en-US" sz="1600" dirty="0"/>
+          </a:p>
+        </p:txBody>
+      </p:sp>
+      <p:sp>
+        <p:nvSpPr>
+          <p:cNvPr id="21" name="Text 15"/>
+          <p:cNvSpPr txBox="1"/>
+          <p:nvPr/>
+        </p:nvSpPr>
+        <p:spPr>
+          <a:xfrm>
+            <a:off x="3977640" y="4480560"/>
+            <a:ext cx="2103120" cy="1645920"/>
+          </a:xfrm>
+          <a:prstGeom prst="rect">
+            <a:avLst/>
+          </a:prstGeom>
+          <a:noFill/>
+          <a:ln/>
+        </p:spPr>
+        <p:txBody>
+          <a:bodyPr wrap="square" lIns="0" tIns="0" rIns="0" bIns="0" rtlCol="0" anchor="t"/>
+          <a:lstStyle/>
+          <a:p>
+            <a:pPr indent="0" marL="0">
+              <a:buNone/>
+            </a:pPr>
+            <a:r>
+              <a:rPr lang="en-US" sz="1400" dirty="0">
+                <a:solidFill>
+                  <a:srgbClr val="0F172A"/>
+                </a:solidFill>
+                <a:latin typeface="Calibri" pitchFamily="34" charset="0"/>
+                <a:ea typeface="Calibri" pitchFamily="34" charset="-122"/>
+                <a:cs typeface="Calibri" pitchFamily="34" charset="-120"/>
+              </a:rPr>
+              <a:t>Поставили 2 часа в день, и календарь заполнился почти целиком.</a:t>
+            </a:r>
+            <a:endParaRPr lang="en-US" sz="1400" dirty="0"/>
+          </a:p>
+        </p:txBody>
+      </p:sp>
+      <p:sp>
+        <p:nvSpPr>
+          <p:cNvPr id="22" name="Shape 16"/>
+          <p:cNvSpPr/>
+          <p:nvPr/>
+        </p:nvSpPr>
+        <p:spPr>
+          <a:xfrm>
+            <a:off x="6192846" y="3813048"/>
+            <a:ext cx="3296268" cy="2386584"/>
+          </a:xfrm>
+          <a:prstGeom prst="rect">
+            <a:avLst/>
+          </a:prstGeom>
+          <a:solidFill>
+            <a:srgbClr val="FFFFFF"/>
+          </a:solidFill>
+          <a:ln w="9525">
+            <a:solidFill>
+              <a:srgbClr val="CBD5E1"/>
+            </a:solidFill>
+            <a:prstDash val="solid"/>
+          </a:ln>
+        </p:spPr>
+      </p:sp>
+      <p:pic>
+        <p:nvPicPr>
+          <p:cNvPr id="23" name="Image 3" descr="Скриншот программы: s4_risk_gantt.png">    </p:cNvPr>
+          <p:cNvPicPr>
+            <a:picLocks noChangeAspect="1"/>
+          </p:cNvPicPr>
+          <p:nvPr/>
+        </p:nvPicPr>
+        <p:blipFill>
+          <a:blip r:embed="rId4"/>
+          <a:stretch>
+            <a:fillRect/>
+          </a:stretch>
+        </p:blipFill>
+        <p:spPr>
+          <a:xfrm>
+            <a:off x="6220278" y="3840480"/>
+            <a:ext cx="3241404" cy="2331720"/>
+          </a:xfrm>
+          <a:prstGeom prst="rect">
+            <a:avLst/>
+          </a:prstGeom>
+        </p:spPr>
+      </p:pic>
+      <p:sp>
+        <p:nvSpPr>
+          <p:cNvPr id="24" name="Shape 17"/>
+          <p:cNvSpPr/>
+          <p:nvPr/>
+        </p:nvSpPr>
+        <p:spPr>
+          <a:xfrm>
+            <a:off x="9646920" y="3886200"/>
+            <a:ext cx="457200" cy="457200"/>
+          </a:xfrm>
+          <a:prstGeom prst="ellipse">
+            <a:avLst/>
+          </a:prstGeom>
+          <a:solidFill>
+            <a:srgbClr val="4F46E5"/>
+          </a:solidFill>
+          <a:ln w="12700">
+            <a:solidFill>
+              <a:srgbClr val="4F46E5"/>
+            </a:solidFill>
+            <a:prstDash val="solid"/>
+          </a:ln>
+        </p:spPr>
+      </p:sp>
+      <p:sp>
+        <p:nvSpPr>
+          <p:cNvPr id="25" name="Text 18"/>
+          <p:cNvSpPr txBox="1"/>
+          <p:nvPr/>
+        </p:nvSpPr>
+        <p:spPr>
+          <a:xfrm>
+            <a:off x="9646920" y="3886200"/>
+            <a:ext cx="457200" cy="457200"/>
+          </a:xfrm>
+          <a:prstGeom prst="rect">
+            <a:avLst/>
+          </a:prstGeom>
+          <a:noFill/>
+          <a:ln/>
+        </p:spPr>
+        <p:txBody>
+          <a:bodyPr wrap="square" lIns="0" tIns="0" rIns="0" bIns="0" rtlCol="0" anchor="ctr"/>
+          <a:lstStyle/>
+          <a:p>
+            <a:pPr algn="ctr" indent="0" marL="0">
+              <a:buNone/>
+            </a:pPr>
+            <a:r>
+              <a:rPr lang="en-US" sz="1600" b="1" dirty="0">
+                <a:solidFill>
+                  <a:srgbClr val="FFFFFF"/>
+                </a:solidFill>
+                <a:latin typeface="Calibri" pitchFamily="34" charset="0"/>
+                <a:ea typeface="Calibri" pitchFamily="34" charset="-122"/>
+                <a:cs typeface="Calibri" pitchFamily="34" charset="-120"/>
+              </a:rPr>
+              <a:t>4</a:t>
+            </a:r>
+            <a:endParaRPr lang="en-US" sz="1600" dirty="0"/>
+          </a:p>
+        </p:txBody>
+      </p:sp>
+      <p:sp>
+        <p:nvSpPr>
+          <p:cNvPr id="26" name="Text 19"/>
+          <p:cNvSpPr txBox="1"/>
+          <p:nvPr/>
+        </p:nvSpPr>
+        <p:spPr>
+          <a:xfrm>
+            <a:off x="10195560" y="3886200"/>
+            <a:ext cx="1554480" cy="457200"/>
+          </a:xfrm>
+          <a:prstGeom prst="rect">
+            <a:avLst/>
+          </a:prstGeom>
+          <a:noFill/>
+          <a:ln/>
+        </p:spPr>
+        <p:txBody>
+          <a:bodyPr wrap="square" lIns="0" tIns="0" rIns="0" bIns="0" rtlCol="0" anchor="ctr"/>
+          <a:lstStyle/>
+          <a:p>
+            <a:pPr indent="0" marL="0">
+              <a:buNone/>
+            </a:pPr>
+            <a:r>
+              <a:rPr lang="en-US" sz="1600" b="1" dirty="0">
+                <a:solidFill>
+                  <a:srgbClr val="1E1B4B"/>
+                </a:solidFill>
+                <a:latin typeface="Cambria" pitchFamily="34" charset="0"/>
+                <a:ea typeface="Cambria" pitchFamily="34" charset="-122"/>
+                <a:cs typeface="Cambria" pitchFamily="34" charset="-120"/>
+              </a:rPr>
+              <a:t>Не успеваем</a:t>
+            </a:r>
+            <a:endParaRPr lang="en-US" sz="1600" dirty="0"/>
+          </a:p>
+        </p:txBody>
+      </p:sp>
+      <p:sp>
+        <p:nvSpPr>
+          <p:cNvPr id="27" name="Text 20"/>
+          <p:cNvSpPr txBox="1"/>
+          <p:nvPr/>
+        </p:nvSpPr>
+        <p:spPr>
+          <a:xfrm>
+            <a:off x="9646920" y="4480560"/>
+            <a:ext cx="2103120" cy="1645920"/>
+          </a:xfrm>
+          <a:prstGeom prst="rect">
+            <a:avLst/>
+          </a:prstGeom>
+          <a:noFill/>
+          <a:ln/>
+        </p:spPr>
+        <p:txBody>
+          <a:bodyPr wrap="square" lIns="0" tIns="0" rIns="0" bIns="0" rtlCol="0" anchor="t"/>
+          <a:lstStyle/>
+          <a:p>
+            <a:pPr indent="0" marL="0">
+              <a:buNone/>
+            </a:pPr>
+            <a:r>
+              <a:rPr lang="en-US" sz="1400" dirty="0">
+                <a:solidFill>
+                  <a:srgbClr val="0F172A"/>
+                </a:solidFill>
+                <a:latin typeface="Calibri" pitchFamily="34" charset="0"/>
+                <a:ea typeface="Calibri" pitchFamily="34" charset="-122"/>
+                <a:cs typeface="Calibri" pitchFamily="34" charset="-120"/>
+              </a:rPr>
+              <a:t>На диаграмме красные строки, внизу предупреждение о темах под угрозой.</a:t>
+            </a:r>
+            <a:endParaRPr lang="en-US" sz="1400" dirty="0"/>
+          </a:p>
+        </p:txBody>
+      </p:sp>
+      <p:sp>
+        <p:nvSpPr>
+          <p:cNvPr id="25" name="Slide Number Placeholder 0"/>
+          <p:cNvSpPr>
+            <a:spLocks noGrp="1"/>
+          </p:cNvSpPr>
+          <p:nvPr>
+            <p:ph type="sldNum" sz="quarter" idx="4294967295"/>
+          </p:nvPr>
+        </p:nvSpPr>
+        <p:spPr>
+          <a:xfrm>
+            <a:off x="10972800" y="6400800"/>
+            <a:ext cx="731520" cy="274320"/>
+          </a:xfrm>
+          <a:prstGeom prst="rect">
+            <a:avLst/>
+          </a:prstGeom>
+          <a:extLst>
+            <a:ext uri="{C572A759-6A51-4108-AA02-DFA0A04FC94B}">
+              <ma14:wrappingTextBoxFlag xmlns:ma14="http://schemas.microsoft.com/office/mac/drawingml/2011/main" val="0"/>
+            </a:ext>
+          </a:extLst>
+        </p:spPr>
+        <p:txBody>
+          <a:bodyPr/>
+          <a:lstStyle>
+            <a:lvl1pPr>
+              <a:defRPr sz="1000">
+                <a:solidFill>
+                  <a:srgbClr val="64748B"/>
+                </a:solidFill>
+                <a:latin typeface="Calibri"/>
+                <a:ea typeface="Calibri"/>
+                <a:cs typeface="Calibri"/>
+              </a:defRPr>
+            </a:lvl1pPr>
+          </a:lstStyle>
+          <a:p>
+            <a:pPr algn="r"/>
+            <a:fld id="{F7021451-1387-4CA6-816F-3879F97B5CBC}" type="slidenum">
+              <a:rPr b="0" lang="en-US"/>
+              <a:t>16</a:t>
+            </a:fld>
+            <a:endParaRPr lang="en-US"/>
+          </a:p>
+        </p:txBody>
+      </p:sp>
+    </p:spTree>
+  </p:cSld>
+  <p:clrMapOvr>
+    <a:masterClrMapping/>
+  </p:clrMapOvr>
+</p:sld>
+</file>
+
+<file path=ppt/slides/slide17.xml><?xml version="1.0" encoding="utf-8"?>
+<p:sld xmlns:a="http://schemas.openxmlformats.org/drawingml/2006/main" xmlns:r="http://schemas.openxmlformats.org/officeDocument/2006/relationships" xmlns:p="http://schemas.openxmlformats.org/presentationml/2006/main">
+  <p:cSld name="Slide 17">
+    <p:spTree>
+      <p:nvGrpSpPr>
+        <p:cNvPr id="1" name=""/>
+        <p:cNvGrpSpPr/>
+        <p:nvPr/>
+      </p:nvGrpSpPr>
+      <p:grpSpPr>
+        <a:xfrm>
+          <a:off x="0" y="0"/>
+          <a:ext cx="0" cy="0"/>
+          <a:chOff x="0" y="0"/>
+          <a:chExt cx="0" cy="0"/>
+        </a:xfrm>
+      </p:grpSpPr>
+      <p:sp>
+        <p:nvSpPr>
+          <p:cNvPr id="2" name="Title"/>
+          <p:cNvSpPr txBox="1"/>
+          <p:nvPr/>
+        </p:nvSpPr>
+        <p:spPr>
+          <a:xfrm>
+            <a:off x="548640" y="320040"/>
+            <a:ext cx="11064240" cy="822960"/>
+          </a:xfrm>
+          <a:prstGeom prst="rect">
+            <a:avLst/>
+          </a:prstGeom>
+          <a:noFill/>
+          <a:ln/>
+        </p:spPr>
+        <p:txBody>
+          <a:bodyPr wrap="square" lIns="0" tIns="0" rIns="0" bIns="0" rtlCol="0" anchor="ctr"/>
+          <a:lstStyle/>
+          <a:p>
+            <a:pPr indent="0" marL="0">
+              <a:buNone/>
+            </a:pPr>
+            <a:r>
+              <a:rPr lang="en-US" sz="3400" b="1" dirty="0">
+                <a:solidFill>
+                  <a:srgbClr val="1E1B4B"/>
+                </a:solidFill>
+                <a:latin typeface="Cambria" pitchFamily="34" charset="0"/>
+                <a:ea typeface="Cambria" pitchFamily="34" charset="-122"/>
+                <a:cs typeface="Cambria" pitchFamily="34" charset="-120"/>
+              </a:rPr>
               <a:t>Примеры ввода и вывода</a:t>
             </a:r>
             <a:endParaRPr lang="en-US" sz="3400" dirty="0"/>
@@ -3375,7 +5155,7 @@
       </p:sp>
       <p:graphicFrame>
         <p:nvGraphicFramePr>
-          <p:cNvPr id="12" name="Table 0"/>
+          <p:cNvPr id="18" name="Table 0"/>
           <p:cNvGraphicFramePr>
             <a:graphicFrameLocks noGrp="1"/>
           </p:cNvGraphicFramePr>
@@ -4647,7 +6427,7 @@
             <a:pPr algn="r"/>
             <a:fld id="{F7021451-1387-4CA6-816F-3879F97B5CBC}" type="slidenum">
               <a:rPr b="0" lang="en-US"/>
-              <a:t>11</a:t>
+              <a:t>17</a:t>
             </a:fld>
             <a:endParaRPr lang="en-US"/>
           </a:p>
@@ -4661,9 +6441,9 @@
 </p:sld>
 </file>
 
-<file path=ppt/slides/slide12.xml><?xml version="1.0" encoding="utf-8"?>
+<file path=ppt/slides/slide18.xml><?xml version="1.0" encoding="utf-8"?>
 <p:sld xmlns:a="http://schemas.openxmlformats.org/drawingml/2006/main" xmlns:r="http://schemas.openxmlformats.org/officeDocument/2006/relationships" xmlns:p="http://schemas.openxmlformats.org/presentationml/2006/main">
-  <p:cSld name="Slide 12">
+  <p:cSld name="Slide 18">
     <p:spTree>
       <p:nvGrpSpPr>
         <p:cNvPr id="1" name=""/>
@@ -5036,7 +6816,7 @@
             <a:pPr algn="r"/>
             <a:fld id="{F7021451-1387-4CA6-816F-3879F97B5CBC}" type="slidenum">
               <a:rPr b="0" lang="en-US"/>
-              <a:t>12</a:t>
+              <a:t>18</a:t>
             </a:fld>
             <a:endParaRPr lang="en-US"/>
           </a:p>
@@ -5050,9 +6830,9 @@
 </p:sld>
 </file>
 
-<file path=ppt/slides/slide13.xml><?xml version="1.0" encoding="utf-8"?>
+<file path=ppt/slides/slide19.xml><?xml version="1.0" encoding="utf-8"?>
 <p:sld xmlns:a="http://schemas.openxmlformats.org/drawingml/2006/main" xmlns:r="http://schemas.openxmlformats.org/officeDocument/2006/relationships" xmlns:p="http://schemas.openxmlformats.org/presentationml/2006/main">
-  <p:cSld name="Slide 13">
+  <p:cSld name="Slide 19">
     <p:spTree>
       <p:nvGrpSpPr>
         <p:cNvPr id="1" name=""/>
@@ -11060,7 +12840,7 @@
                 <a:ea typeface="Cambria" pitchFamily="34" charset="-122"/>
                 <a:cs typeface="Cambria" pitchFamily="34" charset="-120"/>
               </a:rPr>
-              <a:t>Календарь нагрузки</a:t>
+              <a:t>Ошибки: свои исключения</a:t>
             </a:r>
             <a:endParaRPr lang="en-US" sz="3400" dirty="0"/>
           </a:p>
@@ -11074,8 +12854,8 @@
         </p:nvSpPr>
         <p:spPr>
           <a:xfrm>
-            <a:off x="883893" y="1252728"/>
-            <a:ext cx="6919015" cy="4992624"/>
+            <a:off x="1015786" y="1207008"/>
+            <a:ext cx="10157380" cy="5084064"/>
           </a:xfrm>
           <a:prstGeom prst="rect">
             <a:avLst/>
@@ -11093,7 +12873,7 @@
       </p:sp>
       <p:pic>
         <p:nvPicPr>
-          <p:cNvPr id="5" name="Image 0" descr="Скриншот программы: 01_calendar.png">    </p:cNvPr>
+          <p:cNvPr id="5" name="Image 0" descr="Скриншот программы: code_errors_left.png">    </p:cNvPr>
           <p:cNvPicPr>
             <a:picLocks noChangeAspect="1"/>
           </p:cNvPicPr>
@@ -11107,154 +12887,14 @@
         </p:blipFill>
         <p:spPr>
           <a:xfrm>
-            <a:off x="911325" y="1280160"/>
-            <a:ext cx="6864151" cy="4937760"/>
+            <a:off x="1043218" y="1234440"/>
+            <a:ext cx="10102516" cy="5029200"/>
           </a:xfrm>
           <a:prstGeom prst="rect">
             <a:avLst/>
           </a:prstGeom>
         </p:spPr>
       </p:pic>
-      <p:sp>
-        <p:nvSpPr>
-          <p:cNvPr id="6" name="Shape 2"/>
-          <p:cNvSpPr/>
-          <p:nvPr/>
-        </p:nvSpPr>
-        <p:spPr>
-          <a:xfrm>
-            <a:off x="8412480" y="1280160"/>
-            <a:ext cx="3227832" cy="4937760"/>
-          </a:xfrm>
-          <a:prstGeom prst="roundRect">
-            <a:avLst>
-              <a:gd name="adj" fmla="val 3399"/>
-            </a:avLst>
-          </a:prstGeom>
-          <a:solidFill>
-            <a:srgbClr val="FFFFFF"/>
-          </a:solidFill>
-          <a:ln w="9525">
-            <a:solidFill>
-              <a:srgbClr val="DBE3EE"/>
-            </a:solidFill>
-            <a:prstDash val="solid"/>
-          </a:ln>
-          <a:effectLst>
-            <a:outerShdw sx="100000" sy="100000" kx="0" ky="0" algn="bl" rotWithShape="0" blurRad="76200" dist="25400" dir="5400000">
-              <a:srgbClr val="000000">
-                <a:alpha val="8000"/>
-              </a:srgbClr>
-            </a:outerShdw>
-          </a:effectLst>
-        </p:spPr>
-      </p:sp>
-      <p:sp>
-        <p:nvSpPr>
-          <p:cNvPr id="7" name="Text 3"/>
-          <p:cNvSpPr txBox="1"/>
-          <p:nvPr/>
-        </p:nvSpPr>
-        <p:spPr>
-          <a:xfrm>
-            <a:off x="8641080" y="1508760"/>
-            <a:ext cx="2834640" cy="4480560"/>
-          </a:xfrm>
-          <a:prstGeom prst="rect">
-            <a:avLst/>
-          </a:prstGeom>
-          <a:noFill/>
-          <a:ln/>
-        </p:spPr>
-        <p:txBody>
-          <a:bodyPr wrap="square" lIns="0" tIns="0" rIns="0" bIns="0" rtlCol="0" anchor="t"/>
-          <a:lstStyle/>
-          <a:p>
-            <a:pPr marL="228600" indent="-228600">
-              <a:spcAft>
-                <a:spcPts val="800"/>
-              </a:spcAft>
-              <a:buSzPct val="100000"/>
-              <a:buChar char="•"/>
-            </a:pPr>
-            <a:r>
-              <a:rPr lang="en-US" sz="1600" dirty="0">
-                <a:solidFill>
-                  <a:srgbClr val="0F172A"/>
-                </a:solidFill>
-                <a:latin typeface="Calibri" pitchFamily="34" charset="0"/>
-                <a:ea typeface="Calibri" pitchFamily="34" charset="-122"/>
-                <a:cs typeface="Calibri" pitchFamily="34" charset="-120"/>
-              </a:rPr>
-              <a:t>Цвет — загрузка дня</a:t>
-            </a:r>
-            <a:endParaRPr lang="en-US" sz="1600" dirty="0"/>
-          </a:p>
-          <a:p>
-            <a:pPr marL="228600" indent="-228600">
-              <a:spcAft>
-                <a:spcPts val="800"/>
-              </a:spcAft>
-              <a:buSzPct val="100000"/>
-              <a:buChar char="•"/>
-            </a:pPr>
-            <a:r>
-              <a:rPr lang="en-US" sz="1600" dirty="0">
-                <a:solidFill>
-                  <a:srgbClr val="0F172A"/>
-                </a:solidFill>
-                <a:latin typeface="Calibri" pitchFamily="34" charset="0"/>
-                <a:ea typeface="Calibri" pitchFamily="34" charset="-122"/>
-                <a:cs typeface="Calibri" pitchFamily="34" charset="-120"/>
-              </a:rPr>
-              <a:t>Красный — экзамен, фиолетовый — контрольная</a:t>
-            </a:r>
-            <a:endParaRPr lang="en-US" sz="1600" dirty="0"/>
-          </a:p>
-          <a:p>
-            <a:pPr marL="228600" indent="-228600">
-              <a:spcAft>
-                <a:spcPts val="800"/>
-              </a:spcAft>
-              <a:buSzPct val="100000"/>
-              <a:buChar char="•"/>
-            </a:pPr>
-            <a:r>
-              <a:rPr lang="en-US" sz="1600" dirty="0">
-                <a:solidFill>
-                  <a:srgbClr val="0F172A"/>
-                </a:solidFill>
-                <a:latin typeface="Calibri" pitchFamily="34" charset="0"/>
-                <a:ea typeface="Calibri" pitchFamily="34" charset="-122"/>
-                <a:cs typeface="Calibri" pitchFamily="34" charset="-120"/>
-              </a:rPr>
-              <a:t>Клик по дню — список тем и часов</a:t>
-            </a:r>
-            <a:endParaRPr lang="en-US" sz="1600" dirty="0"/>
-          </a:p>
-          <a:p>
-            <a:pPr marL="228600" indent="-228600">
-              <a:spcAft>
-                <a:spcPts val="800"/>
-              </a:spcAft>
-              <a:buSzPct val="100000"/>
-              <a:buChar char="•"/>
-            </a:pPr>
-            <a:r>
-              <a:rPr lang="en-US" sz="1600" dirty="0">
-                <a:solidFill>
-                  <a:srgbClr val="0F172A"/>
-                </a:solidFill>
-                <a:latin typeface="Calibri" pitchFamily="34" charset="0"/>
-                <a:ea typeface="Calibri" pitchFamily="34" charset="-122"/>
-                <a:cs typeface="Calibri" pitchFamily="34" charset="-120"/>
-              </a:rPr>
-              <a:t>Листание месяцев</a:t>
-            </a:r>
-            <a:endParaRPr lang="en-US" sz="1600" dirty="0"/>
-          </a:p>
-        </p:txBody>
-      </p:sp>
       <p:sp>
         <p:nvSpPr>
           <p:cNvPr id="25" name="Slide Number Placeholder 0"/>
@@ -11361,7 +13001,7 @@
                 <a:ea typeface="Cambria" pitchFamily="34" charset="-122"/>
                 <a:cs typeface="Cambria" pitchFamily="34" charset="-120"/>
               </a:rPr>
-              <a:t>Диаграмма Ганта</a:t>
+              <a:t>Ошибки: как мы их ловим</a:t>
             </a:r>
             <a:endParaRPr lang="en-US" sz="3400" dirty="0"/>
           </a:p>
@@ -11375,8 +13015,8 @@
         </p:nvSpPr>
         <p:spPr>
           <a:xfrm>
-            <a:off x="883893" y="1252728"/>
-            <a:ext cx="6919015" cy="4992624"/>
+            <a:off x="521208" y="1867714"/>
+            <a:ext cx="11146536" cy="3762651"/>
           </a:xfrm>
           <a:prstGeom prst="rect">
             <a:avLst/>
@@ -11394,7 +13034,7 @@
       </p:sp>
       <p:pic>
         <p:nvPicPr>
-          <p:cNvPr id="5" name="Image 0" descr="Скриншот программы: 02_gantt.png">    </p:cNvPr>
+          <p:cNvPr id="5" name="Image 0" descr="Скриншот программы: code_errors_right.png">    </p:cNvPr>
           <p:cNvPicPr>
             <a:picLocks noChangeAspect="1"/>
           </p:cNvPicPr>
@@ -11408,154 +13048,14 @@
         </p:blipFill>
         <p:spPr>
           <a:xfrm>
-            <a:off x="911325" y="1280160"/>
-            <a:ext cx="6864151" cy="4937760"/>
+            <a:off x="548640" y="1895146"/>
+            <a:ext cx="11091672" cy="3707787"/>
           </a:xfrm>
           <a:prstGeom prst="rect">
             <a:avLst/>
           </a:prstGeom>
         </p:spPr>
       </p:pic>
-      <p:sp>
-        <p:nvSpPr>
-          <p:cNvPr id="6" name="Shape 2"/>
-          <p:cNvSpPr/>
-          <p:nvPr/>
-        </p:nvSpPr>
-        <p:spPr>
-          <a:xfrm>
-            <a:off x="8412480" y="1280160"/>
-            <a:ext cx="3227832" cy="4937760"/>
-          </a:xfrm>
-          <a:prstGeom prst="roundRect">
-            <a:avLst>
-              <a:gd name="adj" fmla="val 3399"/>
-            </a:avLst>
-          </a:prstGeom>
-          <a:solidFill>
-            <a:srgbClr val="FFFFFF"/>
-          </a:solidFill>
-          <a:ln w="9525">
-            <a:solidFill>
-              <a:srgbClr val="DBE3EE"/>
-            </a:solidFill>
-            <a:prstDash val="solid"/>
-          </a:ln>
-          <a:effectLst>
-            <a:outerShdw sx="100000" sy="100000" kx="0" ky="0" algn="bl" rotWithShape="0" blurRad="76200" dist="25400" dir="5400000">
-              <a:srgbClr val="000000">
-                <a:alpha val="8000"/>
-              </a:srgbClr>
-            </a:outerShdw>
-          </a:effectLst>
-        </p:spPr>
-      </p:sp>
-      <p:sp>
-        <p:nvSpPr>
-          <p:cNvPr id="7" name="Text 3"/>
-          <p:cNvSpPr txBox="1"/>
-          <p:nvPr/>
-        </p:nvSpPr>
-        <p:spPr>
-          <a:xfrm>
-            <a:off x="8641080" y="1508760"/>
-            <a:ext cx="2834640" cy="4480560"/>
-          </a:xfrm>
-          <a:prstGeom prst="rect">
-            <a:avLst/>
-          </a:prstGeom>
-          <a:noFill/>
-          <a:ln/>
-        </p:spPr>
-        <p:txBody>
-          <a:bodyPr wrap="square" lIns="0" tIns="0" rIns="0" bIns="0" rtlCol="0" anchor="t"/>
-          <a:lstStyle/>
-          <a:p>
-            <a:pPr marL="228600" indent="-228600">
-              <a:spcAft>
-                <a:spcPts val="800"/>
-              </a:spcAft>
-              <a:buSzPct val="100000"/>
-              <a:buChar char="•"/>
-            </a:pPr>
-            <a:r>
-              <a:rPr lang="en-US" sz="1600" dirty="0">
-                <a:solidFill>
-                  <a:srgbClr val="0F172A"/>
-                </a:solidFill>
-                <a:latin typeface="Calibri" pitchFamily="34" charset="0"/>
-                <a:ea typeface="Calibri" pitchFamily="34" charset="-122"/>
-                <a:cs typeface="Calibri" pitchFamily="34" charset="-120"/>
-              </a:rPr>
-              <a:t>Полоска — период занятий по теме</a:t>
-            </a:r>
-            <a:endParaRPr lang="en-US" sz="1600" dirty="0"/>
-          </a:p>
-          <a:p>
-            <a:pPr marL="228600" indent="-228600">
-              <a:spcAft>
-                <a:spcPts val="800"/>
-              </a:spcAft>
-              <a:buSzPct val="100000"/>
-              <a:buChar char="•"/>
-            </a:pPr>
-            <a:r>
-              <a:rPr lang="en-US" sz="1600" dirty="0">
-                <a:solidFill>
-                  <a:srgbClr val="0F172A"/>
-                </a:solidFill>
-                <a:latin typeface="Calibri" pitchFamily="34" charset="0"/>
-                <a:ea typeface="Calibri" pitchFamily="34" charset="-122"/>
-                <a:cs typeface="Calibri" pitchFamily="34" charset="-120"/>
-              </a:rPr>
-              <a:t>Линии — экзамены, контрольные и «сегодня»</a:t>
-            </a:r>
-            <a:endParaRPr lang="en-US" sz="1600" dirty="0"/>
-          </a:p>
-          <a:p>
-            <a:pPr marL="228600" indent="-228600">
-              <a:spcAft>
-                <a:spcPts val="800"/>
-              </a:spcAft>
-              <a:buSzPct val="100000"/>
-              <a:buChar char="•"/>
-            </a:pPr>
-            <a:r>
-              <a:rPr lang="en-US" sz="1600" dirty="0">
-                <a:solidFill>
-                  <a:srgbClr val="0F172A"/>
-                </a:solidFill>
-                <a:latin typeface="Calibri" pitchFamily="34" charset="0"/>
-                <a:ea typeface="Calibri" pitchFamily="34" charset="-122"/>
-                <a:cs typeface="Calibri" pitchFamily="34" charset="-120"/>
-              </a:rPr>
-              <a:t>Красная строка — тема не помещается</a:t>
-            </a:r>
-            <a:endParaRPr lang="en-US" sz="1600" dirty="0"/>
-          </a:p>
-          <a:p>
-            <a:pPr marL="228600" indent="-228600">
-              <a:spcAft>
-                <a:spcPts val="800"/>
-              </a:spcAft>
-              <a:buSzPct val="100000"/>
-              <a:buChar char="•"/>
-            </a:pPr>
-            <a:r>
-              <a:rPr lang="en-US" sz="1600" dirty="0">
-                <a:solidFill>
-                  <a:srgbClr val="0F172A"/>
-                </a:solidFill>
-                <a:latin typeface="Calibri" pitchFamily="34" charset="0"/>
-                <a:ea typeface="Calibri" pitchFamily="34" charset="-122"/>
-                <a:cs typeface="Calibri" pitchFamily="34" charset="-120"/>
-              </a:rPr>
-              <a:t>Серая — тема уже выполнена</a:t>
-            </a:r>
-            <a:endParaRPr lang="en-US" sz="1600" dirty="0"/>
-          </a:p>
-        </p:txBody>
-      </p:sp>
       <p:sp>
         <p:nvSpPr>
           <p:cNvPr id="25" name="Slide Number Placeholder 0"/>

</xml_diff>

<commit_message>
Hints stay under focus, short dates (25, 25.11), date picker popup; docs updated (80 tests)
Co-Authored-By: Claude Sonnet 5.5 <noreply@anthropic.com>
</commit_message>
<xml_diff>
--- a/docs/Презентация_Планировщик_экзаменов.pptx
+++ b/docs/Презентация_Планировщик_экзаменов.pptx
@@ -1312,7 +1312,7 @@
           <a:p>
             <a:r>
               <a:rPr lang="en-US" dirty="0"/>
-              <a:t>Логику проверяют 70 автотестов, все проходят. Они смотрят на неверный ввод, лимиты часов, день повторения, распределение по дням, перепланирование, автоподбор сложности и битые файлы. Окно мы проверяли руками.</a:t>
+              <a:t>Логику проверяют 80 автотестов, все проходят. Они смотрят на неверный ввод, лимиты часов, день повторения, распределение по дням, перепланирование, автоподбор сложности и битые файлы. Окно мы проверяли руками.</a:t>
             </a:r>
             <a:endParaRPr lang="en-US" dirty="0"/>
           </a:p>
@@ -3683,50 +3683,82 @@
         </p:nvSpPr>
         <p:spPr>
           <a:xfrm>
-            <a:off x="883893" y="1252728"/>
-            <a:ext cx="6919015" cy="4992624"/>
+            <a:off x="548640" y="1280160"/>
+            <a:ext cx="7589520" cy="4937760"/>
           </a:xfrm>
           <a:prstGeom prst="rect">
             <a:avLst/>
           </a:prstGeom>
           <a:solidFill>
-            <a:srgbClr val="FFFFFF"/>
+            <a:srgbClr val="E2E8F0"/>
           </a:solidFill>
-          <a:ln w="9525">
+          <a:ln w="12700">
             <a:solidFill>
-              <a:srgbClr val="CBD5E1"/>
+              <a:srgbClr val="94A3B8"/>
             </a:solidFill>
-            <a:prstDash val="solid"/>
+            <a:prstDash val="dash"/>
           </a:ln>
         </p:spPr>
       </p:sp>
-      <p:pic>
-        <p:nvPicPr>
-          <p:cNvPr id="5" name="Image 0" descr="Скриншот программы: 01_calendar.png">    </p:cNvPr>
-          <p:cNvPicPr>
-            <a:picLocks noChangeAspect="1"/>
-          </p:cNvPicPr>
-          <p:nvPr/>
-        </p:nvPicPr>
-        <p:blipFill>
-          <a:blip r:embed="rId1"/>
-          <a:stretch>
-            <a:fillRect/>
-          </a:stretch>
-        </p:blipFill>
-        <p:spPr>
-          <a:xfrm>
-            <a:off x="911325" y="1280160"/>
-            <a:ext cx="6864151" cy="4937760"/>
-          </a:xfrm>
-          <a:prstGeom prst="rect">
-            <a:avLst/>
-          </a:prstGeom>
-        </p:spPr>
-      </p:pic>
-      <p:sp>
-        <p:nvSpPr>
-          <p:cNvPr id="6" name="Shape 2"/>
+      <p:sp>
+        <p:nvSpPr>
+          <p:cNvPr id="5" name="Text 2"/>
+          <p:cNvSpPr txBox="1"/>
+          <p:nvPr/>
+        </p:nvSpPr>
+        <p:spPr>
+          <a:xfrm>
+            <a:off x="548640" y="1280160"/>
+            <a:ext cx="7589520" cy="4937760"/>
+          </a:xfrm>
+          <a:prstGeom prst="rect">
+            <a:avLst/>
+          </a:prstGeom>
+          <a:noFill/>
+          <a:ln/>
+        </p:spPr>
+        <p:txBody>
+          <a:bodyPr wrap="square" rtlCol="0" anchor="ctr"/>
+          <a:lstStyle/>
+          <a:p>
+            <a:pPr algn="ctr" indent="0" marL="0">
+              <a:buNone/>
+            </a:pPr>
+            <a:r>
+              <a:rPr lang="en-US" sz="1600" dirty="0">
+                <a:solidFill>
+                  <a:srgbClr val="64748B"/>
+                </a:solidFill>
+                <a:latin typeface="Calibri" pitchFamily="34" charset="0"/>
+                <a:ea typeface="Calibri" pitchFamily="34" charset="-122"/>
+                <a:cs typeface="Calibri" pitchFamily="34" charset="-120"/>
+              </a:rPr>
+              <a:t>Здесь будет скриншот</a:t>
+            </a:r>
+            <a:endParaRPr lang="en-US" sz="1600" dirty="0"/>
+          </a:p>
+          <a:p>
+            <a:pPr algn="ctr" indent="0" marL="0">
+              <a:buNone/>
+            </a:pPr>
+            <a:r>
+              <a:rPr lang="en-US" sz="1600" dirty="0">
+                <a:solidFill>
+                  <a:srgbClr val="64748B"/>
+                </a:solidFill>
+                <a:latin typeface="Calibri" pitchFamily="34" charset="0"/>
+                <a:ea typeface="Calibri" pitchFamily="34" charset="-122"/>
+                <a:cs typeface="Calibri" pitchFamily="34" charset="-120"/>
+              </a:rPr>
+              <a:t>01_calendar.png</a:t>
+            </a:r>
+            <a:endParaRPr lang="en-US" sz="1600" dirty="0"/>
+          </a:p>
+        </p:txBody>
+      </p:sp>
+      <p:sp>
+        <p:nvSpPr>
+          <p:cNvPr id="6" name="Shape 3"/>
           <p:cNvSpPr/>
           <p:nvPr/>
         </p:nvSpPr>
@@ -3760,7 +3792,7 @@
       </p:sp>
       <p:sp>
         <p:nvSpPr>
-          <p:cNvPr id="7" name="Text 3"/>
+          <p:cNvPr id="7" name="Text 4"/>
           <p:cNvSpPr txBox="1"/>
           <p:nvPr/>
         </p:nvSpPr>
@@ -3984,50 +4016,82 @@
         </p:nvSpPr>
         <p:spPr>
           <a:xfrm>
-            <a:off x="883893" y="1252728"/>
-            <a:ext cx="6919015" cy="4992624"/>
+            <a:off x="548640" y="1280160"/>
+            <a:ext cx="7589520" cy="4937760"/>
           </a:xfrm>
           <a:prstGeom prst="rect">
             <a:avLst/>
           </a:prstGeom>
           <a:solidFill>
-            <a:srgbClr val="FFFFFF"/>
+            <a:srgbClr val="E2E8F0"/>
           </a:solidFill>
-          <a:ln w="9525">
+          <a:ln w="12700">
             <a:solidFill>
-              <a:srgbClr val="CBD5E1"/>
+              <a:srgbClr val="94A3B8"/>
             </a:solidFill>
-            <a:prstDash val="solid"/>
+            <a:prstDash val="dash"/>
           </a:ln>
         </p:spPr>
       </p:sp>
-      <p:pic>
-        <p:nvPicPr>
-          <p:cNvPr id="5" name="Image 0" descr="Скриншот программы: 02_gantt.png">    </p:cNvPr>
-          <p:cNvPicPr>
-            <a:picLocks noChangeAspect="1"/>
-          </p:cNvPicPr>
-          <p:nvPr/>
-        </p:nvPicPr>
-        <p:blipFill>
-          <a:blip r:embed="rId1"/>
-          <a:stretch>
-            <a:fillRect/>
-          </a:stretch>
-        </p:blipFill>
-        <p:spPr>
-          <a:xfrm>
-            <a:off x="911325" y="1280160"/>
-            <a:ext cx="6864151" cy="4937760"/>
-          </a:xfrm>
-          <a:prstGeom prst="rect">
-            <a:avLst/>
-          </a:prstGeom>
-        </p:spPr>
-      </p:pic>
-      <p:sp>
-        <p:nvSpPr>
-          <p:cNvPr id="6" name="Shape 2"/>
+      <p:sp>
+        <p:nvSpPr>
+          <p:cNvPr id="5" name="Text 2"/>
+          <p:cNvSpPr txBox="1"/>
+          <p:nvPr/>
+        </p:nvSpPr>
+        <p:spPr>
+          <a:xfrm>
+            <a:off x="548640" y="1280160"/>
+            <a:ext cx="7589520" cy="4937760"/>
+          </a:xfrm>
+          <a:prstGeom prst="rect">
+            <a:avLst/>
+          </a:prstGeom>
+          <a:noFill/>
+          <a:ln/>
+        </p:spPr>
+        <p:txBody>
+          <a:bodyPr wrap="square" rtlCol="0" anchor="ctr"/>
+          <a:lstStyle/>
+          <a:p>
+            <a:pPr algn="ctr" indent="0" marL="0">
+              <a:buNone/>
+            </a:pPr>
+            <a:r>
+              <a:rPr lang="en-US" sz="1600" dirty="0">
+                <a:solidFill>
+                  <a:srgbClr val="64748B"/>
+                </a:solidFill>
+                <a:latin typeface="Calibri" pitchFamily="34" charset="0"/>
+                <a:ea typeface="Calibri" pitchFamily="34" charset="-122"/>
+                <a:cs typeface="Calibri" pitchFamily="34" charset="-120"/>
+              </a:rPr>
+              <a:t>Здесь будет скриншот</a:t>
+            </a:r>
+            <a:endParaRPr lang="en-US" sz="1600" dirty="0"/>
+          </a:p>
+          <a:p>
+            <a:pPr algn="ctr" indent="0" marL="0">
+              <a:buNone/>
+            </a:pPr>
+            <a:r>
+              <a:rPr lang="en-US" sz="1600" dirty="0">
+                <a:solidFill>
+                  <a:srgbClr val="64748B"/>
+                </a:solidFill>
+                <a:latin typeface="Calibri" pitchFamily="34" charset="0"/>
+                <a:ea typeface="Calibri" pitchFamily="34" charset="-122"/>
+                <a:cs typeface="Calibri" pitchFamily="34" charset="-120"/>
+              </a:rPr>
+              <a:t>02_gantt.png</a:t>
+            </a:r>
+            <a:endParaRPr lang="en-US" sz="1600" dirty="0"/>
+          </a:p>
+        </p:txBody>
+      </p:sp>
+      <p:sp>
+        <p:nvSpPr>
+          <p:cNvPr id="6" name="Shape 3"/>
           <p:cNvSpPr/>
           <p:nvPr/>
         </p:nvSpPr>
@@ -4061,7 +4125,7 @@
       </p:sp>
       <p:sp>
         <p:nvSpPr>
-          <p:cNvPr id="7" name="Text 3"/>
+          <p:cNvPr id="7" name="Text 4"/>
           <p:cNvSpPr txBox="1"/>
           <p:nvPr/>
         </p:nvSpPr>
@@ -4476,8 +4540,231 @@
         </p:nvSpPr>
         <p:spPr>
           <a:xfrm>
-            <a:off x="6261197" y="1298448"/>
-            <a:ext cx="3159565" cy="2386584"/>
+            <a:off x="6217920" y="1325880"/>
+            <a:ext cx="3246120" cy="2331720"/>
+          </a:xfrm>
+          <a:prstGeom prst="rect">
+            <a:avLst/>
+          </a:prstGeom>
+          <a:solidFill>
+            <a:srgbClr val="E2E8F0"/>
+          </a:solidFill>
+          <a:ln w="12700">
+            <a:solidFill>
+              <a:srgbClr val="94A3B8"/>
+            </a:solidFill>
+            <a:prstDash val="dash"/>
+          </a:ln>
+        </p:spPr>
+      </p:sp>
+      <p:sp>
+        <p:nvSpPr>
+          <p:cNvPr id="11" name="Text 7"/>
+          <p:cNvSpPr txBox="1"/>
+          <p:nvPr/>
+        </p:nvSpPr>
+        <p:spPr>
+          <a:xfrm>
+            <a:off x="6217920" y="1325880"/>
+            <a:ext cx="3246120" cy="2331720"/>
+          </a:xfrm>
+          <a:prstGeom prst="rect">
+            <a:avLst/>
+          </a:prstGeom>
+          <a:noFill/>
+          <a:ln/>
+        </p:spPr>
+        <p:txBody>
+          <a:bodyPr wrap="square" rtlCol="0" anchor="ctr"/>
+          <a:lstStyle/>
+          <a:p>
+            <a:pPr algn="ctr" indent="0" marL="0">
+              <a:buNone/>
+            </a:pPr>
+            <a:r>
+              <a:rPr lang="en-US" sz="1600" dirty="0">
+                <a:solidFill>
+                  <a:srgbClr val="64748B"/>
+                </a:solidFill>
+                <a:latin typeface="Calibri" pitchFamily="34" charset="0"/>
+                <a:ea typeface="Calibri" pitchFamily="34" charset="-122"/>
+                <a:cs typeface="Calibri" pitchFamily="34" charset="-120"/>
+              </a:rPr>
+              <a:t>Здесь будет скриншот</a:t>
+            </a:r>
+            <a:endParaRPr lang="en-US" sz="1600" dirty="0"/>
+          </a:p>
+          <a:p>
+            <a:pPr algn="ctr" indent="0" marL="0">
+              <a:buNone/>
+            </a:pPr>
+            <a:r>
+              <a:rPr lang="en-US" sz="1600" dirty="0">
+                <a:solidFill>
+                  <a:srgbClr val="64748B"/>
+                </a:solidFill>
+                <a:latin typeface="Calibri" pitchFamily="34" charset="0"/>
+                <a:ea typeface="Calibri" pitchFamily="34" charset="-122"/>
+                <a:cs typeface="Calibri" pitchFamily="34" charset="-120"/>
+              </a:rPr>
+              <a:t>03_dialog.png</a:t>
+            </a:r>
+            <a:endParaRPr lang="en-US" sz="1600" dirty="0"/>
+          </a:p>
+        </p:txBody>
+      </p:sp>
+      <p:sp>
+        <p:nvSpPr>
+          <p:cNvPr id="12" name="Shape 8"/>
+          <p:cNvSpPr/>
+          <p:nvPr/>
+        </p:nvSpPr>
+        <p:spPr>
+          <a:xfrm>
+            <a:off x="9646920" y="1371600"/>
+            <a:ext cx="457200" cy="457200"/>
+          </a:xfrm>
+          <a:prstGeom prst="ellipse">
+            <a:avLst/>
+          </a:prstGeom>
+          <a:solidFill>
+            <a:srgbClr val="4F46E5"/>
+          </a:solidFill>
+          <a:ln w="12700">
+            <a:solidFill>
+              <a:srgbClr val="4F46E5"/>
+            </a:solidFill>
+            <a:prstDash val="solid"/>
+          </a:ln>
+        </p:spPr>
+      </p:sp>
+      <p:sp>
+        <p:nvSpPr>
+          <p:cNvPr id="13" name="Text 9"/>
+          <p:cNvSpPr txBox="1"/>
+          <p:nvPr/>
+        </p:nvSpPr>
+        <p:spPr>
+          <a:xfrm>
+            <a:off x="9646920" y="1371600"/>
+            <a:ext cx="457200" cy="457200"/>
+          </a:xfrm>
+          <a:prstGeom prst="rect">
+            <a:avLst/>
+          </a:prstGeom>
+          <a:noFill/>
+          <a:ln/>
+        </p:spPr>
+        <p:txBody>
+          <a:bodyPr wrap="square" lIns="0" tIns="0" rIns="0" bIns="0" rtlCol="0" anchor="ctr"/>
+          <a:lstStyle/>
+          <a:p>
+            <a:pPr algn="ctr" indent="0" marL="0">
+              <a:buNone/>
+            </a:pPr>
+            <a:r>
+              <a:rPr lang="en-US" sz="1600" b="1" dirty="0">
+                <a:solidFill>
+                  <a:srgbClr val="FFFFFF"/>
+                </a:solidFill>
+                <a:latin typeface="Calibri" pitchFamily="34" charset="0"/>
+                <a:ea typeface="Calibri" pitchFamily="34" charset="-122"/>
+                <a:cs typeface="Calibri" pitchFamily="34" charset="-120"/>
+              </a:rPr>
+              <a:t>2</a:t>
+            </a:r>
+            <a:endParaRPr lang="en-US" sz="1600" dirty="0"/>
+          </a:p>
+        </p:txBody>
+      </p:sp>
+      <p:sp>
+        <p:nvSpPr>
+          <p:cNvPr id="14" name="Text 10"/>
+          <p:cNvSpPr txBox="1"/>
+          <p:nvPr/>
+        </p:nvSpPr>
+        <p:spPr>
+          <a:xfrm>
+            <a:off x="10195560" y="1371600"/>
+            <a:ext cx="1554480" cy="457200"/>
+          </a:xfrm>
+          <a:prstGeom prst="rect">
+            <a:avLst/>
+          </a:prstGeom>
+          <a:noFill/>
+          <a:ln/>
+        </p:spPr>
+        <p:txBody>
+          <a:bodyPr wrap="square" lIns="0" tIns="0" rIns="0" bIns="0" rtlCol="0" anchor="ctr"/>
+          <a:lstStyle/>
+          <a:p>
+            <a:pPr indent="0" marL="0">
+              <a:buNone/>
+            </a:pPr>
+            <a:r>
+              <a:rPr lang="en-US" sz="1600" b="1" dirty="0">
+                <a:solidFill>
+                  <a:srgbClr val="1E1B4B"/>
+                </a:solidFill>
+                <a:latin typeface="Cambria" pitchFamily="34" charset="0"/>
+                <a:ea typeface="Cambria" pitchFamily="34" charset="-122"/>
+                <a:cs typeface="Cambria" pitchFamily="34" charset="-120"/>
+              </a:rPr>
+              <a:t>Темы пачкой</a:t>
+            </a:r>
+            <a:endParaRPr lang="en-US" sz="1600" dirty="0"/>
+          </a:p>
+        </p:txBody>
+      </p:sp>
+      <p:sp>
+        <p:nvSpPr>
+          <p:cNvPr id="15" name="Text 11"/>
+          <p:cNvSpPr txBox="1"/>
+          <p:nvPr/>
+        </p:nvSpPr>
+        <p:spPr>
+          <a:xfrm>
+            <a:off x="9646920" y="1965960"/>
+            <a:ext cx="2103120" cy="1645920"/>
+          </a:xfrm>
+          <a:prstGeom prst="rect">
+            <a:avLst/>
+          </a:prstGeom>
+          <a:noFill/>
+          <a:ln/>
+        </p:spPr>
+        <p:txBody>
+          <a:bodyPr wrap="square" lIns="0" tIns="0" rIns="0" bIns="0" rtlCol="0" anchor="t"/>
+          <a:lstStyle/>
+          <a:p>
+            <a:pPr indent="0" marL="0">
+              <a:buNone/>
+            </a:pPr>
+            <a:r>
+              <a:rPr lang="en-US" sz="1400" dirty="0">
+                <a:solidFill>
+                  <a:srgbClr val="0F172A"/>
+                </a:solidFill>
+                <a:latin typeface="Calibri" pitchFamily="34" charset="0"/>
+                <a:ea typeface="Calibri" pitchFamily="34" charset="-122"/>
+                <a:cs typeface="Calibri" pitchFamily="34" charset="-120"/>
+              </a:rPr>
+              <a:t>В окне «Несколько…» отмечаем готовые темы и дописываем свои.</a:t>
+            </a:r>
+            <a:endParaRPr lang="en-US" sz="1400" dirty="0"/>
+          </a:p>
+        </p:txBody>
+      </p:sp>
+      <p:sp>
+        <p:nvSpPr>
+          <p:cNvPr id="16" name="Shape 12"/>
+          <p:cNvSpPr/>
+          <p:nvPr/>
+        </p:nvSpPr>
+        <p:spPr>
+          <a:xfrm>
+            <a:off x="523566" y="3813048"/>
+            <a:ext cx="3296268" cy="2386584"/>
           </a:xfrm>
           <a:prstGeom prst="rect">
             <a:avLst/>
@@ -4495,7 +4782,7 @@
       </p:sp>
       <p:pic>
         <p:nvPicPr>
-          <p:cNvPr id="11" name="Image 1" descr="Скриншот программы: 03_dialog.png">    </p:cNvPr>
+          <p:cNvPr id="17" name="Image 1" descr="Скриншот программы: s4_risk_calendar.png">    </p:cNvPr>
           <p:cNvPicPr>
             <a:picLocks noChangeAspect="1"/>
           </p:cNvPicPr>
@@ -4509,8 +4796,8 @@
         </p:blipFill>
         <p:spPr>
           <a:xfrm>
-            <a:off x="6288629" y="1325880"/>
-            <a:ext cx="3104701" cy="2331720"/>
+            <a:off x="550998" y="3840480"/>
+            <a:ext cx="3241404" cy="2331720"/>
           </a:xfrm>
           <a:prstGeom prst="rect">
             <a:avLst/>
@@ -4519,13 +4806,13 @@
       </p:pic>
       <p:sp>
         <p:nvSpPr>
-          <p:cNvPr id="12" name="Shape 7"/>
+          <p:cNvPr id="18" name="Shape 13"/>
           <p:cNvSpPr/>
           <p:nvPr/>
         </p:nvSpPr>
         <p:spPr>
           <a:xfrm>
-            <a:off x="9646920" y="1371600"/>
+            <a:off x="3977640" y="3886200"/>
             <a:ext cx="457200" cy="457200"/>
           </a:xfrm>
           <a:prstGeom prst="ellipse">
@@ -4544,13 +4831,13 @@
       </p:sp>
       <p:sp>
         <p:nvSpPr>
-          <p:cNvPr id="13" name="Text 8"/>
+          <p:cNvPr id="19" name="Text 14"/>
           <p:cNvSpPr txBox="1"/>
           <p:nvPr/>
         </p:nvSpPr>
         <p:spPr>
           <a:xfrm>
-            <a:off x="9646920" y="1371600"/>
+            <a:off x="3977640" y="3886200"/>
             <a:ext cx="457200" cy="457200"/>
           </a:xfrm>
           <a:prstGeom prst="rect">
@@ -4575,7 +4862,7 @@
                 <a:ea typeface="Calibri" pitchFamily="34" charset="-122"/>
                 <a:cs typeface="Calibri" pitchFamily="34" charset="-120"/>
               </a:rPr>
-              <a:t>2</a:t>
+              <a:t>3</a:t>
             </a:r>
             <a:endParaRPr lang="en-US" sz="1600" dirty="0"/>
           </a:p>
@@ -4583,13 +4870,13 @@
       </p:sp>
       <p:sp>
         <p:nvSpPr>
-          <p:cNvPr id="14" name="Text 9"/>
+          <p:cNvPr id="20" name="Text 15"/>
           <p:cNvSpPr txBox="1"/>
           <p:nvPr/>
         </p:nvSpPr>
         <p:spPr>
           <a:xfrm>
-            <a:off x="10195560" y="1371600"/>
+            <a:off x="4526280" y="3886200"/>
             <a:ext cx="1554480" cy="457200"/>
           </a:xfrm>
           <a:prstGeom prst="rect">
@@ -4614,7 +4901,7 @@
                 <a:ea typeface="Cambria" pitchFamily="34" charset="-122"/>
                 <a:cs typeface="Cambria" pitchFamily="34" charset="-120"/>
               </a:rPr>
-              <a:t>Темы пачкой</a:t>
+              <a:t>Мало часов в день</a:t>
             </a:r>
             <a:endParaRPr lang="en-US" sz="1600" dirty="0"/>
           </a:p>
@@ -4622,13 +4909,13 @@
       </p:sp>
       <p:sp>
         <p:nvSpPr>
-          <p:cNvPr id="15" name="Text 10"/>
+          <p:cNvPr id="21" name="Text 16"/>
           <p:cNvSpPr txBox="1"/>
           <p:nvPr/>
         </p:nvSpPr>
         <p:spPr>
           <a:xfrm>
-            <a:off x="9646920" y="1965960"/>
+            <a:off x="3977640" y="4480560"/>
             <a:ext cx="2103120" cy="1645920"/>
           </a:xfrm>
           <a:prstGeom prst="rect">
@@ -4653,7 +4940,7 @@
                 <a:ea typeface="Calibri" pitchFamily="34" charset="-122"/>
                 <a:cs typeface="Calibri" pitchFamily="34" charset="-120"/>
               </a:rPr>
-              <a:t>В окне «Несколько…» отмечаем готовые темы и дописываем свои.</a:t>
+              <a:t>Поставили 2 часа в день, и календарь заполнился почти целиком.</a:t>
             </a:r>
             <a:endParaRPr lang="en-US" sz="1400" dirty="0"/>
           </a:p>
@@ -4661,13 +4948,13 @@
       </p:sp>
       <p:sp>
         <p:nvSpPr>
-          <p:cNvPr id="16" name="Shape 11"/>
+          <p:cNvPr id="22" name="Shape 17"/>
           <p:cNvSpPr/>
           <p:nvPr/>
         </p:nvSpPr>
         <p:spPr>
           <a:xfrm>
-            <a:off x="523566" y="3813048"/>
+            <a:off x="6192846" y="3813048"/>
             <a:ext cx="3296268" cy="2386584"/>
           </a:xfrm>
           <a:prstGeom prst="rect">
@@ -4686,7 +4973,7 @@
       </p:sp>
       <p:pic>
         <p:nvPicPr>
-          <p:cNvPr id="17" name="Image 2" descr="Скриншот программы: s4_risk_calendar.png">    </p:cNvPr>
+          <p:cNvPr id="23" name="Image 2" descr="Скриншот программы: s4_risk_gantt.png">    </p:cNvPr>
           <p:cNvPicPr>
             <a:picLocks noChangeAspect="1"/>
           </p:cNvPicPr>
@@ -4700,7 +4987,7 @@
         </p:blipFill>
         <p:spPr>
           <a:xfrm>
-            <a:off x="550998" y="3840480"/>
+            <a:off x="6220278" y="3840480"/>
             <a:ext cx="3241404" cy="2331720"/>
           </a:xfrm>
           <a:prstGeom prst="rect">
@@ -4710,13 +4997,13 @@
       </p:pic>
       <p:sp>
         <p:nvSpPr>
-          <p:cNvPr id="18" name="Shape 12"/>
+          <p:cNvPr id="24" name="Shape 18"/>
           <p:cNvSpPr/>
           <p:nvPr/>
         </p:nvSpPr>
         <p:spPr>
           <a:xfrm>
-            <a:off x="3977640" y="3886200"/>
+            <a:off x="9646920" y="3886200"/>
             <a:ext cx="457200" cy="457200"/>
           </a:xfrm>
           <a:prstGeom prst="ellipse">
@@ -4735,13 +5022,13 @@
       </p:sp>
       <p:sp>
         <p:nvSpPr>
-          <p:cNvPr id="19" name="Text 13"/>
+          <p:cNvPr id="25" name="Text 19"/>
           <p:cNvSpPr txBox="1"/>
           <p:nvPr/>
         </p:nvSpPr>
         <p:spPr>
           <a:xfrm>
-            <a:off x="3977640" y="3886200"/>
+            <a:off x="9646920" y="3886200"/>
             <a:ext cx="457200" cy="457200"/>
           </a:xfrm>
           <a:prstGeom prst="rect">
@@ -4766,7 +5053,7 @@
                 <a:ea typeface="Calibri" pitchFamily="34" charset="-122"/>
                 <a:cs typeface="Calibri" pitchFamily="34" charset="-120"/>
               </a:rPr>
-              <a:t>3</a:t>
+              <a:t>4</a:t>
             </a:r>
             <a:endParaRPr lang="en-US" sz="1600" dirty="0"/>
           </a:p>
@@ -4774,13 +5061,13 @@
       </p:sp>
       <p:sp>
         <p:nvSpPr>
-          <p:cNvPr id="20" name="Text 14"/>
+          <p:cNvPr id="26" name="Text 20"/>
           <p:cNvSpPr txBox="1"/>
           <p:nvPr/>
         </p:nvSpPr>
         <p:spPr>
           <a:xfrm>
-            <a:off x="4526280" y="3886200"/>
+            <a:off x="10195560" y="3886200"/>
             <a:ext cx="1554480" cy="457200"/>
           </a:xfrm>
           <a:prstGeom prst="rect">
@@ -4805,7 +5092,7 @@
                 <a:ea typeface="Cambria" pitchFamily="34" charset="-122"/>
                 <a:cs typeface="Cambria" pitchFamily="34" charset="-120"/>
               </a:rPr>
-              <a:t>Мало часов в день</a:t>
+              <a:t>Не успеваем</a:t>
             </a:r>
             <a:endParaRPr lang="en-US" sz="1600" dirty="0"/>
           </a:p>
@@ -4813,198 +5100,7 @@
       </p:sp>
       <p:sp>
         <p:nvSpPr>
-          <p:cNvPr id="21" name="Text 15"/>
-          <p:cNvSpPr txBox="1"/>
-          <p:nvPr/>
-        </p:nvSpPr>
-        <p:spPr>
-          <a:xfrm>
-            <a:off x="3977640" y="4480560"/>
-            <a:ext cx="2103120" cy="1645920"/>
-          </a:xfrm>
-          <a:prstGeom prst="rect">
-            <a:avLst/>
-          </a:prstGeom>
-          <a:noFill/>
-          <a:ln/>
-        </p:spPr>
-        <p:txBody>
-          <a:bodyPr wrap="square" lIns="0" tIns="0" rIns="0" bIns="0" rtlCol="0" anchor="t"/>
-          <a:lstStyle/>
-          <a:p>
-            <a:pPr indent="0" marL="0">
-              <a:buNone/>
-            </a:pPr>
-            <a:r>
-              <a:rPr lang="en-US" sz="1400" dirty="0">
-                <a:solidFill>
-                  <a:srgbClr val="0F172A"/>
-                </a:solidFill>
-                <a:latin typeface="Calibri" pitchFamily="34" charset="0"/>
-                <a:ea typeface="Calibri" pitchFamily="34" charset="-122"/>
-                <a:cs typeface="Calibri" pitchFamily="34" charset="-120"/>
-              </a:rPr>
-              <a:t>Поставили 2 часа в день, и календарь заполнился почти целиком.</a:t>
-            </a:r>
-            <a:endParaRPr lang="en-US" sz="1400" dirty="0"/>
-          </a:p>
-        </p:txBody>
-      </p:sp>
-      <p:sp>
-        <p:nvSpPr>
-          <p:cNvPr id="22" name="Shape 16"/>
-          <p:cNvSpPr/>
-          <p:nvPr/>
-        </p:nvSpPr>
-        <p:spPr>
-          <a:xfrm>
-            <a:off x="6192846" y="3813048"/>
-            <a:ext cx="3296268" cy="2386584"/>
-          </a:xfrm>
-          <a:prstGeom prst="rect">
-            <a:avLst/>
-          </a:prstGeom>
-          <a:solidFill>
-            <a:srgbClr val="FFFFFF"/>
-          </a:solidFill>
-          <a:ln w="9525">
-            <a:solidFill>
-              <a:srgbClr val="CBD5E1"/>
-            </a:solidFill>
-            <a:prstDash val="solid"/>
-          </a:ln>
-        </p:spPr>
-      </p:sp>
-      <p:pic>
-        <p:nvPicPr>
-          <p:cNvPr id="23" name="Image 3" descr="Скриншот программы: s4_risk_gantt.png">    </p:cNvPr>
-          <p:cNvPicPr>
-            <a:picLocks noChangeAspect="1"/>
-          </p:cNvPicPr>
-          <p:nvPr/>
-        </p:nvPicPr>
-        <p:blipFill>
-          <a:blip r:embed="rId4"/>
-          <a:stretch>
-            <a:fillRect/>
-          </a:stretch>
-        </p:blipFill>
-        <p:spPr>
-          <a:xfrm>
-            <a:off x="6220278" y="3840480"/>
-            <a:ext cx="3241404" cy="2331720"/>
-          </a:xfrm>
-          <a:prstGeom prst="rect">
-            <a:avLst/>
-          </a:prstGeom>
-        </p:spPr>
-      </p:pic>
-      <p:sp>
-        <p:nvSpPr>
-          <p:cNvPr id="24" name="Shape 17"/>
-          <p:cNvSpPr/>
-          <p:nvPr/>
-        </p:nvSpPr>
-        <p:spPr>
-          <a:xfrm>
-            <a:off x="9646920" y="3886200"/>
-            <a:ext cx="457200" cy="457200"/>
-          </a:xfrm>
-          <a:prstGeom prst="ellipse">
-            <a:avLst/>
-          </a:prstGeom>
-          <a:solidFill>
-            <a:srgbClr val="4F46E5"/>
-          </a:solidFill>
-          <a:ln w="12700">
-            <a:solidFill>
-              <a:srgbClr val="4F46E5"/>
-            </a:solidFill>
-            <a:prstDash val="solid"/>
-          </a:ln>
-        </p:spPr>
-      </p:sp>
-      <p:sp>
-        <p:nvSpPr>
-          <p:cNvPr id="25" name="Text 18"/>
-          <p:cNvSpPr txBox="1"/>
-          <p:nvPr/>
-        </p:nvSpPr>
-        <p:spPr>
-          <a:xfrm>
-            <a:off x="9646920" y="3886200"/>
-            <a:ext cx="457200" cy="457200"/>
-          </a:xfrm>
-          <a:prstGeom prst="rect">
-            <a:avLst/>
-          </a:prstGeom>
-          <a:noFill/>
-          <a:ln/>
-        </p:spPr>
-        <p:txBody>
-          <a:bodyPr wrap="square" lIns="0" tIns="0" rIns="0" bIns="0" rtlCol="0" anchor="ctr"/>
-          <a:lstStyle/>
-          <a:p>
-            <a:pPr algn="ctr" indent="0" marL="0">
-              <a:buNone/>
-            </a:pPr>
-            <a:r>
-              <a:rPr lang="en-US" sz="1600" b="1" dirty="0">
-                <a:solidFill>
-                  <a:srgbClr val="FFFFFF"/>
-                </a:solidFill>
-                <a:latin typeface="Calibri" pitchFamily="34" charset="0"/>
-                <a:ea typeface="Calibri" pitchFamily="34" charset="-122"/>
-                <a:cs typeface="Calibri" pitchFamily="34" charset="-120"/>
-              </a:rPr>
-              <a:t>4</a:t>
-            </a:r>
-            <a:endParaRPr lang="en-US" sz="1600" dirty="0"/>
-          </a:p>
-        </p:txBody>
-      </p:sp>
-      <p:sp>
-        <p:nvSpPr>
-          <p:cNvPr id="26" name="Text 19"/>
-          <p:cNvSpPr txBox="1"/>
-          <p:nvPr/>
-        </p:nvSpPr>
-        <p:spPr>
-          <a:xfrm>
-            <a:off x="10195560" y="3886200"/>
-            <a:ext cx="1554480" cy="457200"/>
-          </a:xfrm>
-          <a:prstGeom prst="rect">
-            <a:avLst/>
-          </a:prstGeom>
-          <a:noFill/>
-          <a:ln/>
-        </p:spPr>
-        <p:txBody>
-          <a:bodyPr wrap="square" lIns="0" tIns="0" rIns="0" bIns="0" rtlCol="0" anchor="ctr"/>
-          <a:lstStyle/>
-          <a:p>
-            <a:pPr indent="0" marL="0">
-              <a:buNone/>
-            </a:pPr>
-            <a:r>
-              <a:rPr lang="en-US" sz="1600" b="1" dirty="0">
-                <a:solidFill>
-                  <a:srgbClr val="1E1B4B"/>
-                </a:solidFill>
-                <a:latin typeface="Cambria" pitchFamily="34" charset="0"/>
-                <a:ea typeface="Cambria" pitchFamily="34" charset="-122"/>
-                <a:cs typeface="Cambria" pitchFamily="34" charset="-120"/>
-              </a:rPr>
-              <a:t>Не успеваем</a:t>
-            </a:r>
-            <a:endParaRPr lang="en-US" sz="1600" dirty="0"/>
-          </a:p>
-        </p:txBody>
-      </p:sp>
-      <p:sp>
-        <p:nvSpPr>
-          <p:cNvPr id="27" name="Text 20"/>
+          <p:cNvPr id="27" name="Text 21"/>
           <p:cNvSpPr txBox="1"/>
           <p:nvPr/>
         </p:nvSpPr>
@@ -6295,96 +6391,160 @@
         </p:nvSpPr>
         <p:spPr>
           <a:xfrm>
-            <a:off x="7882942" y="1344168"/>
-            <a:ext cx="3463948" cy="2615184"/>
+            <a:off x="7589520" y="1371600"/>
+            <a:ext cx="4050792" cy="2560320"/>
           </a:xfrm>
           <a:prstGeom prst="rect">
             <a:avLst/>
           </a:prstGeom>
           <a:solidFill>
-            <a:srgbClr val="FFFFFF"/>
+            <a:srgbClr val="E2E8F0"/>
           </a:solidFill>
-          <a:ln w="9525">
+          <a:ln w="12700">
             <a:solidFill>
-              <a:srgbClr val="CBD5E1"/>
+              <a:srgbClr val="94A3B8"/>
             </a:solidFill>
-            <a:prstDash val="solid"/>
+            <a:prstDash val="dash"/>
           </a:ln>
         </p:spPr>
       </p:sp>
-      <p:pic>
-        <p:nvPicPr>
-          <p:cNvPr id="6" name="Image 0" descr="Скриншот программы: 03_dialog.png">    </p:cNvPr>
-          <p:cNvPicPr>
-            <a:picLocks noChangeAspect="1"/>
-          </p:cNvPicPr>
-          <p:nvPr/>
-        </p:nvPicPr>
-        <p:blipFill>
-          <a:blip r:embed="rId1"/>
-          <a:stretch>
-            <a:fillRect/>
-          </a:stretch>
-        </p:blipFill>
-        <p:spPr>
-          <a:xfrm>
-            <a:off x="7910374" y="1371600"/>
-            <a:ext cx="3409084" cy="2560320"/>
-          </a:xfrm>
-          <a:prstGeom prst="rect">
-            <a:avLst/>
-          </a:prstGeom>
-        </p:spPr>
-      </p:pic>
-      <p:sp>
-        <p:nvSpPr>
-          <p:cNvPr id="7" name="Shape 2"/>
+      <p:sp>
+        <p:nvSpPr>
+          <p:cNvPr id="6" name="Text 2"/>
+          <p:cNvSpPr txBox="1"/>
+          <p:nvPr/>
+        </p:nvSpPr>
+        <p:spPr>
+          <a:xfrm>
+            <a:off x="7589520" y="1371600"/>
+            <a:ext cx="4050792" cy="2560320"/>
+          </a:xfrm>
+          <a:prstGeom prst="rect">
+            <a:avLst/>
+          </a:prstGeom>
+          <a:noFill/>
+          <a:ln/>
+        </p:spPr>
+        <p:txBody>
+          <a:bodyPr wrap="square" rtlCol="0" anchor="ctr"/>
+          <a:lstStyle/>
+          <a:p>
+            <a:pPr algn="ctr" indent="0" marL="0">
+              <a:buNone/>
+            </a:pPr>
+            <a:r>
+              <a:rPr lang="en-US" sz="1600" dirty="0">
+                <a:solidFill>
+                  <a:srgbClr val="64748B"/>
+                </a:solidFill>
+                <a:latin typeface="Calibri" pitchFamily="34" charset="0"/>
+                <a:ea typeface="Calibri" pitchFamily="34" charset="-122"/>
+                <a:cs typeface="Calibri" pitchFamily="34" charset="-120"/>
+              </a:rPr>
+              <a:t>Здесь будет скриншот</a:t>
+            </a:r>
+            <a:endParaRPr lang="en-US" sz="1600" dirty="0"/>
+          </a:p>
+          <a:p>
+            <a:pPr algn="ctr" indent="0" marL="0">
+              <a:buNone/>
+            </a:pPr>
+            <a:r>
+              <a:rPr lang="en-US" sz="1600" dirty="0">
+                <a:solidFill>
+                  <a:srgbClr val="64748B"/>
+                </a:solidFill>
+                <a:latin typeface="Calibri" pitchFamily="34" charset="0"/>
+                <a:ea typeface="Calibri" pitchFamily="34" charset="-122"/>
+                <a:cs typeface="Calibri" pitchFamily="34" charset="-120"/>
+              </a:rPr>
+              <a:t>03_dialog.png</a:t>
+            </a:r>
+            <a:endParaRPr lang="en-US" sz="1600" dirty="0"/>
+          </a:p>
+        </p:txBody>
+      </p:sp>
+      <p:sp>
+        <p:nvSpPr>
+          <p:cNvPr id="7" name="Shape 3"/>
           <p:cNvSpPr/>
           <p:nvPr/>
         </p:nvSpPr>
         <p:spPr>
           <a:xfrm>
-            <a:off x="7906080" y="4087368"/>
-            <a:ext cx="3417672" cy="2066544"/>
+            <a:off x="7589520" y="4114800"/>
+            <a:ext cx="4050792" cy="2011680"/>
           </a:xfrm>
           <a:prstGeom prst="rect">
             <a:avLst/>
           </a:prstGeom>
           <a:solidFill>
-            <a:srgbClr val="FFFFFF"/>
+            <a:srgbClr val="E2E8F0"/>
           </a:solidFill>
-          <a:ln w="9525">
+          <a:ln w="12700">
             <a:solidFill>
-              <a:srgbClr val="CBD5E1"/>
+              <a:srgbClr val="94A3B8"/>
             </a:solidFill>
-            <a:prstDash val="solid"/>
+            <a:prstDash val="dash"/>
           </a:ln>
         </p:spPr>
       </p:sp>
-      <p:pic>
-        <p:nvPicPr>
-          <p:cNvPr id="8" name="Image 1" descr="Скриншот программы: 04_error.png">    </p:cNvPr>
-          <p:cNvPicPr>
-            <a:picLocks noChangeAspect="1"/>
-          </p:cNvPicPr>
-          <p:nvPr/>
-        </p:nvPicPr>
-        <p:blipFill>
-          <a:blip r:embed="rId2"/>
-          <a:stretch>
-            <a:fillRect/>
-          </a:stretch>
-        </p:blipFill>
-        <p:spPr>
-          <a:xfrm>
-            <a:off x="7933512" y="4114800"/>
-            <a:ext cx="3362808" cy="2011680"/>
-          </a:xfrm>
-          <a:prstGeom prst="rect">
-            <a:avLst/>
-          </a:prstGeom>
-        </p:spPr>
-      </p:pic>
+      <p:sp>
+        <p:nvSpPr>
+          <p:cNvPr id="8" name="Text 4"/>
+          <p:cNvSpPr txBox="1"/>
+          <p:nvPr/>
+        </p:nvSpPr>
+        <p:spPr>
+          <a:xfrm>
+            <a:off x="7589520" y="4114800"/>
+            <a:ext cx="4050792" cy="2011680"/>
+          </a:xfrm>
+          <a:prstGeom prst="rect">
+            <a:avLst/>
+          </a:prstGeom>
+          <a:noFill/>
+          <a:ln/>
+        </p:spPr>
+        <p:txBody>
+          <a:bodyPr wrap="square" rtlCol="0" anchor="ctr"/>
+          <a:lstStyle/>
+          <a:p>
+            <a:pPr algn="ctr" indent="0" marL="0">
+              <a:buNone/>
+            </a:pPr>
+            <a:r>
+              <a:rPr lang="en-US" sz="1600" dirty="0">
+                <a:solidFill>
+                  <a:srgbClr val="64748B"/>
+                </a:solidFill>
+                <a:latin typeface="Calibri" pitchFamily="34" charset="0"/>
+                <a:ea typeface="Calibri" pitchFamily="34" charset="-122"/>
+                <a:cs typeface="Calibri" pitchFamily="34" charset="-120"/>
+              </a:rPr>
+              <a:t>Здесь будет скриншот</a:t>
+            </a:r>
+            <a:endParaRPr lang="en-US" sz="1600" dirty="0"/>
+          </a:p>
+          <a:p>
+            <a:pPr algn="ctr" indent="0" marL="0">
+              <a:buNone/>
+            </a:pPr>
+            <a:r>
+              <a:rPr lang="en-US" sz="1600" dirty="0">
+                <a:solidFill>
+                  <a:srgbClr val="64748B"/>
+                </a:solidFill>
+                <a:latin typeface="Calibri" pitchFamily="34" charset="0"/>
+                <a:ea typeface="Calibri" pitchFamily="34" charset="-122"/>
+                <a:cs typeface="Calibri" pitchFamily="34" charset="-120"/>
+              </a:rPr>
+              <a:t>04_error.png</a:t>
+            </a:r>
+            <a:endParaRPr lang="en-US" sz="1600" dirty="0"/>
+          </a:p>
+        </p:txBody>
+      </p:sp>
       <p:sp>
         <p:nvSpPr>
           <p:cNvPr id="25" name="Slide Number Placeholder 0"/>
@@ -6564,7 +6724,7 @@
                 <a:ea typeface="Cambria" pitchFamily="34" charset="-122"/>
                 <a:cs typeface="Cambria" pitchFamily="34" charset="-120"/>
               </a:rPr>
-              <a:t>70</a:t>
+              <a:t>80</a:t>
             </a:r>
             <a:endParaRPr lang="en-US" sz="11000" dirty="0"/>
           </a:p>
@@ -8758,7 +8918,7 @@
                 <a:ea typeface="Calibri" pitchFamily="34" charset="-122"/>
                 <a:cs typeface="Calibri" pitchFamily="34" charset="-120"/>
               </a:rPr>
-              <a:t>70 автотестов</a:t>
+              <a:t>80 автотестов</a:t>
             </a:r>
             <a:endParaRPr lang="en-US" sz="1600" dirty="0"/>
           </a:p>

</xml_diff>

<commit_message>
Spread each event's hours evenly over the whole period before the exam
Co-Authored-By: Claude Sonnet 5.5 <noreply@anthropic.com>
</commit_message>
<xml_diff>
--- a/docs/Презентация_Планировщик_экзаменов.pptx
+++ b/docs/Презентация_Планировщик_экзаменов.pptx
@@ -1312,7 +1312,7 @@
           <a:p>
             <a:r>
               <a:rPr lang="en-US" dirty="0"/>
-              <a:t>Логику проверяют 80 автотестов, все проходят. Они смотрят на неверный ввод, лимиты часов, день повторения, распределение по дням, перепланирование, автоподбор сложности и битые файлы. Окно мы проверяли руками.</a:t>
+              <a:t>Логику проверяют 83 автотеста, все проходят. Они смотрят на неверный ввод, лимиты часов, день повторения, распределение по дням, перепланирование, автоподбор сложности и битые файлы. Окно мы проверяли руками.</a:t>
             </a:r>
             <a:endParaRPr lang="en-US" dirty="0"/>
           </a:p>
@@ -1752,7 +1752,7 @@
           <a:p>
             <a:r>
               <a:rPr lang="en-US" dirty="0"/>
-              <a:t>Что умеет программа. Добавлять экзамены и контрольные с датами. Выбирать темы из списков или вписывать свои, причём можно сразу несколько. Сложность подбирается по названию, её можно поправить. План учитывает лимит часов в день и не сваливает большую тему в один день. Если вы отстали, есть кнопка «Перепланировать». Всё видно в календаре и на диаграмме Ганта, и всё сохраняется в файлы.</a:t>
+              <a:t>Что умеет программа. Добавлять экзамены и контрольные с датами. Выбирать темы из списков или вписывать свои, причём можно сразу несколько. Сложность подбирается по названию, её можно поправить. План учитывает лимит часов в день и раскладывает занятия равномерно до самого экзамена. Если вы отстали, есть кнопка «Перепланировать». Всё видно в календаре и на диаграмме Ганта, и всё сохраняется в файлы.</a:t>
             </a:r>
             <a:endParaRPr lang="en-US" dirty="0"/>
           </a:p>
@@ -1840,7 +1840,7 @@
           <a:p>
             <a:r>
               <a:rPr lang="en-US" dirty="0"/>
-              <a:t>Правила простые. Сложность от одного до пяти равна числу часов на тему. В день не больше четырёх часов, и не больше двух часов одной темы, так что тема на пять часов растянется на три дня: два, два и один. Первыми идут сложные темы ближайшего экзамена. Накануне экзамена только повторение, а в сам день ничего.</a:t>
+              <a:t>Правила простые. Сложность от одного до пяти равна числу часов на тему. Часы события делятся поровну на все дни до экзамена: если тем мало, занятия идут через день-два, а не в первый же день. В день не больше четырёх часов и не больше двух часов одной темы. Первыми идут сложные темы ближайшего экзамена. Накануне экзамена только повторение, а в сам день ничего.</a:t>
             </a:r>
             <a:endParaRPr lang="en-US" dirty="0"/>
           </a:p>
@@ -3200,8 +3200,8 @@
         </p:nvSpPr>
         <p:spPr>
           <a:xfrm>
-            <a:off x="521208" y="1456289"/>
-            <a:ext cx="11146536" cy="4585502"/>
+            <a:off x="1015786" y="1207008"/>
+            <a:ext cx="10157380" cy="5084064"/>
           </a:xfrm>
           <a:prstGeom prst="rect">
             <a:avLst/>
@@ -3233,8 +3233,8 @@
         </p:blipFill>
         <p:spPr>
           <a:xfrm>
-            <a:off x="548640" y="1483721"/>
-            <a:ext cx="11091672" cy="4530638"/>
+            <a:off x="1043218" y="1234440"/>
+            <a:ext cx="10102516" cy="5029200"/>
           </a:xfrm>
           <a:prstGeom prst="rect">
             <a:avLst/>
@@ -3683,82 +3683,50 @@
         </p:nvSpPr>
         <p:spPr>
           <a:xfrm>
-            <a:off x="548640" y="1280160"/>
-            <a:ext cx="7589520" cy="4937760"/>
+            <a:off x="883893" y="1252728"/>
+            <a:ext cx="6919015" cy="4992624"/>
           </a:xfrm>
           <a:prstGeom prst="rect">
             <a:avLst/>
           </a:prstGeom>
           <a:solidFill>
-            <a:srgbClr val="E2E8F0"/>
+            <a:srgbClr val="FFFFFF"/>
           </a:solidFill>
-          <a:ln w="12700">
+          <a:ln w="9525">
             <a:solidFill>
-              <a:srgbClr val="94A3B8"/>
+              <a:srgbClr val="CBD5E1"/>
             </a:solidFill>
-            <a:prstDash val="dash"/>
+            <a:prstDash val="solid"/>
           </a:ln>
         </p:spPr>
       </p:sp>
-      <p:sp>
-        <p:nvSpPr>
-          <p:cNvPr id="5" name="Text 2"/>
-          <p:cNvSpPr txBox="1"/>
-          <p:nvPr/>
-        </p:nvSpPr>
-        <p:spPr>
-          <a:xfrm>
-            <a:off x="548640" y="1280160"/>
-            <a:ext cx="7589520" cy="4937760"/>
-          </a:xfrm>
-          <a:prstGeom prst="rect">
-            <a:avLst/>
-          </a:prstGeom>
-          <a:noFill/>
-          <a:ln/>
-        </p:spPr>
-        <p:txBody>
-          <a:bodyPr wrap="square" rtlCol="0" anchor="ctr"/>
-          <a:lstStyle/>
-          <a:p>
-            <a:pPr algn="ctr" indent="0" marL="0">
-              <a:buNone/>
-            </a:pPr>
-            <a:r>
-              <a:rPr lang="en-US" sz="1600" dirty="0">
-                <a:solidFill>
-                  <a:srgbClr val="64748B"/>
-                </a:solidFill>
-                <a:latin typeface="Calibri" pitchFamily="34" charset="0"/>
-                <a:ea typeface="Calibri" pitchFamily="34" charset="-122"/>
-                <a:cs typeface="Calibri" pitchFamily="34" charset="-120"/>
-              </a:rPr>
-              <a:t>Здесь будет скриншот</a:t>
-            </a:r>
-            <a:endParaRPr lang="en-US" sz="1600" dirty="0"/>
-          </a:p>
-          <a:p>
-            <a:pPr algn="ctr" indent="0" marL="0">
-              <a:buNone/>
-            </a:pPr>
-            <a:r>
-              <a:rPr lang="en-US" sz="1600" dirty="0">
-                <a:solidFill>
-                  <a:srgbClr val="64748B"/>
-                </a:solidFill>
-                <a:latin typeface="Calibri" pitchFamily="34" charset="0"/>
-                <a:ea typeface="Calibri" pitchFamily="34" charset="-122"/>
-                <a:cs typeface="Calibri" pitchFamily="34" charset="-120"/>
-              </a:rPr>
-              <a:t>01_calendar.png</a:t>
-            </a:r>
-            <a:endParaRPr lang="en-US" sz="1600" dirty="0"/>
-          </a:p>
-        </p:txBody>
-      </p:sp>
-      <p:sp>
-        <p:nvSpPr>
-          <p:cNvPr id="6" name="Shape 3"/>
+      <p:pic>
+        <p:nvPicPr>
+          <p:cNvPr id="5" name="Image 0" descr="Скриншот программы: 01_calendar.png">    </p:cNvPr>
+          <p:cNvPicPr>
+            <a:picLocks noChangeAspect="1"/>
+          </p:cNvPicPr>
+          <p:nvPr/>
+        </p:nvPicPr>
+        <p:blipFill>
+          <a:blip r:embed="rId1"/>
+          <a:stretch>
+            <a:fillRect/>
+          </a:stretch>
+        </p:blipFill>
+        <p:spPr>
+          <a:xfrm>
+            <a:off x="911325" y="1280160"/>
+            <a:ext cx="6864151" cy="4937760"/>
+          </a:xfrm>
+          <a:prstGeom prst="rect">
+            <a:avLst/>
+          </a:prstGeom>
+        </p:spPr>
+      </p:pic>
+      <p:sp>
+        <p:nvSpPr>
+          <p:cNvPr id="6" name="Shape 2"/>
           <p:cNvSpPr/>
           <p:nvPr/>
         </p:nvSpPr>
@@ -3792,7 +3760,7 @@
       </p:sp>
       <p:sp>
         <p:nvSpPr>
-          <p:cNvPr id="7" name="Text 4"/>
+          <p:cNvPr id="7" name="Text 3"/>
           <p:cNvSpPr txBox="1"/>
           <p:nvPr/>
         </p:nvSpPr>
@@ -4016,82 +3984,50 @@
         </p:nvSpPr>
         <p:spPr>
           <a:xfrm>
-            <a:off x="548640" y="1280160"/>
-            <a:ext cx="7589520" cy="4937760"/>
+            <a:off x="883893" y="1252728"/>
+            <a:ext cx="6919015" cy="4992624"/>
           </a:xfrm>
           <a:prstGeom prst="rect">
             <a:avLst/>
           </a:prstGeom>
           <a:solidFill>
-            <a:srgbClr val="E2E8F0"/>
+            <a:srgbClr val="FFFFFF"/>
           </a:solidFill>
-          <a:ln w="12700">
+          <a:ln w="9525">
             <a:solidFill>
-              <a:srgbClr val="94A3B8"/>
+              <a:srgbClr val="CBD5E1"/>
             </a:solidFill>
-            <a:prstDash val="dash"/>
+            <a:prstDash val="solid"/>
           </a:ln>
         </p:spPr>
       </p:sp>
-      <p:sp>
-        <p:nvSpPr>
-          <p:cNvPr id="5" name="Text 2"/>
-          <p:cNvSpPr txBox="1"/>
-          <p:nvPr/>
-        </p:nvSpPr>
-        <p:spPr>
-          <a:xfrm>
-            <a:off x="548640" y="1280160"/>
-            <a:ext cx="7589520" cy="4937760"/>
-          </a:xfrm>
-          <a:prstGeom prst="rect">
-            <a:avLst/>
-          </a:prstGeom>
-          <a:noFill/>
-          <a:ln/>
-        </p:spPr>
-        <p:txBody>
-          <a:bodyPr wrap="square" rtlCol="0" anchor="ctr"/>
-          <a:lstStyle/>
-          <a:p>
-            <a:pPr algn="ctr" indent="0" marL="0">
-              <a:buNone/>
-            </a:pPr>
-            <a:r>
-              <a:rPr lang="en-US" sz="1600" dirty="0">
-                <a:solidFill>
-                  <a:srgbClr val="64748B"/>
-                </a:solidFill>
-                <a:latin typeface="Calibri" pitchFamily="34" charset="0"/>
-                <a:ea typeface="Calibri" pitchFamily="34" charset="-122"/>
-                <a:cs typeface="Calibri" pitchFamily="34" charset="-120"/>
-              </a:rPr>
-              <a:t>Здесь будет скриншот</a:t>
-            </a:r>
-            <a:endParaRPr lang="en-US" sz="1600" dirty="0"/>
-          </a:p>
-          <a:p>
-            <a:pPr algn="ctr" indent="0" marL="0">
-              <a:buNone/>
-            </a:pPr>
-            <a:r>
-              <a:rPr lang="en-US" sz="1600" dirty="0">
-                <a:solidFill>
-                  <a:srgbClr val="64748B"/>
-                </a:solidFill>
-                <a:latin typeface="Calibri" pitchFamily="34" charset="0"/>
-                <a:ea typeface="Calibri" pitchFamily="34" charset="-122"/>
-                <a:cs typeface="Calibri" pitchFamily="34" charset="-120"/>
-              </a:rPr>
-              <a:t>02_gantt.png</a:t>
-            </a:r>
-            <a:endParaRPr lang="en-US" sz="1600" dirty="0"/>
-          </a:p>
-        </p:txBody>
-      </p:sp>
-      <p:sp>
-        <p:nvSpPr>
-          <p:cNvPr id="6" name="Shape 3"/>
+      <p:pic>
+        <p:nvPicPr>
+          <p:cNvPr id="5" name="Image 0" descr="Скриншот программы: 02_gantt.png">    </p:cNvPr>
+          <p:cNvPicPr>
+            <a:picLocks noChangeAspect="1"/>
+          </p:cNvPicPr>
+          <p:nvPr/>
+        </p:nvPicPr>
+        <p:blipFill>
+          <a:blip r:embed="rId1"/>
+          <a:stretch>
+            <a:fillRect/>
+          </a:stretch>
+        </p:blipFill>
+        <p:spPr>
+          <a:xfrm>
+            <a:off x="911325" y="1280160"/>
+            <a:ext cx="6864151" cy="4937760"/>
+          </a:xfrm>
+          <a:prstGeom prst="rect">
+            <a:avLst/>
+          </a:prstGeom>
+        </p:spPr>
+      </p:pic>
+      <p:sp>
+        <p:nvSpPr>
+          <p:cNvPr id="6" name="Shape 2"/>
           <p:cNvSpPr/>
           <p:nvPr/>
         </p:nvSpPr>
@@ -4125,7 +4061,7 @@
       </p:sp>
       <p:sp>
         <p:nvSpPr>
-          <p:cNvPr id="7" name="Text 4"/>
+          <p:cNvPr id="7" name="Text 3"/>
           <p:cNvSpPr txBox="1"/>
           <p:nvPr/>
         </p:nvSpPr>
@@ -4540,82 +4476,50 @@
         </p:nvSpPr>
         <p:spPr>
           <a:xfrm>
-            <a:off x="6217920" y="1325880"/>
-            <a:ext cx="3246120" cy="2331720"/>
+            <a:off x="6261197" y="1298448"/>
+            <a:ext cx="3159565" cy="2386584"/>
           </a:xfrm>
           <a:prstGeom prst="rect">
             <a:avLst/>
           </a:prstGeom>
           <a:solidFill>
-            <a:srgbClr val="E2E8F0"/>
+            <a:srgbClr val="FFFFFF"/>
           </a:solidFill>
-          <a:ln w="12700">
+          <a:ln w="9525">
             <a:solidFill>
-              <a:srgbClr val="94A3B8"/>
+              <a:srgbClr val="CBD5E1"/>
             </a:solidFill>
-            <a:prstDash val="dash"/>
+            <a:prstDash val="solid"/>
           </a:ln>
         </p:spPr>
       </p:sp>
-      <p:sp>
-        <p:nvSpPr>
-          <p:cNvPr id="11" name="Text 7"/>
-          <p:cNvSpPr txBox="1"/>
-          <p:nvPr/>
-        </p:nvSpPr>
-        <p:spPr>
-          <a:xfrm>
-            <a:off x="6217920" y="1325880"/>
-            <a:ext cx="3246120" cy="2331720"/>
-          </a:xfrm>
-          <a:prstGeom prst="rect">
-            <a:avLst/>
-          </a:prstGeom>
-          <a:noFill/>
-          <a:ln/>
-        </p:spPr>
-        <p:txBody>
-          <a:bodyPr wrap="square" rtlCol="0" anchor="ctr"/>
-          <a:lstStyle/>
-          <a:p>
-            <a:pPr algn="ctr" indent="0" marL="0">
-              <a:buNone/>
-            </a:pPr>
-            <a:r>
-              <a:rPr lang="en-US" sz="1600" dirty="0">
-                <a:solidFill>
-                  <a:srgbClr val="64748B"/>
-                </a:solidFill>
-                <a:latin typeface="Calibri" pitchFamily="34" charset="0"/>
-                <a:ea typeface="Calibri" pitchFamily="34" charset="-122"/>
-                <a:cs typeface="Calibri" pitchFamily="34" charset="-120"/>
-              </a:rPr>
-              <a:t>Здесь будет скриншот</a:t>
-            </a:r>
-            <a:endParaRPr lang="en-US" sz="1600" dirty="0"/>
-          </a:p>
-          <a:p>
-            <a:pPr algn="ctr" indent="0" marL="0">
-              <a:buNone/>
-            </a:pPr>
-            <a:r>
-              <a:rPr lang="en-US" sz="1600" dirty="0">
-                <a:solidFill>
-                  <a:srgbClr val="64748B"/>
-                </a:solidFill>
-                <a:latin typeface="Calibri" pitchFamily="34" charset="0"/>
-                <a:ea typeface="Calibri" pitchFamily="34" charset="-122"/>
-                <a:cs typeface="Calibri" pitchFamily="34" charset="-120"/>
-              </a:rPr>
-              <a:t>03_dialog.png</a:t>
-            </a:r>
-            <a:endParaRPr lang="en-US" sz="1600" dirty="0"/>
-          </a:p>
-        </p:txBody>
-      </p:sp>
-      <p:sp>
-        <p:nvSpPr>
-          <p:cNvPr id="12" name="Shape 8"/>
+      <p:pic>
+        <p:nvPicPr>
+          <p:cNvPr id="11" name="Image 1" descr="Скриншот программы: 03_dialog.png">    </p:cNvPr>
+          <p:cNvPicPr>
+            <a:picLocks noChangeAspect="1"/>
+          </p:cNvPicPr>
+          <p:nvPr/>
+        </p:nvPicPr>
+        <p:blipFill>
+          <a:blip r:embed="rId2"/>
+          <a:stretch>
+            <a:fillRect/>
+          </a:stretch>
+        </p:blipFill>
+        <p:spPr>
+          <a:xfrm>
+            <a:off x="6288629" y="1325880"/>
+            <a:ext cx="3104701" cy="2331720"/>
+          </a:xfrm>
+          <a:prstGeom prst="rect">
+            <a:avLst/>
+          </a:prstGeom>
+        </p:spPr>
+      </p:pic>
+      <p:sp>
+        <p:nvSpPr>
+          <p:cNvPr id="12" name="Shape 7"/>
           <p:cNvSpPr/>
           <p:nvPr/>
         </p:nvSpPr>
@@ -4640,7 +4544,7 @@
       </p:sp>
       <p:sp>
         <p:nvSpPr>
-          <p:cNvPr id="13" name="Text 9"/>
+          <p:cNvPr id="13" name="Text 8"/>
           <p:cNvSpPr txBox="1"/>
           <p:nvPr/>
         </p:nvSpPr>
@@ -4679,7 +4583,7 @@
       </p:sp>
       <p:sp>
         <p:nvSpPr>
-          <p:cNvPr id="14" name="Text 10"/>
+          <p:cNvPr id="14" name="Text 9"/>
           <p:cNvSpPr txBox="1"/>
           <p:nvPr/>
         </p:nvSpPr>
@@ -4718,7 +4622,7 @@
       </p:sp>
       <p:sp>
         <p:nvSpPr>
-          <p:cNvPr id="15" name="Text 11"/>
+          <p:cNvPr id="15" name="Text 10"/>
           <p:cNvSpPr txBox="1"/>
           <p:nvPr/>
         </p:nvSpPr>
@@ -4757,7 +4661,7 @@
       </p:sp>
       <p:sp>
         <p:nvSpPr>
-          <p:cNvPr id="16" name="Shape 12"/>
+          <p:cNvPr id="16" name="Shape 11"/>
           <p:cNvSpPr/>
           <p:nvPr/>
         </p:nvSpPr>
@@ -4782,14 +4686,14 @@
       </p:sp>
       <p:pic>
         <p:nvPicPr>
-          <p:cNvPr id="17" name="Image 1" descr="Скриншот программы: s4_risk_calendar.png">    </p:cNvPr>
+          <p:cNvPr id="17" name="Image 2" descr="Скриншот программы: s4_risk_calendar.png">    </p:cNvPr>
           <p:cNvPicPr>
             <a:picLocks noChangeAspect="1"/>
           </p:cNvPicPr>
           <p:nvPr/>
         </p:nvPicPr>
         <p:blipFill>
-          <a:blip r:embed="rId2"/>
+          <a:blip r:embed="rId3"/>
           <a:stretch>
             <a:fillRect/>
           </a:stretch>
@@ -4806,7 +4710,7 @@
       </p:pic>
       <p:sp>
         <p:nvSpPr>
-          <p:cNvPr id="18" name="Shape 13"/>
+          <p:cNvPr id="18" name="Shape 12"/>
           <p:cNvSpPr/>
           <p:nvPr/>
         </p:nvSpPr>
@@ -4831,7 +4735,7 @@
       </p:sp>
       <p:sp>
         <p:nvSpPr>
-          <p:cNvPr id="19" name="Text 14"/>
+          <p:cNvPr id="19" name="Text 13"/>
           <p:cNvSpPr txBox="1"/>
           <p:nvPr/>
         </p:nvSpPr>
@@ -4870,7 +4774,7 @@
       </p:sp>
       <p:sp>
         <p:nvSpPr>
-          <p:cNvPr id="20" name="Text 15"/>
+          <p:cNvPr id="20" name="Text 14"/>
           <p:cNvSpPr txBox="1"/>
           <p:nvPr/>
         </p:nvSpPr>
@@ -4909,7 +4813,7 @@
       </p:sp>
       <p:sp>
         <p:nvSpPr>
-          <p:cNvPr id="21" name="Text 16"/>
+          <p:cNvPr id="21" name="Text 15"/>
           <p:cNvSpPr txBox="1"/>
           <p:nvPr/>
         </p:nvSpPr>
@@ -4948,7 +4852,7 @@
       </p:sp>
       <p:sp>
         <p:nvSpPr>
-          <p:cNvPr id="22" name="Shape 17"/>
+          <p:cNvPr id="22" name="Shape 16"/>
           <p:cNvSpPr/>
           <p:nvPr/>
         </p:nvSpPr>
@@ -4973,14 +4877,14 @@
       </p:sp>
       <p:pic>
         <p:nvPicPr>
-          <p:cNvPr id="23" name="Image 2" descr="Скриншот программы: s4_risk_gantt.png">    </p:cNvPr>
+          <p:cNvPr id="23" name="Image 3" descr="Скриншот программы: s4_risk_gantt.png">    </p:cNvPr>
           <p:cNvPicPr>
             <a:picLocks noChangeAspect="1"/>
           </p:cNvPicPr>
           <p:nvPr/>
         </p:nvPicPr>
         <p:blipFill>
-          <a:blip r:embed="rId3"/>
+          <a:blip r:embed="rId4"/>
           <a:stretch>
             <a:fillRect/>
           </a:stretch>
@@ -4997,7 +4901,7 @@
       </p:pic>
       <p:sp>
         <p:nvSpPr>
-          <p:cNvPr id="24" name="Shape 18"/>
+          <p:cNvPr id="24" name="Shape 17"/>
           <p:cNvSpPr/>
           <p:nvPr/>
         </p:nvSpPr>
@@ -5022,7 +4926,7 @@
       </p:sp>
       <p:sp>
         <p:nvSpPr>
-          <p:cNvPr id="25" name="Text 19"/>
+          <p:cNvPr id="25" name="Text 18"/>
           <p:cNvSpPr txBox="1"/>
           <p:nvPr/>
         </p:nvSpPr>
@@ -5061,7 +4965,7 @@
       </p:sp>
       <p:sp>
         <p:nvSpPr>
-          <p:cNvPr id="26" name="Text 20"/>
+          <p:cNvPr id="26" name="Text 19"/>
           <p:cNvSpPr txBox="1"/>
           <p:nvPr/>
         </p:nvSpPr>
@@ -5100,7 +5004,7 @@
       </p:sp>
       <p:sp>
         <p:nvSpPr>
-          <p:cNvPr id="27" name="Text 21"/>
+          <p:cNvPr id="27" name="Text 20"/>
           <p:cNvSpPr txBox="1"/>
           <p:nvPr/>
         </p:nvSpPr>
@@ -6391,8 +6295,57 @@
         </p:nvSpPr>
         <p:spPr>
           <a:xfrm>
-            <a:off x="7589520" y="1371600"/>
-            <a:ext cx="4050792" cy="2560320"/>
+            <a:off x="7882942" y="1344168"/>
+            <a:ext cx="3463948" cy="2615184"/>
+          </a:xfrm>
+          <a:prstGeom prst="rect">
+            <a:avLst/>
+          </a:prstGeom>
+          <a:solidFill>
+            <a:srgbClr val="FFFFFF"/>
+          </a:solidFill>
+          <a:ln w="9525">
+            <a:solidFill>
+              <a:srgbClr val="CBD5E1"/>
+            </a:solidFill>
+            <a:prstDash val="solid"/>
+          </a:ln>
+        </p:spPr>
+      </p:sp>
+      <p:pic>
+        <p:nvPicPr>
+          <p:cNvPr id="6" name="Image 0" descr="Скриншот программы: 03_dialog.png">    </p:cNvPr>
+          <p:cNvPicPr>
+            <a:picLocks noChangeAspect="1"/>
+          </p:cNvPicPr>
+          <p:nvPr/>
+        </p:nvPicPr>
+        <p:blipFill>
+          <a:blip r:embed="rId1"/>
+          <a:stretch>
+            <a:fillRect/>
+          </a:stretch>
+        </p:blipFill>
+        <p:spPr>
+          <a:xfrm>
+            <a:off x="7910374" y="1371600"/>
+            <a:ext cx="3409084" cy="2560320"/>
+          </a:xfrm>
+          <a:prstGeom prst="rect">
+            <a:avLst/>
+          </a:prstGeom>
+        </p:spPr>
+      </p:pic>
+      <p:sp>
+        <p:nvSpPr>
+          <p:cNvPr id="7" name="Shape 2"/>
+          <p:cNvSpPr/>
+          <p:nvPr/>
+        </p:nvSpPr>
+        <p:spPr>
+          <a:xfrm>
+            <a:off x="7589520" y="4114800"/>
+            <a:ext cx="4050792" cy="2011680"/>
           </a:xfrm>
           <a:prstGeom prst="rect">
             <a:avLst/>
@@ -6410,88 +6363,7 @@
       </p:sp>
       <p:sp>
         <p:nvSpPr>
-          <p:cNvPr id="6" name="Text 2"/>
-          <p:cNvSpPr txBox="1"/>
-          <p:nvPr/>
-        </p:nvSpPr>
-        <p:spPr>
-          <a:xfrm>
-            <a:off x="7589520" y="1371600"/>
-            <a:ext cx="4050792" cy="2560320"/>
-          </a:xfrm>
-          <a:prstGeom prst="rect">
-            <a:avLst/>
-          </a:prstGeom>
-          <a:noFill/>
-          <a:ln/>
-        </p:spPr>
-        <p:txBody>
-          <a:bodyPr wrap="square" rtlCol="0" anchor="ctr"/>
-          <a:lstStyle/>
-          <a:p>
-            <a:pPr algn="ctr" indent="0" marL="0">
-              <a:buNone/>
-            </a:pPr>
-            <a:r>
-              <a:rPr lang="en-US" sz="1600" dirty="0">
-                <a:solidFill>
-                  <a:srgbClr val="64748B"/>
-                </a:solidFill>
-                <a:latin typeface="Calibri" pitchFamily="34" charset="0"/>
-                <a:ea typeface="Calibri" pitchFamily="34" charset="-122"/>
-                <a:cs typeface="Calibri" pitchFamily="34" charset="-120"/>
-              </a:rPr>
-              <a:t>Здесь будет скриншот</a:t>
-            </a:r>
-            <a:endParaRPr lang="en-US" sz="1600" dirty="0"/>
-          </a:p>
-          <a:p>
-            <a:pPr algn="ctr" indent="0" marL="0">
-              <a:buNone/>
-            </a:pPr>
-            <a:r>
-              <a:rPr lang="en-US" sz="1600" dirty="0">
-                <a:solidFill>
-                  <a:srgbClr val="64748B"/>
-                </a:solidFill>
-                <a:latin typeface="Calibri" pitchFamily="34" charset="0"/>
-                <a:ea typeface="Calibri" pitchFamily="34" charset="-122"/>
-                <a:cs typeface="Calibri" pitchFamily="34" charset="-120"/>
-              </a:rPr>
-              <a:t>03_dialog.png</a:t>
-            </a:r>
-            <a:endParaRPr lang="en-US" sz="1600" dirty="0"/>
-          </a:p>
-        </p:txBody>
-      </p:sp>
-      <p:sp>
-        <p:nvSpPr>
-          <p:cNvPr id="7" name="Shape 3"/>
-          <p:cNvSpPr/>
-          <p:nvPr/>
-        </p:nvSpPr>
-        <p:spPr>
-          <a:xfrm>
-            <a:off x="7589520" y="4114800"/>
-            <a:ext cx="4050792" cy="2011680"/>
-          </a:xfrm>
-          <a:prstGeom prst="rect">
-            <a:avLst/>
-          </a:prstGeom>
-          <a:solidFill>
-            <a:srgbClr val="E2E8F0"/>
-          </a:solidFill>
-          <a:ln w="12700">
-            <a:solidFill>
-              <a:srgbClr val="94A3B8"/>
-            </a:solidFill>
-            <a:prstDash val="dash"/>
-          </a:ln>
-        </p:spPr>
-      </p:sp>
-      <p:sp>
-        <p:nvSpPr>
-          <p:cNvPr id="8" name="Text 4"/>
+          <p:cNvPr id="8" name="Text 3"/>
           <p:cNvSpPr txBox="1"/>
           <p:nvPr/>
         </p:nvSpPr>
@@ -6724,7 +6596,7 @@
                 <a:ea typeface="Cambria" pitchFamily="34" charset="-122"/>
                 <a:cs typeface="Cambria" pitchFamily="34" charset="-120"/>
               </a:rPr>
-              <a:t>80</a:t>
+              <a:t>83</a:t>
             </a:r>
             <a:endParaRPr lang="en-US" sz="11000" dirty="0"/>
           </a:p>
@@ -8918,7 +8790,7 @@
                 <a:ea typeface="Calibri" pitchFamily="34" charset="-122"/>
                 <a:cs typeface="Calibri" pitchFamily="34" charset="-120"/>
               </a:rPr>
-              <a:t>80 автотестов</a:t>
+              <a:t>83 автотеста</a:t>
             </a:r>
             <a:endParaRPr lang="en-US" sz="1600" dirty="0"/>
           </a:p>
@@ -11456,6 +11328,27 @@
                 <a:ea typeface="Calibri" pitchFamily="34" charset="-122"/>
                 <a:cs typeface="Calibri" pitchFamily="34" charset="-120"/>
               </a:rPr>
+              <a:t>Часы делятся поровну на все дни до экзамена</a:t>
+            </a:r>
+            <a:endParaRPr lang="en-US" sz="1800" dirty="0"/>
+          </a:p>
+          <a:p>
+            <a:pPr marL="228600" indent="-228600">
+              <a:spcAft>
+                <a:spcPts val="1000"/>
+              </a:spcAft>
+              <a:buSzPct val="100000"/>
+              <a:buChar char="•"/>
+            </a:pPr>
+            <a:r>
+              <a:rPr lang="en-US" sz="1800" dirty="0">
+                <a:solidFill>
+                  <a:srgbClr val="0F172A"/>
+                </a:solidFill>
+                <a:latin typeface="Calibri" pitchFamily="34" charset="0"/>
+                <a:ea typeface="Calibri" pitchFamily="34" charset="-122"/>
+                <a:cs typeface="Calibri" pitchFamily="34" charset="-120"/>
+              </a:rPr>
               <a:t>В день не больше 4 часов, одной темы — не больше 2</a:t>
             </a:r>
             <a:endParaRPr lang="en-US" sz="1800" dirty="0"/>
@@ -11589,7 +11482,7 @@
                 <a:ea typeface="Cambria" pitchFamily="34" charset="-122"/>
                 <a:cs typeface="Cambria" pitchFamily="34" charset="-120"/>
               </a:rPr>
-              <a:t>Тема на 5 часов</a:t>
+              <a:t>3 часа, экзамен через 10 дней</a:t>
             </a:r>
             <a:endParaRPr lang="en-US" sz="2000" dirty="0"/>
           </a:p>
@@ -11603,8 +11496,72 @@
         </p:nvSpPr>
         <p:spPr>
           <a:xfrm>
-            <a:off x="6675120" y="2834640"/>
-            <a:ext cx="731520" cy="1645920"/>
+            <a:off x="6675120" y="4370832"/>
+            <a:ext cx="365760" cy="18288"/>
+          </a:xfrm>
+          <a:prstGeom prst="rect">
+            <a:avLst/>
+          </a:prstGeom>
+          <a:solidFill>
+            <a:srgbClr val="CBD5E1"/>
+          </a:solidFill>
+          <a:ln w="12700">
+            <a:solidFill>
+              <a:srgbClr val="CBD5E1"/>
+            </a:solidFill>
+            <a:prstDash val="solid"/>
+          </a:ln>
+        </p:spPr>
+      </p:sp>
+      <p:sp>
+        <p:nvSpPr>
+          <p:cNvPr id="8" name="Text 5"/>
+          <p:cNvSpPr txBox="1"/>
+          <p:nvPr/>
+        </p:nvSpPr>
+        <p:spPr>
+          <a:xfrm>
+            <a:off x="6675120" y="4434840"/>
+            <a:ext cx="365760" cy="274320"/>
+          </a:xfrm>
+          <a:prstGeom prst="rect">
+            <a:avLst/>
+          </a:prstGeom>
+          <a:noFill/>
+          <a:ln/>
+        </p:spPr>
+        <p:txBody>
+          <a:bodyPr wrap="square" lIns="0" tIns="0" rIns="0" bIns="0" rtlCol="0" anchor="ctr"/>
+          <a:lstStyle/>
+          <a:p>
+            <a:pPr algn="ctr" indent="0" marL="0">
+              <a:buNone/>
+            </a:pPr>
+            <a:r>
+              <a:rPr lang="en-US" sz="1200" dirty="0">
+                <a:solidFill>
+                  <a:srgbClr val="64748B"/>
+                </a:solidFill>
+                <a:latin typeface="Calibri" pitchFamily="34" charset="0"/>
+                <a:ea typeface="Calibri" pitchFamily="34" charset="-122"/>
+                <a:cs typeface="Calibri" pitchFamily="34" charset="-120"/>
+              </a:rPr>
+              <a:t>1</a:t>
+            </a:r>
+            <a:endParaRPr lang="en-US" sz="1200" dirty="0"/>
+          </a:p>
+        </p:txBody>
+      </p:sp>
+      <p:sp>
+        <p:nvSpPr>
+          <p:cNvPr id="9" name="Shape 6"/>
+          <p:cNvSpPr/>
+          <p:nvPr/>
+        </p:nvSpPr>
+        <p:spPr>
+          <a:xfrm>
+            <a:off x="7132320" y="3566160"/>
+            <a:ext cx="365760" cy="822960"/>
           </a:xfrm>
           <a:prstGeom prst="rect">
             <a:avLst/>
@@ -11622,14 +11579,14 @@
       </p:sp>
       <p:sp>
         <p:nvSpPr>
-          <p:cNvPr id="8" name="Text 5"/>
+          <p:cNvPr id="10" name="Text 7"/>
           <p:cNvSpPr txBox="1"/>
           <p:nvPr/>
         </p:nvSpPr>
         <p:spPr>
           <a:xfrm>
-            <a:off x="6675120" y="2834640"/>
-            <a:ext cx="731520" cy="1645920"/>
+            <a:off x="7132320" y="3566160"/>
+            <a:ext cx="365760" cy="822960"/>
           </a:xfrm>
           <a:prstGeom prst="rect">
             <a:avLst/>
@@ -11645,7 +11602,7 @@
               <a:buNone/>
             </a:pPr>
             <a:r>
-              <a:rPr lang="en-US" sz="1600" b="1" dirty="0">
+              <a:rPr lang="en-US" sz="1200" b="1" dirty="0">
                 <a:solidFill>
                   <a:srgbClr val="FFFFFF"/>
                 </a:solidFill>
@@ -11653,22 +11610,22 @@
                 <a:ea typeface="Calibri" pitchFamily="34" charset="-122"/>
                 <a:cs typeface="Calibri" pitchFamily="34" charset="-120"/>
               </a:rPr>
-              <a:t>2 ч</a:t>
-            </a:r>
-            <a:endParaRPr lang="en-US" sz="1600" dirty="0"/>
-          </a:p>
-        </p:txBody>
-      </p:sp>
-      <p:sp>
-        <p:nvSpPr>
-          <p:cNvPr id="9" name="Text 6"/>
+              <a:t>1 ч</a:t>
+            </a:r>
+            <a:endParaRPr lang="en-US" sz="1200" dirty="0"/>
+          </a:p>
+        </p:txBody>
+      </p:sp>
+      <p:sp>
+        <p:nvSpPr>
+          <p:cNvPr id="11" name="Text 8"/>
           <p:cNvSpPr txBox="1"/>
           <p:nvPr/>
         </p:nvSpPr>
         <p:spPr>
           <a:xfrm>
-            <a:off x="6675120" y="4572000"/>
-            <a:ext cx="731520" cy="320040"/>
+            <a:off x="7132320" y="4434840"/>
+            <a:ext cx="365760" cy="274320"/>
           </a:xfrm>
           <a:prstGeom prst="rect">
             <a:avLst/>
@@ -11684,7 +11641,7 @@
               <a:buNone/>
             </a:pPr>
             <a:r>
-              <a:rPr lang="en-US" sz="1400" dirty="0">
+              <a:rPr lang="en-US" sz="1200" dirty="0">
                 <a:solidFill>
                   <a:srgbClr val="64748B"/>
                 </a:solidFill>
@@ -11692,22 +11649,150 @@
                 <a:ea typeface="Calibri" pitchFamily="34" charset="-122"/>
                 <a:cs typeface="Calibri" pitchFamily="34" charset="-120"/>
               </a:rPr>
-              <a:t>Пн</a:t>
-            </a:r>
-            <a:endParaRPr lang="en-US" sz="1400" dirty="0"/>
-          </a:p>
-        </p:txBody>
-      </p:sp>
-      <p:sp>
-        <p:nvSpPr>
-          <p:cNvPr id="10" name="Shape 7"/>
+              <a:t>2</a:t>
+            </a:r>
+            <a:endParaRPr lang="en-US" sz="1200" dirty="0"/>
+          </a:p>
+        </p:txBody>
+      </p:sp>
+      <p:sp>
+        <p:nvSpPr>
+          <p:cNvPr id="12" name="Shape 9"/>
           <p:cNvSpPr/>
           <p:nvPr/>
         </p:nvSpPr>
         <p:spPr>
           <a:xfrm>
-            <a:off x="7589520" y="2834640"/>
-            <a:ext cx="731520" cy="1645920"/>
+            <a:off x="7589520" y="4370832"/>
+            <a:ext cx="365760" cy="18288"/>
+          </a:xfrm>
+          <a:prstGeom prst="rect">
+            <a:avLst/>
+          </a:prstGeom>
+          <a:solidFill>
+            <a:srgbClr val="CBD5E1"/>
+          </a:solidFill>
+          <a:ln w="12700">
+            <a:solidFill>
+              <a:srgbClr val="CBD5E1"/>
+            </a:solidFill>
+            <a:prstDash val="solid"/>
+          </a:ln>
+        </p:spPr>
+      </p:sp>
+      <p:sp>
+        <p:nvSpPr>
+          <p:cNvPr id="13" name="Text 10"/>
+          <p:cNvSpPr txBox="1"/>
+          <p:nvPr/>
+        </p:nvSpPr>
+        <p:spPr>
+          <a:xfrm>
+            <a:off x="7589520" y="4434840"/>
+            <a:ext cx="365760" cy="274320"/>
+          </a:xfrm>
+          <a:prstGeom prst="rect">
+            <a:avLst/>
+          </a:prstGeom>
+          <a:noFill/>
+          <a:ln/>
+        </p:spPr>
+        <p:txBody>
+          <a:bodyPr wrap="square" lIns="0" tIns="0" rIns="0" bIns="0" rtlCol="0" anchor="ctr"/>
+          <a:lstStyle/>
+          <a:p>
+            <a:pPr algn="ctr" indent="0" marL="0">
+              <a:buNone/>
+            </a:pPr>
+            <a:r>
+              <a:rPr lang="en-US" sz="1200" dirty="0">
+                <a:solidFill>
+                  <a:srgbClr val="64748B"/>
+                </a:solidFill>
+                <a:latin typeface="Calibri" pitchFamily="34" charset="0"/>
+                <a:ea typeface="Calibri" pitchFamily="34" charset="-122"/>
+                <a:cs typeface="Calibri" pitchFamily="34" charset="-120"/>
+              </a:rPr>
+              <a:t>3</a:t>
+            </a:r>
+            <a:endParaRPr lang="en-US" sz="1200" dirty="0"/>
+          </a:p>
+        </p:txBody>
+      </p:sp>
+      <p:sp>
+        <p:nvSpPr>
+          <p:cNvPr id="14" name="Shape 11"/>
+          <p:cNvSpPr/>
+          <p:nvPr/>
+        </p:nvSpPr>
+        <p:spPr>
+          <a:xfrm>
+            <a:off x="8046720" y="4370832"/>
+            <a:ext cx="365760" cy="18288"/>
+          </a:xfrm>
+          <a:prstGeom prst="rect">
+            <a:avLst/>
+          </a:prstGeom>
+          <a:solidFill>
+            <a:srgbClr val="CBD5E1"/>
+          </a:solidFill>
+          <a:ln w="12700">
+            <a:solidFill>
+              <a:srgbClr val="CBD5E1"/>
+            </a:solidFill>
+            <a:prstDash val="solid"/>
+          </a:ln>
+        </p:spPr>
+      </p:sp>
+      <p:sp>
+        <p:nvSpPr>
+          <p:cNvPr id="15" name="Text 12"/>
+          <p:cNvSpPr txBox="1"/>
+          <p:nvPr/>
+        </p:nvSpPr>
+        <p:spPr>
+          <a:xfrm>
+            <a:off x="8046720" y="4434840"/>
+            <a:ext cx="365760" cy="274320"/>
+          </a:xfrm>
+          <a:prstGeom prst="rect">
+            <a:avLst/>
+          </a:prstGeom>
+          <a:noFill/>
+          <a:ln/>
+        </p:spPr>
+        <p:txBody>
+          <a:bodyPr wrap="square" lIns="0" tIns="0" rIns="0" bIns="0" rtlCol="0" anchor="ctr"/>
+          <a:lstStyle/>
+          <a:p>
+            <a:pPr algn="ctr" indent="0" marL="0">
+              <a:buNone/>
+            </a:pPr>
+            <a:r>
+              <a:rPr lang="en-US" sz="1200" dirty="0">
+                <a:solidFill>
+                  <a:srgbClr val="64748B"/>
+                </a:solidFill>
+                <a:latin typeface="Calibri" pitchFamily="34" charset="0"/>
+                <a:ea typeface="Calibri" pitchFamily="34" charset="-122"/>
+                <a:cs typeface="Calibri" pitchFamily="34" charset="-120"/>
+              </a:rPr>
+              <a:t>4</a:t>
+            </a:r>
+            <a:endParaRPr lang="en-US" sz="1200" dirty="0"/>
+          </a:p>
+        </p:txBody>
+      </p:sp>
+      <p:sp>
+        <p:nvSpPr>
+          <p:cNvPr id="16" name="Shape 13"/>
+          <p:cNvSpPr/>
+          <p:nvPr/>
+        </p:nvSpPr>
+        <p:spPr>
+          <a:xfrm>
+            <a:off x="8503920" y="3566160"/>
+            <a:ext cx="365760" cy="822960"/>
           </a:xfrm>
           <a:prstGeom prst="rect">
             <a:avLst/>
@@ -11725,14 +11810,14 @@
       </p:sp>
       <p:sp>
         <p:nvSpPr>
-          <p:cNvPr id="11" name="Text 8"/>
+          <p:cNvPr id="17" name="Text 14"/>
           <p:cNvSpPr txBox="1"/>
           <p:nvPr/>
         </p:nvSpPr>
         <p:spPr>
           <a:xfrm>
-            <a:off x="7589520" y="2834640"/>
-            <a:ext cx="731520" cy="1645920"/>
+            <a:off x="8503920" y="3566160"/>
+            <a:ext cx="365760" cy="822960"/>
           </a:xfrm>
           <a:prstGeom prst="rect">
             <a:avLst/>
@@ -11748,7 +11833,7 @@
               <a:buNone/>
             </a:pPr>
             <a:r>
-              <a:rPr lang="en-US" sz="1600" b="1" dirty="0">
+              <a:rPr lang="en-US" sz="1200" b="1" dirty="0">
                 <a:solidFill>
                   <a:srgbClr val="FFFFFF"/>
                 </a:solidFill>
@@ -11756,22 +11841,22 @@
                 <a:ea typeface="Calibri" pitchFamily="34" charset="-122"/>
                 <a:cs typeface="Calibri" pitchFamily="34" charset="-120"/>
               </a:rPr>
-              <a:t>2 ч</a:t>
-            </a:r>
-            <a:endParaRPr lang="en-US" sz="1600" dirty="0"/>
-          </a:p>
-        </p:txBody>
-      </p:sp>
-      <p:sp>
-        <p:nvSpPr>
-          <p:cNvPr id="12" name="Text 9"/>
+              <a:t>1 ч</a:t>
+            </a:r>
+            <a:endParaRPr lang="en-US" sz="1200" dirty="0"/>
+          </a:p>
+        </p:txBody>
+      </p:sp>
+      <p:sp>
+        <p:nvSpPr>
+          <p:cNvPr id="18" name="Text 15"/>
           <p:cNvSpPr txBox="1"/>
           <p:nvPr/>
         </p:nvSpPr>
         <p:spPr>
           <a:xfrm>
-            <a:off x="7589520" y="4572000"/>
-            <a:ext cx="731520" cy="320040"/>
+            <a:off x="8503920" y="4434840"/>
+            <a:ext cx="365760" cy="274320"/>
           </a:xfrm>
           <a:prstGeom prst="rect">
             <a:avLst/>
@@ -11787,7 +11872,7 @@
               <a:buNone/>
             </a:pPr>
             <a:r>
-              <a:rPr lang="en-US" sz="1400" dirty="0">
+              <a:rPr lang="en-US" sz="1200" dirty="0">
                 <a:solidFill>
                   <a:srgbClr val="64748B"/>
                 </a:solidFill>
@@ -11795,22 +11880,214 @@
                 <a:ea typeface="Calibri" pitchFamily="34" charset="-122"/>
                 <a:cs typeface="Calibri" pitchFamily="34" charset="-120"/>
               </a:rPr>
-              <a:t>Вт</a:t>
-            </a:r>
-            <a:endParaRPr lang="en-US" sz="1400" dirty="0"/>
-          </a:p>
-        </p:txBody>
-      </p:sp>
-      <p:sp>
-        <p:nvSpPr>
-          <p:cNvPr id="13" name="Shape 10"/>
+              <a:t>5</a:t>
+            </a:r>
+            <a:endParaRPr lang="en-US" sz="1200" dirty="0"/>
+          </a:p>
+        </p:txBody>
+      </p:sp>
+      <p:sp>
+        <p:nvSpPr>
+          <p:cNvPr id="19" name="Shape 16"/>
           <p:cNvSpPr/>
           <p:nvPr/>
         </p:nvSpPr>
         <p:spPr>
           <a:xfrm>
-            <a:off x="8503920" y="3657600"/>
-            <a:ext cx="731520" cy="822960"/>
+            <a:off x="8961120" y="4370832"/>
+            <a:ext cx="365760" cy="18288"/>
+          </a:xfrm>
+          <a:prstGeom prst="rect">
+            <a:avLst/>
+          </a:prstGeom>
+          <a:solidFill>
+            <a:srgbClr val="CBD5E1"/>
+          </a:solidFill>
+          <a:ln w="12700">
+            <a:solidFill>
+              <a:srgbClr val="CBD5E1"/>
+            </a:solidFill>
+            <a:prstDash val="solid"/>
+          </a:ln>
+        </p:spPr>
+      </p:sp>
+      <p:sp>
+        <p:nvSpPr>
+          <p:cNvPr id="20" name="Text 17"/>
+          <p:cNvSpPr txBox="1"/>
+          <p:nvPr/>
+        </p:nvSpPr>
+        <p:spPr>
+          <a:xfrm>
+            <a:off x="8961120" y="4434840"/>
+            <a:ext cx="365760" cy="274320"/>
+          </a:xfrm>
+          <a:prstGeom prst="rect">
+            <a:avLst/>
+          </a:prstGeom>
+          <a:noFill/>
+          <a:ln/>
+        </p:spPr>
+        <p:txBody>
+          <a:bodyPr wrap="square" lIns="0" tIns="0" rIns="0" bIns="0" rtlCol="0" anchor="ctr"/>
+          <a:lstStyle/>
+          <a:p>
+            <a:pPr algn="ctr" indent="0" marL="0">
+              <a:buNone/>
+            </a:pPr>
+            <a:r>
+              <a:rPr lang="en-US" sz="1200" dirty="0">
+                <a:solidFill>
+                  <a:srgbClr val="64748B"/>
+                </a:solidFill>
+                <a:latin typeface="Calibri" pitchFamily="34" charset="0"/>
+                <a:ea typeface="Calibri" pitchFamily="34" charset="-122"/>
+                <a:cs typeface="Calibri" pitchFamily="34" charset="-120"/>
+              </a:rPr>
+              <a:t>6</a:t>
+            </a:r>
+            <a:endParaRPr lang="en-US" sz="1200" dirty="0"/>
+          </a:p>
+        </p:txBody>
+      </p:sp>
+      <p:sp>
+        <p:nvSpPr>
+          <p:cNvPr id="21" name="Shape 18"/>
+          <p:cNvSpPr/>
+          <p:nvPr/>
+        </p:nvSpPr>
+        <p:spPr>
+          <a:xfrm>
+            <a:off x="9418320" y="4370832"/>
+            <a:ext cx="365760" cy="18288"/>
+          </a:xfrm>
+          <a:prstGeom prst="rect">
+            <a:avLst/>
+          </a:prstGeom>
+          <a:solidFill>
+            <a:srgbClr val="CBD5E1"/>
+          </a:solidFill>
+          <a:ln w="12700">
+            <a:solidFill>
+              <a:srgbClr val="CBD5E1"/>
+            </a:solidFill>
+            <a:prstDash val="solid"/>
+          </a:ln>
+        </p:spPr>
+      </p:sp>
+      <p:sp>
+        <p:nvSpPr>
+          <p:cNvPr id="22" name="Text 19"/>
+          <p:cNvSpPr txBox="1"/>
+          <p:nvPr/>
+        </p:nvSpPr>
+        <p:spPr>
+          <a:xfrm>
+            <a:off x="9418320" y="4434840"/>
+            <a:ext cx="365760" cy="274320"/>
+          </a:xfrm>
+          <a:prstGeom prst="rect">
+            <a:avLst/>
+          </a:prstGeom>
+          <a:noFill/>
+          <a:ln/>
+        </p:spPr>
+        <p:txBody>
+          <a:bodyPr wrap="square" lIns="0" tIns="0" rIns="0" bIns="0" rtlCol="0" anchor="ctr"/>
+          <a:lstStyle/>
+          <a:p>
+            <a:pPr algn="ctr" indent="0" marL="0">
+              <a:buNone/>
+            </a:pPr>
+            <a:r>
+              <a:rPr lang="en-US" sz="1200" dirty="0">
+                <a:solidFill>
+                  <a:srgbClr val="64748B"/>
+                </a:solidFill>
+                <a:latin typeface="Calibri" pitchFamily="34" charset="0"/>
+                <a:ea typeface="Calibri" pitchFamily="34" charset="-122"/>
+                <a:cs typeface="Calibri" pitchFamily="34" charset="-120"/>
+              </a:rPr>
+              <a:t>7</a:t>
+            </a:r>
+            <a:endParaRPr lang="en-US" sz="1200" dirty="0"/>
+          </a:p>
+        </p:txBody>
+      </p:sp>
+      <p:sp>
+        <p:nvSpPr>
+          <p:cNvPr id="23" name="Shape 20"/>
+          <p:cNvSpPr/>
+          <p:nvPr/>
+        </p:nvSpPr>
+        <p:spPr>
+          <a:xfrm>
+            <a:off x="9875520" y="4370832"/>
+            <a:ext cx="365760" cy="18288"/>
+          </a:xfrm>
+          <a:prstGeom prst="rect">
+            <a:avLst/>
+          </a:prstGeom>
+          <a:solidFill>
+            <a:srgbClr val="CBD5E1"/>
+          </a:solidFill>
+          <a:ln w="12700">
+            <a:solidFill>
+              <a:srgbClr val="CBD5E1"/>
+            </a:solidFill>
+            <a:prstDash val="solid"/>
+          </a:ln>
+        </p:spPr>
+      </p:sp>
+      <p:sp>
+        <p:nvSpPr>
+          <p:cNvPr id="24" name="Text 21"/>
+          <p:cNvSpPr txBox="1"/>
+          <p:nvPr/>
+        </p:nvSpPr>
+        <p:spPr>
+          <a:xfrm>
+            <a:off x="9875520" y="4434840"/>
+            <a:ext cx="365760" cy="274320"/>
+          </a:xfrm>
+          <a:prstGeom prst="rect">
+            <a:avLst/>
+          </a:prstGeom>
+          <a:noFill/>
+          <a:ln/>
+        </p:spPr>
+        <p:txBody>
+          <a:bodyPr wrap="square" lIns="0" tIns="0" rIns="0" bIns="0" rtlCol="0" anchor="ctr"/>
+          <a:lstStyle/>
+          <a:p>
+            <a:pPr algn="ctr" indent="0" marL="0">
+              <a:buNone/>
+            </a:pPr>
+            <a:r>
+              <a:rPr lang="en-US" sz="1200" dirty="0">
+                <a:solidFill>
+                  <a:srgbClr val="64748B"/>
+                </a:solidFill>
+                <a:latin typeface="Calibri" pitchFamily="34" charset="0"/>
+                <a:ea typeface="Calibri" pitchFamily="34" charset="-122"/>
+                <a:cs typeface="Calibri" pitchFamily="34" charset="-120"/>
+              </a:rPr>
+              <a:t>8</a:t>
+            </a:r>
+            <a:endParaRPr lang="en-US" sz="1200" dirty="0"/>
+          </a:p>
+        </p:txBody>
+      </p:sp>
+      <p:sp>
+        <p:nvSpPr>
+          <p:cNvPr id="25" name="Shape 22"/>
+          <p:cNvSpPr/>
+          <p:nvPr/>
+        </p:nvSpPr>
+        <p:spPr>
+          <a:xfrm>
+            <a:off x="10332720" y="3566160"/>
+            <a:ext cx="365760" cy="822960"/>
           </a:xfrm>
           <a:prstGeom prst="rect">
             <a:avLst/>
@@ -11828,14 +12105,14 @@
       </p:sp>
       <p:sp>
         <p:nvSpPr>
-          <p:cNvPr id="14" name="Text 11"/>
+          <p:cNvPr id="26" name="Text 23"/>
           <p:cNvSpPr txBox="1"/>
           <p:nvPr/>
         </p:nvSpPr>
         <p:spPr>
           <a:xfrm>
-            <a:off x="8503920" y="3657600"/>
-            <a:ext cx="731520" cy="822960"/>
+            <a:off x="10332720" y="3566160"/>
+            <a:ext cx="365760" cy="822960"/>
           </a:xfrm>
           <a:prstGeom prst="rect">
             <a:avLst/>
@@ -11851,7 +12128,7 @@
               <a:buNone/>
             </a:pPr>
             <a:r>
-              <a:rPr lang="en-US" sz="1600" b="1" dirty="0">
+              <a:rPr lang="en-US" sz="1200" b="1" dirty="0">
                 <a:solidFill>
                   <a:srgbClr val="FFFFFF"/>
                 </a:solidFill>
@@ -11861,20 +12138,20 @@
               </a:rPr>
               <a:t>1 ч</a:t>
             </a:r>
-            <a:endParaRPr lang="en-US" sz="1600" dirty="0"/>
-          </a:p>
-        </p:txBody>
-      </p:sp>
-      <p:sp>
-        <p:nvSpPr>
-          <p:cNvPr id="15" name="Text 12"/>
+            <a:endParaRPr lang="en-US" sz="1200" dirty="0"/>
+          </a:p>
+        </p:txBody>
+      </p:sp>
+      <p:sp>
+        <p:nvSpPr>
+          <p:cNvPr id="27" name="Text 24"/>
           <p:cNvSpPr txBox="1"/>
           <p:nvPr/>
         </p:nvSpPr>
         <p:spPr>
           <a:xfrm>
-            <a:off x="8503920" y="4572000"/>
-            <a:ext cx="731520" cy="320040"/>
+            <a:off x="10332720" y="4434840"/>
+            <a:ext cx="365760" cy="274320"/>
           </a:xfrm>
           <a:prstGeom prst="rect">
             <a:avLst/>
@@ -11890,7 +12167,7 @@
               <a:buNone/>
             </a:pPr>
             <a:r>
-              <a:rPr lang="en-US" sz="1400" dirty="0">
+              <a:rPr lang="en-US" sz="1200" dirty="0">
                 <a:solidFill>
                   <a:srgbClr val="64748B"/>
                 </a:solidFill>
@@ -11898,22 +12175,22 @@
                 <a:ea typeface="Calibri" pitchFamily="34" charset="-122"/>
                 <a:cs typeface="Calibri" pitchFamily="34" charset="-120"/>
               </a:rPr>
-              <a:t>Ср</a:t>
-            </a:r>
-            <a:endParaRPr lang="en-US" sz="1400" dirty="0"/>
-          </a:p>
-        </p:txBody>
-      </p:sp>
-      <p:sp>
-        <p:nvSpPr>
-          <p:cNvPr id="16" name="Shape 13"/>
+              <a:t>9</a:t>
+            </a:r>
+            <a:endParaRPr lang="en-US" sz="1200" dirty="0"/>
+          </a:p>
+        </p:txBody>
+      </p:sp>
+      <p:sp>
+        <p:nvSpPr>
+          <p:cNvPr id="28" name="Shape 25"/>
           <p:cNvSpPr/>
           <p:nvPr/>
         </p:nvSpPr>
         <p:spPr>
           <a:xfrm>
-            <a:off x="9418320" y="4480560"/>
-            <a:ext cx="731520" cy="18288"/>
+            <a:off x="10789920" y="4370832"/>
+            <a:ext cx="365760" cy="18288"/>
           </a:xfrm>
           <a:prstGeom prst="rect">
             <a:avLst/>
@@ -11931,14 +12208,14 @@
       </p:sp>
       <p:sp>
         <p:nvSpPr>
-          <p:cNvPr id="17" name="Text 14"/>
+          <p:cNvPr id="29" name="Text 26"/>
           <p:cNvSpPr txBox="1"/>
           <p:nvPr/>
         </p:nvSpPr>
         <p:spPr>
           <a:xfrm>
-            <a:off x="9418320" y="4572000"/>
-            <a:ext cx="731520" cy="320040"/>
+            <a:off x="10789920" y="4434840"/>
+            <a:ext cx="365760" cy="274320"/>
           </a:xfrm>
           <a:prstGeom prst="rect">
             <a:avLst/>
@@ -11954,7 +12231,7 @@
               <a:buNone/>
             </a:pPr>
             <a:r>
-              <a:rPr lang="en-US" sz="1400" dirty="0">
+              <a:rPr lang="en-US" sz="1200" dirty="0">
                 <a:solidFill>
                   <a:srgbClr val="64748B"/>
                 </a:solidFill>
@@ -11962,47 +12239,22 @@
                 <a:ea typeface="Calibri" pitchFamily="34" charset="-122"/>
                 <a:cs typeface="Calibri" pitchFamily="34" charset="-120"/>
               </a:rPr>
-              <a:t>Чт</a:t>
-            </a:r>
-            <a:endParaRPr lang="en-US" sz="1400" dirty="0"/>
-          </a:p>
-        </p:txBody>
-      </p:sp>
-      <p:sp>
-        <p:nvSpPr>
-          <p:cNvPr id="18" name="Shape 15"/>
-          <p:cNvSpPr/>
-          <p:nvPr/>
-        </p:nvSpPr>
-        <p:spPr>
-          <a:xfrm>
-            <a:off x="10332720" y="4480560"/>
-            <a:ext cx="731520" cy="18288"/>
-          </a:xfrm>
-          <a:prstGeom prst="rect">
-            <a:avLst/>
-          </a:prstGeom>
-          <a:solidFill>
-            <a:srgbClr val="CBD5E1"/>
-          </a:solidFill>
-          <a:ln w="12700">
-            <a:solidFill>
-              <a:srgbClr val="CBD5E1"/>
-            </a:solidFill>
-            <a:prstDash val="solid"/>
-          </a:ln>
-        </p:spPr>
-      </p:sp>
-      <p:sp>
-        <p:nvSpPr>
-          <p:cNvPr id="19" name="Text 16"/>
+              <a:t>10</a:t>
+            </a:r>
+            <a:endParaRPr lang="en-US" sz="1200" dirty="0"/>
+          </a:p>
+        </p:txBody>
+      </p:sp>
+      <p:sp>
+        <p:nvSpPr>
+          <p:cNvPr id="30" name="Text 27"/>
           <p:cNvSpPr txBox="1"/>
           <p:nvPr/>
         </p:nvSpPr>
         <p:spPr>
           <a:xfrm>
-            <a:off x="10332720" y="4572000"/>
-            <a:ext cx="731520" cy="320040"/>
+            <a:off x="6675120" y="4937760"/>
+            <a:ext cx="4663440" cy="640080"/>
           </a:xfrm>
           <a:prstGeom prst="rect">
             <a:avLst/>
@@ -12014,58 +12266,19 @@
           <a:bodyPr wrap="square" lIns="0" tIns="0" rIns="0" bIns="0" rtlCol="0" anchor="ctr"/>
           <a:lstStyle/>
           <a:p>
-            <a:pPr algn="ctr" indent="0" marL="0">
-              <a:buNone/>
-            </a:pPr>
-            <a:r>
-              <a:rPr lang="en-US" sz="1400" dirty="0">
-                <a:solidFill>
-                  <a:srgbClr val="64748B"/>
+            <a:pPr indent="0" marL="0">
+              <a:buNone/>
+            </a:pPr>
+            <a:r>
+              <a:rPr lang="en-US" sz="1600" i="1" dirty="0">
+                <a:solidFill>
+                  <a:srgbClr val="4F46E5"/>
                 </a:solidFill>
                 <a:latin typeface="Calibri" pitchFamily="34" charset="0"/>
                 <a:ea typeface="Calibri" pitchFamily="34" charset="-122"/>
                 <a:cs typeface="Calibri" pitchFamily="34" charset="-120"/>
               </a:rPr>
-              <a:t>Пт</a:t>
-            </a:r>
-            <a:endParaRPr lang="en-US" sz="1400" dirty="0"/>
-          </a:p>
-        </p:txBody>
-      </p:sp>
-      <p:sp>
-        <p:nvSpPr>
-          <p:cNvPr id="20" name="Text 17"/>
-          <p:cNvSpPr txBox="1"/>
-          <p:nvPr/>
-        </p:nvSpPr>
-        <p:spPr>
-          <a:xfrm>
-            <a:off x="6675120" y="5029200"/>
-            <a:ext cx="4663440" cy="457200"/>
-          </a:xfrm>
-          <a:prstGeom prst="rect">
-            <a:avLst/>
-          </a:prstGeom>
-          <a:noFill/>
-          <a:ln/>
-        </p:spPr>
-        <p:txBody>
-          <a:bodyPr wrap="square" lIns="0" tIns="0" rIns="0" bIns="0" rtlCol="0" anchor="ctr"/>
-          <a:lstStyle/>
-          <a:p>
-            <a:pPr indent="0" marL="0">
-              <a:buNone/>
-            </a:pPr>
-            <a:r>
-              <a:rPr lang="en-US" sz="1600" i="1" dirty="0">
-                <a:solidFill>
-                  <a:srgbClr val="4F46E5"/>
-                </a:solidFill>
-                <a:latin typeface="Calibri" pitchFamily="34" charset="0"/>
-                <a:ea typeface="Calibri" pitchFamily="34" charset="-122"/>
-                <a:cs typeface="Calibri" pitchFamily="34" charset="-120"/>
-              </a:rPr>
-              <a:t>2 + 2 + 1 вместо 5 ч в один день</a:t>
+              <a:t>по часу раз в несколько дней, а не 3 часа в первый день</a:t>
             </a:r>
             <a:endParaRPr lang="en-US" sz="1600" dirty="0"/>
           </a:p>

</xml_diff>

<commit_message>
Clean up project: remove helper scripts and tests, simple comments, short README
Co-Authored-By: Claude Sonnet 5.5 <noreply@anthropic.com>
</commit_message>
<xml_diff>
--- a/docs/Презентация_Планировщик_экзаменов.pptx
+++ b/docs/Презентация_Планировщик_экзаменов.pptx
@@ -23,10 +23,9 @@
     <p:sldId id="271" r:id="rId17"/>
     <p:sldId id="272" r:id="rId18"/>
     <p:sldId id="273" r:id="rId19"/>
-    <p:sldId id="274" r:id="rId20"/>
   </p:sldIdLst>
   <p:notesMasterIdLst>
-    <p:notesMasterId r:id="rId21"/>
+    <p:notesMasterId r:id="rId20"/>
   </p:notesMasterIdLst>
   <p:sldSz cx="12192000" cy="6858000"/>
   <p:notesSz cx="6858000" cy="12192000"/>
@@ -1312,7 +1311,7 @@
           <a:p>
             <a:r>
               <a:rPr lang="en-US" dirty="0"/>
-              <a:t>Логику проверяют 83 автотеста, все проходят. Они смотрят на неверный ввод, лимиты часов, день повторения, распределение по дням, перепланирование, автоподбор сложности и битые файлы. Окно мы проверяли руками.</a:t>
+              <a:t>Итог: программа работает, с окном, календарём и диаграммой Ганта, данные сохраняются в файлы. Дальше можно добавить редактирование записей, напоминания и экспорт в календарь. Код проекта выложен на GitHub, ссылка на последнем слайде. Спасибо за внимание, будем рады вопросам.</a:t>
             </a:r>
             <a:endParaRPr lang="en-US" dirty="0"/>
           </a:p>
@@ -1336,94 +1335,6 @@
             <a:fld id="{F7021451-1387-4CA6-816F-3879F97B5CBC}" type="slidenum">
               <a:rPr lang="en-US"/>
               <a:t>18</a:t>
-            </a:fld>
-            <a:endParaRPr lang="en-US"/>
-          </a:p>
-        </p:txBody>
-      </p:sp>
-    </p:spTree>
-    <p:extLst>
-      <p:ext uri="{BB962C8B-B14F-4D97-AF65-F5344CB8AC3E}">
-        <p14:creationId xmlns:p14="http://schemas.microsoft.com/office/powerpoint/2010/main" val="1024086991"/>
-      </p:ext>
-    </p:extLst>
-  </p:cSld>
-  <p:clrMapOvr>
-    <a:masterClrMapping/>
-  </p:clrMapOvr>
-</p:notes>
-</file>
-
-<file path=ppt/notesSlides/notesSlide19.xml><?xml version="1.0" encoding="utf-8"?>
-<p:notes xmlns:a="http://schemas.openxmlformats.org/drawingml/2006/main" xmlns:r="http://schemas.openxmlformats.org/officeDocument/2006/relationships" xmlns:p="http://schemas.openxmlformats.org/presentationml/2006/main">
-  <p:cSld>
-    <p:spTree>
-      <p:nvGrpSpPr>
-        <p:cNvPr id="1" name=""/>
-        <p:cNvGrpSpPr/>
-        <p:nvPr/>
-      </p:nvGrpSpPr>
-      <p:grpSpPr>
-        <a:xfrm>
-          <a:off x="0" y="0"/>
-          <a:ext cx="0" cy="0"/>
-          <a:chOff x="0" y="0"/>
-          <a:chExt cx="0" cy="0"/>
-        </a:xfrm>
-      </p:grpSpPr>
-      <p:sp>
-        <p:nvSpPr>
-          <p:cNvPr id="2" name="Slide Image Placeholder 1"/>
-          <p:cNvSpPr>
-            <a:spLocks noGrp="1" noRot="1" noChangeAspect="1"/>
-          </p:cNvSpPr>
-          <p:nvPr>
-            <p:ph type="sldImg"/>
-          </p:nvPr>
-        </p:nvSpPr>
-        <p:spPr/>
-      </p:sp>
-      <p:sp>
-        <p:nvSpPr>
-          <p:cNvPr id="3" name="Notes Placeholder 2"/>
-          <p:cNvSpPr>
-            <a:spLocks noGrp="1"/>
-          </p:cNvSpPr>
-          <p:nvPr>
-            <p:ph type="body" idx="1"/>
-          </p:nvPr>
-        </p:nvSpPr>
-        <p:spPr/>
-        <p:txBody>
-          <a:bodyPr/>
-          <a:lstStyle/>
-          <a:p>
-            <a:r>
-              <a:rPr lang="en-US" dirty="0"/>
-              <a:t>Итог: программа работает, с окном, календарём и диаграммой Ганта, данные сохраняются, логика покрыта тестами. Дальше можно добавить редактирование записей, напоминания и экспорт в календарь. Код проекта выложен на GitHub, ссылка на последнем слайде. Спасибо за внимание, будем рады вопросам.</a:t>
-            </a:r>
-            <a:endParaRPr lang="en-US" dirty="0"/>
-          </a:p>
-        </p:txBody>
-      </p:sp>
-      <p:sp>
-        <p:nvSpPr>
-          <p:cNvPr id="4" name="Slide Number Placeholder 3"/>
-          <p:cNvSpPr>
-            <a:spLocks noGrp="1"/>
-          </p:cNvSpPr>
-          <p:nvPr>
-            <p:ph type="sldNum" sz="quarter" idx="10"/>
-          </p:nvPr>
-        </p:nvSpPr>
-        <p:spPr/>
-        <p:txBody>
-          <a:bodyPr/>
-          <a:lstStyle/>
-          <a:p>
-            <a:fld id="{F7021451-1387-4CA6-816F-3879F97B5CBC}" type="slidenum">
-              <a:rPr lang="en-US"/>
-              <a:t>19</a:t>
             </a:fld>
             <a:endParaRPr lang="en-US"/>
           </a:p>
@@ -1576,7 +1487,7 @@
           <a:p>
             <a:r>
               <a:rPr lang="en-US" dirty="0"/>
-              <a:t>Окно и формы сделаны на tkinter, диаграмма нарисована на его Canvas. Данные лежат в CSV-файлах. Логику проверяет pytest, историю изменений ведёт git. Код лежит на GitHub.</a:t>
+              <a:t>Окно и формы сделаны на tkinter, диаграмма нарисована на его Canvas. Данные лежат в CSV-файлах. историю изменений ведёт git. Код лежит на GitHub.</a:t>
             </a:r>
             <a:endParaRPr lang="en-US" dirty="0"/>
           </a:p>
@@ -1664,7 +1575,7 @@
           <a:p>
             <a:r>
               <a:rPr lang="en-US" dirty="0"/>
-              <a:t>Код поделён на две части. В папке planner вся логика: классы экзамена и темы, планировщик, оценка сложности, работа с файлами. В папке ui окно. Данные хранятся в трёх CSV. Логика про окно ничего не знает, и поэтому тесты проверяют её без интерфейса.</a:t>
+              <a:t>Код поделён на две части. В папке planner вся логика: классы экзамена и темы, планировщик, оценка сложности, работа с файлами. В папке ui окно. Данные хранятся в трёх CSV. Логика про окно ничего не знает, поэтому её можно менять отдельно.</a:t>
             </a:r>
             <a:endParaRPr lang="en-US" dirty="0"/>
           </a:p>
@@ -3039,8 +2950,8 @@
         </p:nvSpPr>
         <p:spPr>
           <a:xfrm>
-            <a:off x="521208" y="1542022"/>
-            <a:ext cx="11146536" cy="4414036"/>
+            <a:off x="521208" y="1209233"/>
+            <a:ext cx="11146536" cy="5079615"/>
           </a:xfrm>
           <a:prstGeom prst="rect">
             <a:avLst/>
@@ -3072,8 +2983,8 @@
         </p:blipFill>
         <p:spPr>
           <a:xfrm>
-            <a:off x="548640" y="1569454"/>
-            <a:ext cx="11091672" cy="4359172"/>
+            <a:off x="548640" y="1236665"/>
+            <a:ext cx="11091672" cy="5024751"/>
           </a:xfrm>
           <a:prstGeom prst="rect">
             <a:avLst/>
@@ -3200,8 +3111,8 @@
         </p:nvSpPr>
         <p:spPr>
           <a:xfrm>
-            <a:off x="1015786" y="1207008"/>
-            <a:ext cx="10157380" cy="5084064"/>
+            <a:off x="585657" y="1207008"/>
+            <a:ext cx="11017638" cy="5084064"/>
           </a:xfrm>
           <a:prstGeom prst="rect">
             <a:avLst/>
@@ -3233,8 +3144,8 @@
         </p:blipFill>
         <p:spPr>
           <a:xfrm>
-            <a:off x="1043218" y="1234440"/>
-            <a:ext cx="10102516" cy="5029200"/>
+            <a:off x="613089" y="1234440"/>
+            <a:ext cx="10962774" cy="5029200"/>
           </a:xfrm>
           <a:prstGeom prst="rect">
             <a:avLst/>
@@ -3361,8 +3272,8 @@
         </p:nvSpPr>
         <p:spPr>
           <a:xfrm>
-            <a:off x="1222741" y="1207008"/>
-            <a:ext cx="9743470" cy="5084064"/>
+            <a:off x="1382985" y="1207008"/>
+            <a:ext cx="9422982" cy="5084064"/>
           </a:xfrm>
           <a:prstGeom prst="rect">
             <a:avLst/>
@@ -3394,8 +3305,8 @@
         </p:blipFill>
         <p:spPr>
           <a:xfrm>
-            <a:off x="1250173" y="1234440"/>
-            <a:ext cx="9688606" cy="5029200"/>
+            <a:off x="1410417" y="1234440"/>
+            <a:ext cx="9368118" cy="5029200"/>
           </a:xfrm>
           <a:prstGeom prst="rect">
             <a:avLst/>
@@ -3522,8 +3433,8 @@
         </p:nvSpPr>
         <p:spPr>
           <a:xfrm>
-            <a:off x="824618" y="1207008"/>
-            <a:ext cx="10539717" cy="5084064"/>
+            <a:off x="737357" y="1207008"/>
+            <a:ext cx="10714238" cy="5084064"/>
           </a:xfrm>
           <a:prstGeom prst="rect">
             <a:avLst/>
@@ -3555,8 +3466,8 @@
         </p:blipFill>
         <p:spPr>
           <a:xfrm>
-            <a:off x="852050" y="1234440"/>
-            <a:ext cx="10484853" cy="5029200"/>
+            <a:off x="764789" y="1234440"/>
+            <a:ext cx="10659374" cy="5029200"/>
           </a:xfrm>
           <a:prstGeom prst="rect">
             <a:avLst/>
@@ -6492,395 +6403,6 @@
       </p:grpSpPr>
       <p:sp>
         <p:nvSpPr>
-          <p:cNvPr id="2" name="Title"/>
-          <p:cNvSpPr txBox="1"/>
-          <p:nvPr/>
-        </p:nvSpPr>
-        <p:spPr>
-          <a:xfrm>
-            <a:off x="548640" y="320040"/>
-            <a:ext cx="11064240" cy="822960"/>
-          </a:xfrm>
-          <a:prstGeom prst="rect">
-            <a:avLst/>
-          </a:prstGeom>
-          <a:noFill/>
-          <a:ln/>
-        </p:spPr>
-        <p:txBody>
-          <a:bodyPr wrap="square" lIns="0" tIns="0" rIns="0" bIns="0" rtlCol="0" anchor="ctr"/>
-          <a:lstStyle/>
-          <a:p>
-            <a:pPr indent="0" marL="0">
-              <a:buNone/>
-            </a:pPr>
-            <a:r>
-              <a:rPr lang="en-US" sz="3400" b="1" dirty="0">
-                <a:solidFill>
-                  <a:srgbClr val="1E1B4B"/>
-                </a:solidFill>
-                <a:latin typeface="Cambria" pitchFamily="34" charset="0"/>
-                <a:ea typeface="Cambria" pitchFamily="34" charset="-122"/>
-                <a:cs typeface="Cambria" pitchFamily="34" charset="-120"/>
-              </a:rPr>
-              <a:t>Тестирование</a:t>
-            </a:r>
-            <a:endParaRPr lang="en-US" sz="3400" dirty="0"/>
-          </a:p>
-        </p:txBody>
-      </p:sp>
-      <p:sp>
-        <p:nvSpPr>
-          <p:cNvPr id="4" name="Shape 1"/>
-          <p:cNvSpPr/>
-          <p:nvPr/>
-        </p:nvSpPr>
-        <p:spPr>
-          <a:xfrm>
-            <a:off x="548640" y="1463040"/>
-            <a:ext cx="3840480" cy="4206240"/>
-          </a:xfrm>
-          <a:prstGeom prst="roundRect">
-            <a:avLst>
-              <a:gd name="adj" fmla="val 2857"/>
-            </a:avLst>
-          </a:prstGeom>
-          <a:solidFill>
-            <a:srgbClr val="1E1B4B"/>
-          </a:solidFill>
-          <a:ln w="9525">
-            <a:solidFill>
-              <a:srgbClr val="DBE3EE"/>
-            </a:solidFill>
-            <a:prstDash val="solid"/>
-          </a:ln>
-          <a:effectLst>
-            <a:outerShdw sx="100000" sy="100000" kx="0" ky="0" algn="bl" rotWithShape="0" blurRad="76200" dist="25400" dir="5400000">
-              <a:srgbClr val="000000">
-                <a:alpha val="8000"/>
-              </a:srgbClr>
-            </a:outerShdw>
-          </a:effectLst>
-        </p:spPr>
-      </p:sp>
-      <p:sp>
-        <p:nvSpPr>
-          <p:cNvPr id="5" name="Text 2"/>
-          <p:cNvSpPr txBox="1"/>
-          <p:nvPr/>
-        </p:nvSpPr>
-        <p:spPr>
-          <a:xfrm>
-            <a:off x="548640" y="1828800"/>
-            <a:ext cx="3840480" cy="1737360"/>
-          </a:xfrm>
-          <a:prstGeom prst="rect">
-            <a:avLst/>
-          </a:prstGeom>
-          <a:noFill/>
-          <a:ln/>
-        </p:spPr>
-        <p:txBody>
-          <a:bodyPr wrap="square" lIns="0" tIns="0" rIns="0" bIns="0" rtlCol="0" anchor="ctr"/>
-          <a:lstStyle/>
-          <a:p>
-            <a:pPr algn="ctr" indent="0" marL="0">
-              <a:buNone/>
-            </a:pPr>
-            <a:r>
-              <a:rPr lang="en-US" sz="11000" b="1" dirty="0">
-                <a:solidFill>
-                  <a:srgbClr val="FFFFFF"/>
-                </a:solidFill>
-                <a:latin typeface="Cambria" pitchFamily="34" charset="0"/>
-                <a:ea typeface="Cambria" pitchFamily="34" charset="-122"/>
-                <a:cs typeface="Cambria" pitchFamily="34" charset="-120"/>
-              </a:rPr>
-              <a:t>83</a:t>
-            </a:r>
-            <a:endParaRPr lang="en-US" sz="11000" dirty="0"/>
-          </a:p>
-        </p:txBody>
-      </p:sp>
-      <p:sp>
-        <p:nvSpPr>
-          <p:cNvPr id="6" name="Text 3"/>
-          <p:cNvSpPr txBox="1"/>
-          <p:nvPr/>
-        </p:nvSpPr>
-        <p:spPr>
-          <a:xfrm>
-            <a:off x="548640" y="3657600"/>
-            <a:ext cx="3840480" cy="1097280"/>
-          </a:xfrm>
-          <a:prstGeom prst="rect">
-            <a:avLst/>
-          </a:prstGeom>
-          <a:noFill/>
-          <a:ln/>
-        </p:spPr>
-        <p:txBody>
-          <a:bodyPr wrap="square" lIns="0" tIns="0" rIns="0" bIns="0" rtlCol="0" anchor="t"/>
-          <a:lstStyle/>
-          <a:p>
-            <a:pPr algn="ctr" indent="0" marL="0">
-              <a:buNone/>
-            </a:pPr>
-            <a:r>
-              <a:rPr lang="en-US" sz="2200" dirty="0">
-                <a:solidFill>
-                  <a:srgbClr val="C7D2FE"/>
-                </a:solidFill>
-                <a:latin typeface="Calibri" pitchFamily="34" charset="0"/>
-                <a:ea typeface="Calibri" pitchFamily="34" charset="-122"/>
-                <a:cs typeface="Calibri" pitchFamily="34" charset="-120"/>
-              </a:rPr>
-              <a:t>автотестов pytest,</a:t>
-            </a:r>
-            <a:endParaRPr lang="en-US" sz="2200" dirty="0"/>
-          </a:p>
-          <a:p>
-            <a:pPr algn="ctr" indent="0" marL="0">
-              <a:buNone/>
-            </a:pPr>
-            <a:r>
-              <a:rPr lang="en-US" sz="2200" dirty="0">
-                <a:solidFill>
-                  <a:srgbClr val="C7D2FE"/>
-                </a:solidFill>
-                <a:latin typeface="Calibri" pitchFamily="34" charset="0"/>
-                <a:ea typeface="Calibri" pitchFamily="34" charset="-122"/>
-                <a:cs typeface="Calibri" pitchFamily="34" charset="-120"/>
-              </a:rPr>
-              <a:t>все проходят</a:t>
-            </a:r>
-            <a:endParaRPr lang="en-US" sz="2200" dirty="0"/>
-          </a:p>
-        </p:txBody>
-      </p:sp>
-      <p:sp>
-        <p:nvSpPr>
-          <p:cNvPr id="7" name="Text 4"/>
-          <p:cNvSpPr txBox="1"/>
-          <p:nvPr/>
-        </p:nvSpPr>
-        <p:spPr>
-          <a:xfrm>
-            <a:off x="4846320" y="1554480"/>
-            <a:ext cx="6766560" cy="4023360"/>
-          </a:xfrm>
-          <a:prstGeom prst="rect">
-            <a:avLst/>
-          </a:prstGeom>
-          <a:noFill/>
-          <a:ln/>
-        </p:spPr>
-        <p:txBody>
-          <a:bodyPr wrap="square" lIns="0" tIns="0" rIns="0" bIns="0" rtlCol="0" anchor="t"/>
-          <a:lstStyle/>
-          <a:p>
-            <a:pPr marL="228600" indent="-228600">
-              <a:spcAft>
-                <a:spcPts val="800"/>
-              </a:spcAft>
-              <a:buSzPct val="100000"/>
-              <a:buChar char="•"/>
-            </a:pPr>
-            <a:r>
-              <a:rPr lang="en-US" sz="2000" dirty="0">
-                <a:solidFill>
-                  <a:srgbClr val="0F172A"/>
-                </a:solidFill>
-                <a:latin typeface="Calibri" pitchFamily="34" charset="0"/>
-                <a:ea typeface="Calibri" pitchFamily="34" charset="-122"/>
-                <a:cs typeface="Calibri" pitchFamily="34" charset="-120"/>
-              </a:rPr>
-              <a:t>Неверные даты, сложность, лимиты, повторы</a:t>
-            </a:r>
-            <a:endParaRPr lang="en-US" sz="2000" dirty="0"/>
-          </a:p>
-          <a:p>
-            <a:pPr marL="228600" indent="-228600">
-              <a:spcAft>
-                <a:spcPts val="800"/>
-              </a:spcAft>
-              <a:buSzPct val="100000"/>
-              <a:buChar char="•"/>
-            </a:pPr>
-            <a:r>
-              <a:rPr lang="en-US" sz="2000" dirty="0">
-                <a:solidFill>
-                  <a:srgbClr val="0F172A"/>
-                </a:solidFill>
-                <a:latin typeface="Calibri" pitchFamily="34" charset="0"/>
-                <a:ea typeface="Calibri" pitchFamily="34" charset="-122"/>
-                <a:cs typeface="Calibri" pitchFamily="34" charset="-120"/>
-              </a:rPr>
-              <a:t>Лимит часов в день и на тему не превышается</a:t>
-            </a:r>
-            <a:endParaRPr lang="en-US" sz="2000" dirty="0"/>
-          </a:p>
-          <a:p>
-            <a:pPr marL="228600" indent="-228600">
-              <a:spcAft>
-                <a:spcPts val="800"/>
-              </a:spcAft>
-              <a:buSzPct val="100000"/>
-              <a:buChar char="•"/>
-            </a:pPr>
-            <a:r>
-              <a:rPr lang="en-US" sz="2000" dirty="0">
-                <a:solidFill>
-                  <a:srgbClr val="0F172A"/>
-                </a:solidFill>
-                <a:latin typeface="Calibri" pitchFamily="34" charset="0"/>
-                <a:ea typeface="Calibri" pitchFamily="34" charset="-122"/>
-                <a:cs typeface="Calibri" pitchFamily="34" charset="-120"/>
-              </a:rPr>
-              <a:t>День перед экзаменом — только повторение</a:t>
-            </a:r>
-            <a:endParaRPr lang="en-US" sz="2000" dirty="0"/>
-          </a:p>
-          <a:p>
-            <a:pPr marL="228600" indent="-228600">
-              <a:spcAft>
-                <a:spcPts val="800"/>
-              </a:spcAft>
-              <a:buSzPct val="100000"/>
-              <a:buChar char="•"/>
-            </a:pPr>
-            <a:r>
-              <a:rPr lang="en-US" sz="2000" dirty="0">
-                <a:solidFill>
-                  <a:srgbClr val="0F172A"/>
-                </a:solidFill>
-                <a:latin typeface="Calibri" pitchFamily="34" charset="0"/>
-                <a:ea typeface="Calibri" pitchFamily="34" charset="-122"/>
-                <a:cs typeface="Calibri" pitchFamily="34" charset="-120"/>
-              </a:rPr>
-              <a:t>Перепланирование и предупреждение о риске</a:t>
-            </a:r>
-            <a:endParaRPr lang="en-US" sz="2000" dirty="0"/>
-          </a:p>
-          <a:p>
-            <a:pPr marL="228600" indent="-228600">
-              <a:spcAft>
-                <a:spcPts val="800"/>
-              </a:spcAft>
-              <a:buSzPct val="100000"/>
-              <a:buChar char="•"/>
-            </a:pPr>
-            <a:r>
-              <a:rPr lang="en-US" sz="2000" dirty="0">
-                <a:solidFill>
-                  <a:srgbClr val="0F172A"/>
-                </a:solidFill>
-                <a:latin typeface="Calibri" pitchFamily="34" charset="0"/>
-                <a:ea typeface="Calibri" pitchFamily="34" charset="-122"/>
-                <a:cs typeface="Calibri" pitchFamily="34" charset="-120"/>
-              </a:rPr>
-              <a:t>Автоподбор сложности и списки предметов</a:t>
-            </a:r>
-            <a:endParaRPr lang="en-US" sz="2000" dirty="0"/>
-          </a:p>
-          <a:p>
-            <a:pPr marL="228600" indent="-228600">
-              <a:spcAft>
-                <a:spcPts val="800"/>
-              </a:spcAft>
-              <a:buSzPct val="100000"/>
-              <a:buChar char="•"/>
-            </a:pPr>
-            <a:r>
-              <a:rPr lang="en-US" sz="2000" dirty="0">
-                <a:solidFill>
-                  <a:srgbClr val="0F172A"/>
-                </a:solidFill>
-                <a:latin typeface="Calibri" pitchFamily="34" charset="0"/>
-                <a:ea typeface="Calibri" pitchFamily="34" charset="-122"/>
-                <a:cs typeface="Calibri" pitchFamily="34" charset="-120"/>
-              </a:rPr>
-              <a:t>Повреждённые и неполные CSV-файлы</a:t>
-            </a:r>
-            <a:endParaRPr lang="en-US" sz="2000" dirty="0"/>
-          </a:p>
-        </p:txBody>
-      </p:sp>
-      <p:sp>
-        <p:nvSpPr>
-          <p:cNvPr id="25" name="Slide Number Placeholder 0"/>
-          <p:cNvSpPr>
-            <a:spLocks noGrp="1"/>
-          </p:cNvSpPr>
-          <p:nvPr>
-            <p:ph type="sldNum" sz="quarter" idx="4294967295"/>
-          </p:nvPr>
-        </p:nvSpPr>
-        <p:spPr>
-          <a:xfrm>
-            <a:off x="10972800" y="6400800"/>
-            <a:ext cx="731520" cy="274320"/>
-          </a:xfrm>
-          <a:prstGeom prst="rect">
-            <a:avLst/>
-          </a:prstGeom>
-          <a:extLst>
-            <a:ext uri="{C572A759-6A51-4108-AA02-DFA0A04FC94B}">
-              <ma14:wrappingTextBoxFlag xmlns:ma14="http://schemas.microsoft.com/office/mac/drawingml/2011/main" val="0"/>
-            </a:ext>
-          </a:extLst>
-        </p:spPr>
-        <p:txBody>
-          <a:bodyPr/>
-          <a:lstStyle>
-            <a:lvl1pPr>
-              <a:defRPr sz="1000">
-                <a:solidFill>
-                  <a:srgbClr val="64748B"/>
-                </a:solidFill>
-                <a:latin typeface="Calibri"/>
-                <a:ea typeface="Calibri"/>
-                <a:cs typeface="Calibri"/>
-              </a:defRPr>
-            </a:lvl1pPr>
-          </a:lstStyle>
-          <a:p>
-            <a:pPr algn="r"/>
-            <a:fld id="{F7021451-1387-4CA6-816F-3879F97B5CBC}" type="slidenum">
-              <a:rPr b="0" lang="en-US"/>
-              <a:t>18</a:t>
-            </a:fld>
-            <a:endParaRPr lang="en-US"/>
-          </a:p>
-        </p:txBody>
-      </p:sp>
-    </p:spTree>
-  </p:cSld>
-  <p:clrMapOvr>
-    <a:masterClrMapping/>
-  </p:clrMapOvr>
-</p:sld>
-</file>
-
-<file path=ppt/slides/slide19.xml><?xml version="1.0" encoding="utf-8"?>
-<p:sld xmlns:a="http://schemas.openxmlformats.org/drawingml/2006/main" xmlns:r="http://schemas.openxmlformats.org/officeDocument/2006/relationships" xmlns:p="http://schemas.openxmlformats.org/presentationml/2006/main">
-  <p:cSld name="Slide 19">
-    <p:spTree>
-      <p:nvGrpSpPr>
-        <p:cNvPr id="1" name=""/>
-        <p:cNvGrpSpPr/>
-        <p:nvPr/>
-      </p:nvGrpSpPr>
-      <p:grpSpPr>
-        <a:xfrm>
-          <a:off x="0" y="0"/>
-          <a:ext cx="0" cy="0"/>
-          <a:chOff x="0" y="0"/>
-          <a:chExt cx="0" cy="0"/>
-        </a:xfrm>
-      </p:grpSpPr>
-      <p:sp>
-        <p:nvSpPr>
           <p:cNvPr id="2" name="Text 0"/>
           <p:cNvSpPr txBox="1"/>
           <p:nvPr/>
@@ -6976,7 +6498,7 @@
                 <a:ea typeface="Calibri" pitchFamily="34" charset="-122"/>
                 <a:cs typeface="Calibri" pitchFamily="34" charset="-120"/>
               </a:rPr>
-              <a:t>Ошибки, словари и ООП в деле, плюс визуализация, CSV и тесты</a:t>
+              <a:t>Ошибки, словари и ООП в деле, плюс визуализация и CSV</a:t>
             </a:r>
             <a:endParaRPr lang="en-US" sz="2200" dirty="0"/>
           </a:p>
@@ -8751,7 +8273,7 @@
                 <a:ea typeface="Cambria" pitchFamily="34" charset="-122"/>
                 <a:cs typeface="Cambria" pitchFamily="34" charset="-120"/>
               </a:rPr>
-              <a:t>pytest</a:t>
+              <a:t>git</a:t>
             </a:r>
             <a:endParaRPr lang="en-US" sz="2200" dirty="0"/>
           </a:p>
@@ -8790,7 +8312,7 @@
                 <a:ea typeface="Calibri" pitchFamily="34" charset="-122"/>
                 <a:cs typeface="Calibri" pitchFamily="34" charset="-120"/>
               </a:rPr>
-              <a:t>83 автотеста</a:t>
+              <a:t>история версий проекта</a:t>
             </a:r>
             <a:endParaRPr lang="en-US" sz="1600" dirty="0"/>
           </a:p>
@@ -8863,7 +8385,7 @@
                 <a:ea typeface="Cambria" pitchFamily="34" charset="-122"/>
                 <a:cs typeface="Cambria" pitchFamily="34" charset="-120"/>
               </a:rPr>
-              <a:t>git</a:t>
+              <a:t>GitHub</a:t>
             </a:r>
             <a:endParaRPr lang="en-US" sz="2200" dirty="0"/>
           </a:p>
@@ -8878,118 +8400,6 @@
         <p:spPr>
           <a:xfrm>
             <a:off x="6345936" y="4983480"/>
-            <a:ext cx="2258568" cy="640080"/>
-          </a:xfrm>
-          <a:prstGeom prst="rect">
-            <a:avLst/>
-          </a:prstGeom>
-          <a:noFill/>
-          <a:ln/>
-        </p:spPr>
-        <p:txBody>
-          <a:bodyPr wrap="square" lIns="0" tIns="0" rIns="0" bIns="0" rtlCol="0" anchor="t"/>
-          <a:lstStyle/>
-          <a:p>
-            <a:pPr indent="0" marL="0">
-              <a:buNone/>
-            </a:pPr>
-            <a:r>
-              <a:rPr lang="en-US" sz="1600" dirty="0">
-                <a:solidFill>
-                  <a:srgbClr val="64748B"/>
-                </a:solidFill>
-                <a:latin typeface="Calibri" pitchFamily="34" charset="0"/>
-                <a:ea typeface="Calibri" pitchFamily="34" charset="-122"/>
-                <a:cs typeface="Calibri" pitchFamily="34" charset="-120"/>
-              </a:rPr>
-              <a:t>история версий проекта</a:t>
-            </a:r>
-            <a:endParaRPr lang="en-US" sz="1600" dirty="0"/>
-          </a:p>
-        </p:txBody>
-      </p:sp>
-      <p:sp>
-        <p:nvSpPr>
-          <p:cNvPr id="25" name="Shape 22"/>
-          <p:cNvSpPr/>
-          <p:nvPr/>
-        </p:nvSpPr>
-        <p:spPr>
-          <a:xfrm>
-            <a:off x="8970264" y="3794760"/>
-            <a:ext cx="2624328" cy="1965960"/>
-          </a:xfrm>
-          <a:prstGeom prst="roundRect">
-            <a:avLst>
-              <a:gd name="adj" fmla="val 5581"/>
-            </a:avLst>
-          </a:prstGeom>
-          <a:solidFill>
-            <a:srgbClr val="FFFFFF"/>
-          </a:solidFill>
-          <a:ln w="9525">
-            <a:solidFill>
-              <a:srgbClr val="DBE3EE"/>
-            </a:solidFill>
-            <a:prstDash val="solid"/>
-          </a:ln>
-          <a:effectLst>
-            <a:outerShdw sx="100000" sy="100000" kx="0" ky="0" algn="bl" rotWithShape="0" blurRad="76200" dist="25400" dir="5400000">
-              <a:srgbClr val="000000">
-                <a:alpha val="8000"/>
-              </a:srgbClr>
-            </a:outerShdw>
-          </a:effectLst>
-        </p:spPr>
-      </p:sp>
-      <p:sp>
-        <p:nvSpPr>
-          <p:cNvPr id="26" name="Text 23"/>
-          <p:cNvSpPr txBox="1"/>
-          <p:nvPr/>
-        </p:nvSpPr>
-        <p:spPr>
-          <a:xfrm>
-            <a:off x="9153144" y="4069080"/>
-            <a:ext cx="2258568" cy="822960"/>
-          </a:xfrm>
-          <a:prstGeom prst="rect">
-            <a:avLst/>
-          </a:prstGeom>
-          <a:noFill/>
-          <a:ln/>
-        </p:spPr>
-        <p:txBody>
-          <a:bodyPr wrap="square" lIns="0" tIns="0" rIns="0" bIns="0" rtlCol="0" anchor="t"/>
-          <a:lstStyle/>
-          <a:p>
-            <a:pPr indent="0" marL="0">
-              <a:buNone/>
-            </a:pPr>
-            <a:r>
-              <a:rPr lang="en-US" sz="2200" b="1" dirty="0">
-                <a:solidFill>
-                  <a:srgbClr val="1E1B4B"/>
-                </a:solidFill>
-                <a:latin typeface="Cambria" pitchFamily="34" charset="0"/>
-                <a:ea typeface="Cambria" pitchFamily="34" charset="-122"/>
-                <a:cs typeface="Cambria" pitchFamily="34" charset="-120"/>
-              </a:rPr>
-              <a:t>GitHub</a:t>
-            </a:r>
-            <a:endParaRPr lang="en-US" sz="2200" dirty="0"/>
-          </a:p>
-        </p:txBody>
-      </p:sp>
-      <p:sp>
-        <p:nvSpPr>
-          <p:cNvPr id="27" name="Text 24"/>
-          <p:cNvSpPr txBox="1"/>
-          <p:nvPr/>
-        </p:nvSpPr>
-        <p:spPr>
-          <a:xfrm>
-            <a:off x="9153144" y="4983480"/>
             <a:ext cx="2258568" cy="640080"/>
           </a:xfrm>
           <a:prstGeom prst="rect">
@@ -9808,7 +9218,7 @@
                 <a:ea typeface="Calibri" pitchFamily="34" charset="-122"/>
                 <a:cs typeface="Calibri" pitchFamily="34" charset="-120"/>
               </a:rPr>
-              <a:t>Логика не зависит от окна, поэтому тесты проверяют её без интерфейса</a:t>
+              <a:t>Логика не зависит от окна, поэтому её можно менять отдельно</a:t>
             </a:r>
             <a:endParaRPr lang="en-US" sz="1800" dirty="0"/>
           </a:p>
@@ -13227,8 +12637,8 @@
         </p:nvSpPr>
         <p:spPr>
           <a:xfrm>
-            <a:off x="1015786" y="1207008"/>
-            <a:ext cx="10157380" cy="5084064"/>
+            <a:off x="1583339" y="1207008"/>
+            <a:ext cx="9022274" cy="5084064"/>
           </a:xfrm>
           <a:prstGeom prst="rect">
             <a:avLst/>
@@ -13260,8 +12670,8 @@
         </p:blipFill>
         <p:spPr>
           <a:xfrm>
-            <a:off x="1043218" y="1234440"/>
-            <a:ext cx="10102516" cy="5029200"/>
+            <a:off x="1610771" y="1234440"/>
+            <a:ext cx="8967410" cy="5029200"/>
           </a:xfrm>
           <a:prstGeom prst="rect">
             <a:avLst/>
@@ -13388,8 +12798,8 @@
         </p:nvSpPr>
         <p:spPr>
           <a:xfrm>
-            <a:off x="521208" y="1867714"/>
-            <a:ext cx="11146536" cy="3762651"/>
+            <a:off x="521208" y="1777450"/>
+            <a:ext cx="11146536" cy="3943180"/>
           </a:xfrm>
           <a:prstGeom prst="rect">
             <a:avLst/>
@@ -13421,8 +12831,8 @@
         </p:blipFill>
         <p:spPr>
           <a:xfrm>
-            <a:off x="548640" y="1895146"/>
-            <a:ext cx="11091672" cy="3707787"/>
+            <a:off x="548640" y="1804882"/>
+            <a:ext cx="11091672" cy="3888316"/>
           </a:xfrm>
           <a:prstGeom prst="rect">
             <a:avLst/>

</xml_diff>

<commit_message>
Report rewritten in plainer words, real screenshots, date picker section
Co-Authored-By: Claude Sonnet 5.5 <noreply@anthropic.com>
</commit_message>
<xml_diff>
--- a/docs/Презентация_Планировщик_экзаменов.pptx
+++ b/docs/Презентация_Планировщик_экзаменов.pptx
@@ -6255,79 +6255,47 @@
         </p:nvSpPr>
         <p:spPr>
           <a:xfrm>
-            <a:off x="7589520" y="4114800"/>
-            <a:ext cx="4050792" cy="2011680"/>
+            <a:off x="7994904" y="4087368"/>
+            <a:ext cx="3240024" cy="2066544"/>
           </a:xfrm>
           <a:prstGeom prst="rect">
             <a:avLst/>
           </a:prstGeom>
           <a:solidFill>
-            <a:srgbClr val="E2E8F0"/>
+            <a:srgbClr val="FFFFFF"/>
           </a:solidFill>
-          <a:ln w="12700">
+          <a:ln w="9525">
             <a:solidFill>
-              <a:srgbClr val="94A3B8"/>
+              <a:srgbClr val="CBD5E1"/>
             </a:solidFill>
-            <a:prstDash val="dash"/>
+            <a:prstDash val="solid"/>
           </a:ln>
         </p:spPr>
       </p:sp>
-      <p:sp>
-        <p:nvSpPr>
-          <p:cNvPr id="8" name="Text 3"/>
-          <p:cNvSpPr txBox="1"/>
-          <p:nvPr/>
-        </p:nvSpPr>
-        <p:spPr>
-          <a:xfrm>
-            <a:off x="7589520" y="4114800"/>
-            <a:ext cx="4050792" cy="2011680"/>
-          </a:xfrm>
-          <a:prstGeom prst="rect">
-            <a:avLst/>
-          </a:prstGeom>
-          <a:noFill/>
-          <a:ln/>
-        </p:spPr>
-        <p:txBody>
-          <a:bodyPr wrap="square" rtlCol="0" anchor="ctr"/>
-          <a:lstStyle/>
-          <a:p>
-            <a:pPr algn="ctr" indent="0" marL="0">
-              <a:buNone/>
-            </a:pPr>
-            <a:r>
-              <a:rPr lang="en-US" sz="1600" dirty="0">
-                <a:solidFill>
-                  <a:srgbClr val="64748B"/>
-                </a:solidFill>
-                <a:latin typeface="Calibri" pitchFamily="34" charset="0"/>
-                <a:ea typeface="Calibri" pitchFamily="34" charset="-122"/>
-                <a:cs typeface="Calibri" pitchFamily="34" charset="-120"/>
-              </a:rPr>
-              <a:t>Здесь будет скриншот</a:t>
-            </a:r>
-            <a:endParaRPr lang="en-US" sz="1600" dirty="0"/>
-          </a:p>
-          <a:p>
-            <a:pPr algn="ctr" indent="0" marL="0">
-              <a:buNone/>
-            </a:pPr>
-            <a:r>
-              <a:rPr lang="en-US" sz="1600" dirty="0">
-                <a:solidFill>
-                  <a:srgbClr val="64748B"/>
-                </a:solidFill>
-                <a:latin typeface="Calibri" pitchFamily="34" charset="0"/>
-                <a:ea typeface="Calibri" pitchFamily="34" charset="-122"/>
-                <a:cs typeface="Calibri" pitchFamily="34" charset="-120"/>
-              </a:rPr>
-              <a:t>04_error.png</a:t>
-            </a:r>
-            <a:endParaRPr lang="en-US" sz="1600" dirty="0"/>
-          </a:p>
-        </p:txBody>
-      </p:sp>
+      <p:pic>
+        <p:nvPicPr>
+          <p:cNvPr id="8" name="Image 1" descr="Скриншот программы: 04_error.png">    </p:cNvPr>
+          <p:cNvPicPr>
+            <a:picLocks noChangeAspect="1"/>
+          </p:cNvPicPr>
+          <p:nvPr/>
+        </p:nvPicPr>
+        <p:blipFill>
+          <a:blip r:embed="rId2"/>
+          <a:stretch>
+            <a:fillRect/>
+          </a:stretch>
+        </p:blipFill>
+        <p:spPr>
+          <a:xfrm>
+            <a:off x="8022336" y="4114800"/>
+            <a:ext cx="3185160" cy="2011680"/>
+          </a:xfrm>
+          <a:prstGeom prst="rect">
+            <a:avLst/>
+          </a:prstGeom>
+        </p:spPr>
+      </p:pic>
       <p:sp>
         <p:nvSpPr>
           <p:cNvPr id="25" name="Slide Number Placeholder 0"/>

</xml_diff>

<commit_message>
Fix surname (Саладзе), remove project number, clearer title slide
Co-Authored-By: Claude Sonnet 5.5 <noreply@anthropic.com>
</commit_message>
<xml_diff>
--- a/docs/Презентация_Планировщик_экзаменов.pptx
+++ b/docs/Презентация_Планировщик_экзаменов.pptx
@@ -519,7 +519,7 @@
           <a:p>
             <a:r>
               <a:rPr lang="en-US" dirty="0"/>
-              <a:t>Здравствуйте! Мы — Павел Дибривный и Георгий Салазде, группы ИСТ04 и ИСТ03. Наш проект номер 60: планировщик подготовки к экзаменам. Программа на Python сама раскладывает темы по дням, а если вы отстали, пересчитывает план.</a:t>
+              <a:t>Здравствуйте! Мы, Павел Дибривный и Георгий Саладзе, из групп ИСТ04 и ИСТ03. Это наш итоговый проект по Python, планировщик подготовки к экзаменам. Программа сама раскладывает темы по дням, а если вы отстали, пересчитывает план.</a:t>
             </a:r>
             <a:endParaRPr lang="en-US" dirty="0"/>
           </a:p>
@@ -2590,7 +2590,46 @@
         </p:nvSpPr>
         <p:spPr>
           <a:xfrm>
-            <a:off x="731520" y="1554480"/>
+            <a:off x="731520" y="731520"/>
+            <a:ext cx="10698480" cy="457200"/>
+          </a:xfrm>
+          <a:prstGeom prst="rect">
+            <a:avLst/>
+          </a:prstGeom>
+          <a:noFill/>
+          <a:ln/>
+        </p:spPr>
+        <p:txBody>
+          <a:bodyPr wrap="square" lIns="0" tIns="0" rIns="0" bIns="0" rtlCol="0" anchor="ctr"/>
+          <a:lstStyle/>
+          <a:p>
+            <a:pPr indent="0" marL="0">
+              <a:buNone/>
+            </a:pPr>
+            <a:r>
+              <a:rPr lang="en-US" sz="1800" b="1" dirty="0">
+                <a:solidFill>
+                  <a:srgbClr val="A5B4FC"/>
+                </a:solidFill>
+                <a:latin typeface="Calibri" pitchFamily="34" charset="0"/>
+                <a:ea typeface="Calibri" pitchFamily="34" charset="-122"/>
+                <a:cs typeface="Calibri" pitchFamily="34" charset="-120"/>
+              </a:rPr>
+              <a:t>ИТОГОВЫЙ ПРОЕКТ ПО PYTHON</a:t>
+            </a:r>
+            <a:endParaRPr lang="en-US" sz="1800" dirty="0"/>
+          </a:p>
+        </p:txBody>
+      </p:sp>
+      <p:sp>
+        <p:nvSpPr>
+          <p:cNvPr id="3" name="Text 1"/>
+          <p:cNvSpPr txBox="1"/>
+          <p:nvPr/>
+        </p:nvSpPr>
+        <p:spPr>
+          <a:xfrm>
+            <a:off x="731520" y="1371600"/>
             <a:ext cx="10698480" cy="2011680"/>
           </a:xfrm>
           <a:prstGeom prst="rect">
@@ -2640,14 +2679,14 @@
       </p:sp>
       <p:sp>
         <p:nvSpPr>
-          <p:cNvPr id="3" name="Text 1"/>
+          <p:cNvPr id="4" name="Text 2"/>
           <p:cNvSpPr txBox="1"/>
           <p:nvPr/>
         </p:nvSpPr>
         <p:spPr>
           <a:xfrm>
-            <a:off x="731520" y="3840480"/>
-            <a:ext cx="10698480" cy="548640"/>
+            <a:off x="731520" y="3566160"/>
+            <a:ext cx="10058400" cy="914400"/>
           </a:xfrm>
           <a:prstGeom prst="rect">
             <a:avLst/>
@@ -2656,7 +2695,7 @@
           <a:ln/>
         </p:spPr>
         <p:txBody>
-          <a:bodyPr wrap="square" lIns="0" tIns="0" rIns="0" bIns="0" rtlCol="0" anchor="ctr"/>
+          <a:bodyPr wrap="square" lIns="0" tIns="0" rIns="0" bIns="0" rtlCol="0" anchor="t"/>
           <a:lstStyle/>
           <a:p>
             <a:pPr indent="0" marL="0">
@@ -2671,48 +2710,9 @@
                 <a:ea typeface="Calibri" pitchFamily="34" charset="-122"/>
                 <a:cs typeface="Calibri" pitchFamily="34" charset="-120"/>
               </a:rPr>
-              <a:t>Проект №60 · итоговый проект по Python</a:t>
+              <a:t>Программа сама распределяет, что учить каждый день до экзамена, и пересчитывает план, если вы отстали</a:t>
             </a:r>
             <a:endParaRPr lang="en-US" sz="2400" dirty="0"/>
-          </a:p>
-        </p:txBody>
-      </p:sp>
-      <p:sp>
-        <p:nvSpPr>
-          <p:cNvPr id="4" name="Text 2"/>
-          <p:cNvSpPr txBox="1"/>
-          <p:nvPr/>
-        </p:nvSpPr>
-        <p:spPr>
-          <a:xfrm>
-            <a:off x="731520" y="5669280"/>
-            <a:ext cx="10698480" cy="457200"/>
-          </a:xfrm>
-          <a:prstGeom prst="rect">
-            <a:avLst/>
-          </a:prstGeom>
-          <a:noFill/>
-          <a:ln/>
-        </p:spPr>
-        <p:txBody>
-          <a:bodyPr wrap="square" lIns="0" tIns="0" rIns="0" bIns="0" rtlCol="0" anchor="ctr"/>
-          <a:lstStyle/>
-          <a:p>
-            <a:pPr indent="0" marL="0">
-              <a:buNone/>
-            </a:pPr>
-            <a:r>
-              <a:rPr lang="en-US" sz="1800" dirty="0">
-                <a:solidFill>
-                  <a:srgbClr val="A5B4FC"/>
-                </a:solidFill>
-                <a:latin typeface="Calibri" pitchFamily="34" charset="0"/>
-                <a:ea typeface="Calibri" pitchFamily="34" charset="-122"/>
-                <a:cs typeface="Calibri" pitchFamily="34" charset="-120"/>
-              </a:rPr>
-              <a:t>Дибривный Павел (ИСТ04), Салазде Георгий (ИСТ03)</a:t>
-            </a:r>
-            <a:endParaRPr lang="en-US" sz="1800" dirty="0"/>
           </a:p>
         </p:txBody>
       </p:sp>
@@ -2877,6 +2877,45 @@
             <a:prstDash val="solid"/>
           </a:ln>
         </p:spPr>
+      </p:sp>
+      <p:sp>
+        <p:nvSpPr>
+          <p:cNvPr id="11" name="Text 9"/>
+          <p:cNvSpPr txBox="1"/>
+          <p:nvPr/>
+        </p:nvSpPr>
+        <p:spPr>
+          <a:xfrm>
+            <a:off x="731520" y="5669280"/>
+            <a:ext cx="10698480" cy="457200"/>
+          </a:xfrm>
+          <a:prstGeom prst="rect">
+            <a:avLst/>
+          </a:prstGeom>
+          <a:noFill/>
+          <a:ln/>
+        </p:spPr>
+        <p:txBody>
+          <a:bodyPr wrap="square" lIns="0" tIns="0" rIns="0" bIns="0" rtlCol="0" anchor="ctr"/>
+          <a:lstStyle/>
+          <a:p>
+            <a:pPr indent="0" marL="0">
+              <a:buNone/>
+            </a:pPr>
+            <a:r>
+              <a:rPr lang="en-US" sz="1800" dirty="0">
+                <a:solidFill>
+                  <a:srgbClr val="E0E7FF"/>
+                </a:solidFill>
+                <a:latin typeface="Calibri" pitchFamily="34" charset="0"/>
+                <a:ea typeface="Calibri" pitchFamily="34" charset="-122"/>
+                <a:cs typeface="Calibri" pitchFamily="34" charset="-120"/>
+              </a:rPr>
+              <a:t>Выполнили: Дибривный Павел (ИСТ04), Саладзе Георгий (ИСТ03)</a:t>
+            </a:r>
+            <a:endParaRPr lang="en-US" sz="1800" dirty="0"/>
+          </a:p>
+        </p:txBody>
       </p:sp>
     </p:spTree>
   </p:cSld>

</xml_diff>

<commit_message>
Add patronymics to the authors
Co-Authored-By: Claude Sonnet 5.5 <noreply@anthropic.com>
</commit_message>
<xml_diff>
--- a/docs/Презентация_Планировщик_экзаменов.pptx
+++ b/docs/Презентация_Планировщик_экзаменов.pptx
@@ -519,7 +519,7 @@
           <a:p>
             <a:r>
               <a:rPr lang="en-US" dirty="0"/>
-              <a:t>Здравствуйте! Мы, Павел Дибривный и Георгий Саладзе, из групп ИСТ04 и ИСТ03. Это наш итоговый проект по Python, планировщик подготовки к экзаменам. Программа сама раскладывает темы по дням, а если вы отстали, пересчитывает план.</a:t>
+              <a:t>Здравствуйте! Мы, Дибривный Павел Александрович и Саладзе Георгий Давидович, из групп ИСТ04 и ИСТ03. Это наш итоговый проект по Python, планировщик подготовки к экзаменам. Программа сама раскладывает темы по дням, а если вы отстали, пересчитывает план.</a:t>
             </a:r>
             <a:endParaRPr lang="en-US" dirty="0"/>
           </a:p>
@@ -2911,7 +2911,7 @@
                 <a:ea typeface="Calibri" pitchFamily="34" charset="-122"/>
                 <a:cs typeface="Calibri" pitchFamily="34" charset="-120"/>
               </a:rPr>
-              <a:t>Выполнили: Дибривный Павел (ИСТ04), Саладзе Георгий (ИСТ03)</a:t>
+              <a:t>Выполнили: Дибривный Павел Александрович (ИСТ04), Саладзе Георгий Давидович (ИСТ03)</a:t>
             </a:r>
             <a:endParaRPr lang="en-US" sz="1800" dirty="0"/>
           </a:p>

</xml_diff>